<commit_message>
docs(slides): align deck with the general-purpose boilerplate story; fix slide 12
</commit_message>
<xml_diff>
--- a/slides/founder-site-workshop.pptx
+++ b/slides/founder-site-workshop.pptx
@@ -4,9 +4,6 @@
   <p:sldMasterIdLst>
     <p:sldMasterId id="2147483648" r:id="rId1"/>
   </p:sldMasterIdLst>
-  <p:notesMasterIdLst>
-    <p:notesMasterId r:id="rId15"/>
-  </p:notesMasterIdLst>
   <p:sldIdLst>
     <p:sldId id="256" r:id="rId2"/>
     <p:sldId id="257" r:id="rId3"/>
@@ -17,11 +14,14 @@
     <p:sldId id="262" r:id="rId8"/>
     <p:sldId id="263" r:id="rId9"/>
     <p:sldId id="264" r:id="rId10"/>
-    <p:sldId id="266" r:id="rId11"/>
-    <p:sldId id="270" r:id="rId12"/>
-    <p:sldId id="271" r:id="rId13"/>
-    <p:sldId id="272" r:id="rId14"/>
+    <p:sldId id="265" r:id="rId11"/>
+    <p:sldId id="266" r:id="rId12"/>
+    <p:sldId id="267" r:id="rId13"/>
+    <p:sldId id="268" r:id="rId14"/>
   </p:sldIdLst>
+  <p:notesMasterIdLst>
+    <p:notesMasterId r:id="rId15"/>
+  </p:notesMasterIdLst>
   <p:sldSz cx="12192000" cy="6858000"/>
   <p:notesSz cx="6858000" cy="12192000"/>
   <p:defaultTextStyle>
@@ -116,11 +116,6 @@
       </a:defRPr>
     </a:lvl9pPr>
   </p:defaultTextStyle>
-  <p:extLst>
-    <p:ext uri="{EFAFB233-063F-42B5-8137-9DF3F51BA10A}">
-      <p15:sldGuideLst xmlns:p15="http://schemas.microsoft.com/office/powerpoint/2012/main"/>
-    </p:ext>
-  </p:extLst>
 </p:presentation>
 </file>
 
@@ -146,10 +141,234 @@
           <a:chExt cx="0" cy="0"/>
         </a:xfrm>
       </p:grpSpPr>
+      <p:sp>
+        <p:nvSpPr>
+          <p:cNvPr id="2" name="Header Placeholder 1"/>
+          <p:cNvSpPr>
+            <a:spLocks noGrp="1"/>
+          </p:cNvSpPr>
+          <p:nvPr>
+            <p:ph type="hdr" sz="quarter"/>
+          </p:nvPr>
+        </p:nvSpPr>
+        <p:spPr>
+          <a:xfrm>
+            <a:off x="0" y="0"/>
+            <a:ext cx="2971800" cy="458788"/>
+          </a:xfrm>
+          <a:prstGeom prst="rect">
+            <a:avLst/>
+          </a:prstGeom>
+        </p:spPr>
+        <p:txBody>
+          <a:bodyPr vert="horz" lIns="91440" tIns="45720" rIns="91440" bIns="45720" rtlCol="0"/>
+          <a:lstStyle>
+            <a:lvl1pPr algn="l">
+              <a:defRPr sz="1200"/>
+            </a:lvl1pPr>
+          </a:lstStyle>
+          <a:p>
+            <a:endParaRPr lang="en-US"/>
+          </a:p>
+        </p:txBody>
+      </p:sp>
+      <p:sp>
+        <p:nvSpPr>
+          <p:cNvPr id="3" name="Date Placeholder 2"/>
+          <p:cNvSpPr>
+            <a:spLocks noGrp="1"/>
+          </p:cNvSpPr>
+          <p:nvPr>
+            <p:ph type="dt" idx="1"/>
+          </p:nvPr>
+        </p:nvSpPr>
+        <p:spPr>
+          <a:xfrm>
+            <a:off x="3884613" y="0"/>
+            <a:ext cx="2971800" cy="458788"/>
+          </a:xfrm>
+          <a:prstGeom prst="rect">
+            <a:avLst/>
+          </a:prstGeom>
+        </p:spPr>
+        <p:txBody>
+          <a:bodyPr vert="horz" lIns="91440" tIns="45720" rIns="91440" bIns="45720" rtlCol="0"/>
+          <a:lstStyle>
+            <a:lvl1pPr algn="r">
+              <a:defRPr sz="1200"/>
+            </a:lvl1pPr>
+          </a:lstStyle>
+          <a:p>
+            <a:fld id="{5282F153-3F37-0F45-9E97-73ACFA13230C}" type="datetimeFigureOut">
+              <a:rPr lang="en-US"/>
+              <a:t>7/23/19</a:t>
+            </a:fld>
+            <a:endParaRPr lang="en-US"/>
+          </a:p>
+        </p:txBody>
+      </p:sp>
+      <p:sp>
+        <p:nvSpPr>
+          <p:cNvPr id="4" name="Slide Image Placeholder 3"/>
+          <p:cNvSpPr>
+            <a:spLocks noGrp="1" noRot="1" noChangeAspect="1"/>
+          </p:cNvSpPr>
+          <p:nvPr>
+            <p:ph type="sldImg" idx="2"/>
+          </p:nvPr>
+        </p:nvSpPr>
+        <p:spPr>
+          <a:xfrm>
+            <a:off x="685800" y="1143000"/>
+            <a:ext cx="5486400" cy="3086100"/>
+          </a:xfrm>
+          <a:prstGeom prst="rect">
+            <a:avLst/>
+          </a:prstGeom>
+          <a:noFill/>
+          <a:ln w="12700">
+            <a:solidFill>
+              <a:prstClr val="black"/>
+            </a:solidFill>
+          </a:ln>
+        </p:spPr>
+        <p:txBody>
+          <a:bodyPr vert="horz" lIns="91440" tIns="45720" rIns="91440" bIns="45720" rtlCol="0" anchor="ctr"/>
+          <a:lstStyle/>
+          <a:p>
+            <a:endParaRPr lang="en-US"/>
+          </a:p>
+        </p:txBody>
+      </p:sp>
+      <p:sp>
+        <p:nvSpPr>
+          <p:cNvPr id="5" name="Notes Placeholder 4"/>
+          <p:cNvSpPr>
+            <a:spLocks noGrp="1"/>
+          </p:cNvSpPr>
+          <p:nvPr>
+            <p:ph type="body" sz="quarter" idx="3"/>
+          </p:nvPr>
+        </p:nvSpPr>
+        <p:spPr>
+          <a:xfrm>
+            <a:off x="685800" y="4400550"/>
+            <a:ext cx="5486400" cy="3600450"/>
+          </a:xfrm>
+          <a:prstGeom prst="rect">
+            <a:avLst/>
+          </a:prstGeom>
+        </p:spPr>
+        <p:txBody>
+          <a:bodyPr vert="horz" lIns="91440" tIns="45720" rIns="91440" bIns="45720" rtlCol="0"/>
+          <a:lstStyle/>
+          <a:p>
+            <a:pPr lvl="0"/>
+            <a:r>
+              <a:rPr lang="en-US"/>
+              <a:t>Click to edit Master text styles</a:t>
+            </a:r>
+          </a:p>
+          <a:p>
+            <a:pPr lvl="1"/>
+            <a:r>
+              <a:rPr lang="en-US"/>
+              <a:t>Second level</a:t>
+            </a:r>
+          </a:p>
+          <a:p>
+            <a:pPr lvl="2"/>
+            <a:r>
+              <a:rPr lang="en-US"/>
+              <a:t>Third level</a:t>
+            </a:r>
+          </a:p>
+          <a:p>
+            <a:pPr lvl="3"/>
+            <a:r>
+              <a:rPr lang="en-US"/>
+              <a:t>Fourth level</a:t>
+            </a:r>
+          </a:p>
+          <a:p>
+            <a:pPr lvl="4"/>
+            <a:r>
+              <a:rPr lang="en-US"/>
+              <a:t>Fifth level</a:t>
+            </a:r>
+          </a:p>
+        </p:txBody>
+      </p:sp>
+      <p:sp>
+        <p:nvSpPr>
+          <p:cNvPr id="6" name="Footer Placeholder 5"/>
+          <p:cNvSpPr>
+            <a:spLocks noGrp="1"/>
+          </p:cNvSpPr>
+          <p:nvPr>
+            <p:ph type="ftr" sz="quarter" idx="4"/>
+          </p:nvPr>
+        </p:nvSpPr>
+        <p:spPr>
+          <a:xfrm>
+            <a:off x="0" y="8685213"/>
+            <a:ext cx="2971800" cy="458787"/>
+          </a:xfrm>
+          <a:prstGeom prst="rect">
+            <a:avLst/>
+          </a:prstGeom>
+        </p:spPr>
+        <p:txBody>
+          <a:bodyPr vert="horz" lIns="91440" tIns="45720" rIns="91440" bIns="45720" rtlCol="0" anchor="b"/>
+          <a:lstStyle>
+            <a:lvl1pPr algn="l">
+              <a:defRPr sz="1200"/>
+            </a:lvl1pPr>
+          </a:lstStyle>
+          <a:p>
+            <a:endParaRPr lang="en-US"/>
+          </a:p>
+        </p:txBody>
+      </p:sp>
+      <p:sp>
+        <p:nvSpPr>
+          <p:cNvPr id="7" name="Slide Number Placeholder 6"/>
+          <p:cNvSpPr>
+            <a:spLocks noGrp="1"/>
+          </p:cNvSpPr>
+          <p:nvPr>
+            <p:ph type="sldNum" sz="quarter" idx="5"/>
+          </p:nvPr>
+        </p:nvSpPr>
+        <p:spPr>
+          <a:xfrm>
+            <a:off x="3884613" y="8685213"/>
+            <a:ext cx="2971800" cy="458787"/>
+          </a:xfrm>
+          <a:prstGeom prst="rect">
+            <a:avLst/>
+          </a:prstGeom>
+        </p:spPr>
+        <p:txBody>
+          <a:bodyPr vert="horz" lIns="91440" tIns="45720" rIns="91440" bIns="45720" rtlCol="0" anchor="b"/>
+          <a:lstStyle>
+            <a:lvl1pPr algn="r">
+              <a:defRPr sz="1200"/>
+            </a:lvl1pPr>
+          </a:lstStyle>
+          <a:p>
+            <a:fld id="{CE5E9CC1-C706-0F49-92D6-E571CC5EEA8F}" type="slidenum">
+              <a:rPr lang="en-US"/>
+              <a:t>‹#›</a:t>
+            </a:fld>
+            <a:endParaRPr lang="en-US"/>
+          </a:p>
+        </p:txBody>
+      </p:sp>
     </p:spTree>
     <p:extLst>
       <p:ext uri="{BB962C8B-B14F-4D97-AF65-F5344CB8AC3E}">
-        <p14:creationId xmlns:p14="http://schemas.microsoft.com/office/powerpoint/2010/main" val="2518386442"/>
+        <p14:creationId xmlns:p14="http://schemas.microsoft.com/office/powerpoint/2010/main" val="1024086991"/>
       </p:ext>
     </p:extLst>
   </p:cSld>
@@ -293,6 +512,10 @@
           <a:bodyPr/>
           <a:lstStyle/>
           <a:p>
+            <a:r>
+              <a:rPr lang="en-US" dirty="0"/>
+              <a:t/>
+            </a:r>
             <a:endParaRPr lang="en-US" dirty="0"/>
           </a:p>
         </p:txBody>
@@ -377,6 +600,10 @@
           <a:bodyPr/>
           <a:lstStyle/>
           <a:p>
+            <a:r>
+              <a:rPr lang="en-US" dirty="0"/>
+              <a:t/>
+            </a:r>
             <a:endParaRPr lang="en-US" dirty="0"/>
           </a:p>
         </p:txBody>
@@ -461,6 +688,10 @@
           <a:bodyPr/>
           <a:lstStyle/>
           <a:p>
+            <a:r>
+              <a:rPr lang="en-US" dirty="0"/>
+              <a:t/>
+            </a:r>
             <a:endParaRPr lang="en-US" dirty="0"/>
           </a:p>
         </p:txBody>
@@ -545,6 +776,10 @@
           <a:bodyPr/>
           <a:lstStyle/>
           <a:p>
+            <a:r>
+              <a:rPr lang="en-US" dirty="0"/>
+              <a:t/>
+            </a:r>
             <a:endParaRPr lang="en-US" dirty="0"/>
           </a:p>
         </p:txBody>
@@ -629,6 +864,10 @@
           <a:bodyPr/>
           <a:lstStyle/>
           <a:p>
+            <a:r>
+              <a:rPr lang="en-US" dirty="0"/>
+              <a:t/>
+            </a:r>
             <a:endParaRPr lang="en-US" dirty="0"/>
           </a:p>
         </p:txBody>
@@ -713,6 +952,10 @@
           <a:bodyPr/>
           <a:lstStyle/>
           <a:p>
+            <a:r>
+              <a:rPr lang="en-US" dirty="0"/>
+              <a:t/>
+            </a:r>
             <a:endParaRPr lang="en-US" dirty="0"/>
           </a:p>
         </p:txBody>
@@ -797,6 +1040,10 @@
           <a:bodyPr/>
           <a:lstStyle/>
           <a:p>
+            <a:r>
+              <a:rPr lang="en-US" dirty="0"/>
+              <a:t/>
+            </a:r>
             <a:endParaRPr lang="en-US" dirty="0"/>
           </a:p>
         </p:txBody>
@@ -881,6 +1128,10 @@
           <a:bodyPr/>
           <a:lstStyle/>
           <a:p>
+            <a:r>
+              <a:rPr lang="en-US" dirty="0"/>
+              <a:t/>
+            </a:r>
             <a:endParaRPr lang="en-US" dirty="0"/>
           </a:p>
         </p:txBody>
@@ -965,6 +1216,10 @@
           <a:bodyPr/>
           <a:lstStyle/>
           <a:p>
+            <a:r>
+              <a:rPr lang="en-US" dirty="0"/>
+              <a:t/>
+            </a:r>
             <a:endParaRPr lang="en-US" dirty="0"/>
           </a:p>
         </p:txBody>
@@ -1049,6 +1304,10 @@
           <a:bodyPr/>
           <a:lstStyle/>
           <a:p>
+            <a:r>
+              <a:rPr lang="en-US" dirty="0"/>
+              <a:t/>
+            </a:r>
             <a:endParaRPr lang="en-US" dirty="0"/>
           </a:p>
         </p:txBody>
@@ -1133,6 +1392,10 @@
           <a:bodyPr/>
           <a:lstStyle/>
           <a:p>
+            <a:r>
+              <a:rPr lang="en-US" dirty="0"/>
+              <a:t/>
+            </a:r>
             <a:endParaRPr lang="en-US" dirty="0"/>
           </a:p>
         </p:txBody>
@@ -1217,6 +1480,10 @@
           <a:bodyPr/>
           <a:lstStyle/>
           <a:p>
+            <a:r>
+              <a:rPr lang="en-US" dirty="0"/>
+              <a:t/>
+            </a:r>
             <a:endParaRPr lang="en-US" dirty="0"/>
           </a:p>
         </p:txBody>
@@ -1301,6 +1568,10 @@
           <a:bodyPr/>
           <a:lstStyle/>
           <a:p>
+            <a:r>
+              <a:rPr lang="en-US" dirty="0"/>
+              <a:t/>
+            </a:r>
             <a:endParaRPr lang="en-US" dirty="0"/>
           </a:p>
         </p:txBody>
@@ -1374,11 +1645,6 @@
 <file path=ppt/slideMasters/slideMaster1.xml><?xml version="1.0" encoding="utf-8"?>
 <p:sldMaster xmlns:a="http://schemas.openxmlformats.org/drawingml/2006/main" xmlns:r="http://schemas.openxmlformats.org/officeDocument/2006/relationships" xmlns:p="http://schemas.openxmlformats.org/presentationml/2006/main">
   <p:cSld>
-    <p:bg>
-      <p:bgRef idx="1001">
-        <a:schemeClr val="bg1"/>
-      </p:bgRef>
-    </p:bg>
     <p:spTree>
       <p:nvGrpSpPr>
         <p:cNvPr id="1" name=""/>
@@ -1661,7 +1927,6 @@
         <a:solidFill>
           <a:srgbClr val="17151F"/>
         </a:solidFill>
-        <a:effectLst/>
       </p:bgPr>
     </p:bg>
     <p:spTree>
@@ -1699,7 +1964,7 @@
           <a:bodyPr wrap="square" lIns="0" tIns="0" rIns="0" bIns="0" rtlCol="0" anchor="ctr"/>
           <a:lstStyle/>
           <a:p>
-            <a:pPr marL="0" indent="0">
+            <a:pPr indent="0" marL="0">
               <a:buNone/>
             </a:pPr>
             <a:r>
@@ -1738,11 +2003,11 @@
           <a:bodyPr wrap="square" lIns="0" tIns="0" rIns="0" bIns="0" rtlCol="0" anchor="ctr"/>
           <a:lstStyle/>
           <a:p>
-            <a:pPr marL="0" indent="0">
-              <a:buNone/>
-            </a:pPr>
-            <a:r>
-              <a:rPr lang="en-US" sz="1200" kern="0" spc="200" dirty="0">
+            <a:pPr indent="0" marL="0">
+              <a:buNone/>
+            </a:pPr>
+            <a:r>
+              <a:rPr lang="en-US" sz="1200" spc="200" kern="0" dirty="0">
                 <a:solidFill>
                   <a:srgbClr val="C3BCE0"/>
                 </a:solidFill>
@@ -1777,7 +2042,7 @@
           <a:bodyPr wrap="square" lIns="0" tIns="0" rIns="0" bIns="0" rtlCol="0" anchor="ctr"/>
           <a:lstStyle/>
           <a:p>
-            <a:pPr marL="0" indent="0">
+            <a:pPr indent="0" marL="0">
               <a:lnSpc>
                 <a:spcPct val="98000"/>
               </a:lnSpc>
@@ -1797,7 +2062,7 @@
             <a:endParaRPr lang="en-US" sz="5800" dirty="0"/>
           </a:p>
           <a:p>
-            <a:pPr marL="0" indent="0">
+            <a:pPr indent="0" marL="0">
               <a:lnSpc>
                 <a:spcPct val="98000"/>
               </a:lnSpc>
@@ -1827,19 +2092,19 @@
         <p:spPr>
           <a:xfrm>
             <a:off x="548640" y="4297680"/>
-            <a:ext cx="9601200" cy="548640"/>
-          </a:xfrm>
-          <a:prstGeom prst="rect">
-            <a:avLst/>
-          </a:prstGeom>
-          <a:noFill/>
-          <a:ln/>
-        </p:spPr>
-        <p:txBody>
-          <a:bodyPr wrap="square" lIns="0" tIns="0" rIns="0" bIns="0" rtlCol="0" anchor="ctr"/>
-          <a:lstStyle/>
-          <a:p>
-            <a:pPr marL="0" indent="0">
+            <a:ext cx="10789920" cy="548640"/>
+          </a:xfrm>
+          <a:prstGeom prst="rect">
+            <a:avLst/>
+          </a:prstGeom>
+          <a:noFill/>
+          <a:ln/>
+        </p:spPr>
+        <p:txBody>
+          <a:bodyPr wrap="square" lIns="0" tIns="0" rIns="0" bIns="0" rtlCol="0" anchor="ctr"/>
+          <a:lstStyle/>
+          <a:p>
+            <a:pPr indent="0" marL="0">
               <a:buNone/>
             </a:pPr>
             <a:r>
@@ -1851,7 +2116,7 @@
                 <a:ea typeface="Calibri" pitchFamily="34" charset="-122"/>
                 <a:cs typeface="Calibri" pitchFamily="34" charset="-120"/>
               </a:rPr>
-              <a:t>From one idea to a live personal site — with a private CRM — in an hour.</a:t>
+              <a:t>From a one-line idea to finished work — a team of agents on a single source of truth.</a:t>
             </a:r>
             <a:endParaRPr lang="en-US" sz="2000" dirty="0"/>
           </a:p>
@@ -1883,13 +2148,6 @@
             <a:prstDash val="solid"/>
           </a:ln>
         </p:spPr>
-        <p:txBody>
-          <a:bodyPr/>
-          <a:lstStyle/>
-          <a:p>
-            <a:endParaRPr lang="en-US"/>
-          </a:p>
-        </p:txBody>
       </p:sp>
       <p:sp>
         <p:nvSpPr>
@@ -1917,13 +2175,6 @@
             <a:prstDash val="solid"/>
           </a:ln>
         </p:spPr>
-        <p:txBody>
-          <a:bodyPr/>
-          <a:lstStyle/>
-          <a:p>
-            <a:endParaRPr lang="en-US"/>
-          </a:p>
-        </p:txBody>
       </p:sp>
       <p:sp>
         <p:nvSpPr>
@@ -1951,13 +2202,6 @@
             <a:prstDash val="solid"/>
           </a:ln>
         </p:spPr>
-        <p:txBody>
-          <a:bodyPr/>
-          <a:lstStyle/>
-          <a:p>
-            <a:endParaRPr lang="en-US"/>
-          </a:p>
-        </p:txBody>
       </p:sp>
       <p:sp>
         <p:nvSpPr>
@@ -1985,13 +2229,6 @@
             <a:prstDash val="solid"/>
           </a:ln>
         </p:spPr>
-        <p:txBody>
-          <a:bodyPr/>
-          <a:lstStyle/>
-          <a:p>
-            <a:endParaRPr lang="en-US"/>
-          </a:p>
-        </p:txBody>
       </p:sp>
       <p:sp>
         <p:nvSpPr>
@@ -2014,7 +2251,7 @@
           <a:bodyPr wrap="square" lIns="0" tIns="0" rIns="0" bIns="0" rtlCol="0" anchor="ctr"/>
           <a:lstStyle/>
           <a:p>
-            <a:pPr marL="0" indent="0">
+            <a:pPr indent="0" marL="0">
               <a:buNone/>
             </a:pPr>
             <a:r>
@@ -2053,7 +2290,7 @@
           <a:bodyPr wrap="square" lIns="0" tIns="0" rIns="0" bIns="0" rtlCol="0" anchor="ctr"/>
           <a:lstStyle/>
           <a:p>
-            <a:pPr marL="0" indent="0">
+            <a:pPr indent="0" marL="0">
               <a:buNone/>
             </a:pPr>
             <a:r>
@@ -2081,13 +2318,12 @@
 
 <file path=ppt/slides/slide10.xml><?xml version="1.0" encoding="utf-8"?>
 <p:sld xmlns:a="http://schemas.openxmlformats.org/drawingml/2006/main" xmlns:r="http://schemas.openxmlformats.org/officeDocument/2006/relationships" xmlns:p="http://schemas.openxmlformats.org/presentationml/2006/main">
-  <p:cSld name="Slide 11">
+  <p:cSld name="Slide 10">
     <p:bg>
       <p:bgPr>
         <a:solidFill>
           <a:srgbClr val="17151F"/>
         </a:solidFill>
-        <a:effectLst/>
       </p:bgPr>
     </p:bg>
     <p:spTree>
@@ -2125,11 +2361,11 @@
           <a:bodyPr wrap="square" lIns="0" tIns="0" rIns="0" bIns="0" rtlCol="0" anchor="ctr"/>
           <a:lstStyle/>
           <a:p>
-            <a:pPr marL="0" indent="0">
-              <a:buNone/>
-            </a:pPr>
-            <a:r>
-              <a:rPr lang="en-US" sz="1200" b="1" kern="0" spc="200" dirty="0">
+            <a:pPr indent="0" marL="0">
+              <a:buNone/>
+            </a:pPr>
+            <a:r>
+              <a:rPr lang="en-US" sz="1200" b="1" spc="200" kern="0" dirty="0">
                 <a:solidFill>
                   <a:srgbClr val="5B3DF5"/>
                 </a:solidFill>
@@ -2164,7 +2400,7 @@
           <a:bodyPr wrap="square" lIns="0" tIns="0" rIns="0" bIns="0" rtlCol="0" anchor="ctr"/>
           <a:lstStyle/>
           <a:p>
-            <a:pPr marL="0" indent="0">
+            <a:pPr indent="0" marL="0">
               <a:buNone/>
             </a:pPr>
             <a:r>
@@ -2204,13 +2440,6 @@
             <a:prstDash val="solid"/>
           </a:ln>
         </p:spPr>
-        <p:txBody>
-          <a:bodyPr/>
-          <a:lstStyle/>
-          <a:p>
-            <a:endParaRPr lang="en-US"/>
-          </a:p>
-        </p:txBody>
       </p:sp>
       <p:sp>
         <p:nvSpPr>
@@ -2236,13 +2465,6 @@
             <a:prstDash val="solid"/>
           </a:ln>
         </p:spPr>
-        <p:txBody>
-          <a:bodyPr/>
-          <a:lstStyle/>
-          <a:p>
-            <a:endParaRPr lang="en-US"/>
-          </a:p>
-        </p:txBody>
       </p:sp>
       <p:sp>
         <p:nvSpPr>
@@ -2265,7 +2487,7 @@
           <a:bodyPr wrap="square" lIns="0" tIns="0" rIns="0" bIns="0" rtlCol="0" anchor="ctr"/>
           <a:lstStyle/>
           <a:p>
-            <a:pPr marL="0" indent="0" algn="ctr">
+            <a:pPr algn="ctr" indent="0" marL="0">
               <a:buNone/>
             </a:pPr>
             <a:r>
@@ -2304,7 +2526,7 @@
           <a:bodyPr wrap="square" lIns="0" tIns="0" rIns="0" bIns="0" rtlCol="0" anchor="ctr"/>
           <a:lstStyle/>
           <a:p>
-            <a:pPr marL="0" indent="0" algn="ctr">
+            <a:pPr algn="ctr" indent="0" marL="0">
               <a:buNone/>
             </a:pPr>
             <a:r>
@@ -2343,7 +2565,7 @@
           <a:bodyPr wrap="square" lIns="0" tIns="0" rIns="0" bIns="0" rtlCol="0" anchor="ctr"/>
           <a:lstStyle/>
           <a:p>
-            <a:pPr marL="0" indent="0" algn="ctr">
+            <a:pPr algn="ctr" indent="0" marL="0">
               <a:buNone/>
             </a:pPr>
             <a:r>
@@ -2385,13 +2607,6 @@
             <a:prstDash val="solid"/>
           </a:ln>
         </p:spPr>
-        <p:txBody>
-          <a:bodyPr/>
-          <a:lstStyle/>
-          <a:p>
-            <a:endParaRPr lang="en-US"/>
-          </a:p>
-        </p:txBody>
       </p:sp>
       <p:sp>
         <p:nvSpPr>
@@ -2414,7 +2629,7 @@
           <a:bodyPr wrap="square" lIns="0" tIns="0" rIns="0" bIns="0" rtlCol="0" anchor="ctr"/>
           <a:lstStyle/>
           <a:p>
-            <a:pPr marL="0" indent="0" algn="ctr">
+            <a:pPr algn="ctr" indent="0" marL="0">
               <a:buNone/>
             </a:pPr>
             <a:r>
@@ -2453,7 +2668,7 @@
           <a:bodyPr wrap="square" lIns="0" tIns="0" rIns="0" bIns="0" rtlCol="0" anchor="ctr"/>
           <a:lstStyle/>
           <a:p>
-            <a:pPr marL="0" indent="0" algn="ctr">
+            <a:pPr algn="ctr" indent="0" marL="0">
               <a:buNone/>
             </a:pPr>
             <a:r>
@@ -2492,7 +2707,7 @@
           <a:bodyPr wrap="square" lIns="0" tIns="0" rIns="0" bIns="0" rtlCol="0" anchor="ctr"/>
           <a:lstStyle/>
           <a:p>
-            <a:pPr marL="0" indent="0" algn="ctr">
+            <a:pPr algn="ctr" indent="0" marL="0">
               <a:buNone/>
             </a:pPr>
             <a:r>
@@ -2534,13 +2749,6 @@
             <a:prstDash val="solid"/>
           </a:ln>
         </p:spPr>
-        <p:txBody>
-          <a:bodyPr/>
-          <a:lstStyle/>
-          <a:p>
-            <a:endParaRPr lang="en-US"/>
-          </a:p>
-        </p:txBody>
       </p:sp>
       <p:sp>
         <p:nvSpPr>
@@ -2563,7 +2771,7 @@
           <a:bodyPr wrap="square" lIns="0" tIns="0" rIns="0" bIns="0" rtlCol="0" anchor="ctr"/>
           <a:lstStyle/>
           <a:p>
-            <a:pPr marL="0" indent="0" algn="ctr">
+            <a:pPr algn="ctr" indent="0" marL="0">
               <a:buNone/>
             </a:pPr>
             <a:r>
@@ -2602,7 +2810,7 @@
           <a:bodyPr wrap="square" lIns="0" tIns="0" rIns="0" bIns="0" rtlCol="0" anchor="ctr"/>
           <a:lstStyle/>
           <a:p>
-            <a:pPr marL="0" indent="0" algn="ctr">
+            <a:pPr algn="ctr" indent="0" marL="0">
               <a:buNone/>
             </a:pPr>
             <a:r>
@@ -2641,7 +2849,7 @@
           <a:bodyPr wrap="square" lIns="0" tIns="0" rIns="0" bIns="0" rtlCol="0" anchor="ctr"/>
           <a:lstStyle/>
           <a:p>
-            <a:pPr marL="0" indent="0" algn="ctr">
+            <a:pPr algn="ctr" indent="0" marL="0">
               <a:buNone/>
             </a:pPr>
             <a:r>
@@ -2683,13 +2891,6 @@
             <a:prstDash val="solid"/>
           </a:ln>
         </p:spPr>
-        <p:txBody>
-          <a:bodyPr/>
-          <a:lstStyle/>
-          <a:p>
-            <a:endParaRPr lang="en-US"/>
-          </a:p>
-        </p:txBody>
       </p:sp>
       <p:sp>
         <p:nvSpPr>
@@ -2712,7 +2913,7 @@
           <a:bodyPr wrap="square" lIns="0" tIns="0" rIns="0" bIns="0" rtlCol="0" anchor="ctr"/>
           <a:lstStyle/>
           <a:p>
-            <a:pPr marL="0" indent="0" algn="ctr">
+            <a:pPr algn="ctr" indent="0" marL="0">
               <a:buNone/>
             </a:pPr>
             <a:r>
@@ -2751,7 +2952,7 @@
           <a:bodyPr wrap="square" lIns="0" tIns="0" rIns="0" bIns="0" rtlCol="0" anchor="ctr"/>
           <a:lstStyle/>
           <a:p>
-            <a:pPr marL="0" indent="0" algn="ctr">
+            <a:pPr algn="ctr" indent="0" marL="0">
               <a:buNone/>
             </a:pPr>
             <a:r>
@@ -2790,7 +2991,7 @@
           <a:bodyPr wrap="square" lIns="0" tIns="0" rIns="0" bIns="0" rtlCol="0" anchor="ctr"/>
           <a:lstStyle/>
           <a:p>
-            <a:pPr marL="0" indent="0" algn="ctr">
+            <a:pPr algn="ctr" indent="0" marL="0">
               <a:buNone/>
             </a:pPr>
             <a:r>
@@ -2832,13 +3033,6 @@
             <a:prstDash val="solid"/>
           </a:ln>
         </p:spPr>
-        <p:txBody>
-          <a:bodyPr/>
-          <a:lstStyle/>
-          <a:p>
-            <a:endParaRPr lang="en-US"/>
-          </a:p>
-        </p:txBody>
       </p:sp>
       <p:sp>
         <p:nvSpPr>
@@ -2861,7 +3055,7 @@
           <a:bodyPr wrap="square" lIns="0" tIns="0" rIns="0" bIns="0" rtlCol="0" anchor="ctr"/>
           <a:lstStyle/>
           <a:p>
-            <a:pPr marL="0" indent="0" algn="ctr">
+            <a:pPr algn="ctr" indent="0" marL="0">
               <a:buNone/>
             </a:pPr>
             <a:r>
@@ -2900,7 +3094,7 @@
           <a:bodyPr wrap="square" lIns="0" tIns="0" rIns="0" bIns="0" rtlCol="0" anchor="ctr"/>
           <a:lstStyle/>
           <a:p>
-            <a:pPr marL="0" indent="0" algn="ctr">
+            <a:pPr algn="ctr" indent="0" marL="0">
               <a:buNone/>
             </a:pPr>
             <a:r>
@@ -2939,7 +3133,7 @@
           <a:bodyPr wrap="square" lIns="0" tIns="0" rIns="0" bIns="0" rtlCol="0" anchor="ctr"/>
           <a:lstStyle/>
           <a:p>
-            <a:pPr marL="0" indent="0" algn="ctr">
+            <a:pPr algn="ctr" indent="0" marL="0">
               <a:buNone/>
             </a:pPr>
             <a:r>
@@ -2981,13 +3175,6 @@
             <a:prstDash val="solid"/>
           </a:ln>
         </p:spPr>
-        <p:txBody>
-          <a:bodyPr/>
-          <a:lstStyle/>
-          <a:p>
-            <a:endParaRPr lang="en-US"/>
-          </a:p>
-        </p:txBody>
       </p:sp>
       <p:sp>
         <p:nvSpPr>
@@ -3010,7 +3197,7 @@
           <a:bodyPr wrap="square" lIns="0" tIns="0" rIns="0" bIns="0" rtlCol="0" anchor="ctr"/>
           <a:lstStyle/>
           <a:p>
-            <a:pPr marL="0" indent="0" algn="ctr">
+            <a:pPr algn="ctr" indent="0" marL="0">
               <a:buNone/>
             </a:pPr>
             <a:r>
@@ -3049,7 +3236,7 @@
           <a:bodyPr wrap="square" lIns="0" tIns="0" rIns="0" bIns="0" rtlCol="0" anchor="ctr"/>
           <a:lstStyle/>
           <a:p>
-            <a:pPr marL="0" indent="0" algn="ctr">
+            <a:pPr algn="ctr" indent="0" marL="0">
               <a:buNone/>
             </a:pPr>
             <a:r>
@@ -3088,7 +3275,7 @@
           <a:bodyPr wrap="square" lIns="0" tIns="0" rIns="0" bIns="0" rtlCol="0" anchor="ctr"/>
           <a:lstStyle/>
           <a:p>
-            <a:pPr marL="0" indent="0" algn="ctr">
+            <a:pPr algn="ctr" indent="0" marL="0">
               <a:buNone/>
             </a:pPr>
             <a:r>
@@ -3127,7 +3314,7 @@
           <a:bodyPr wrap="square" lIns="0" tIns="0" rIns="0" bIns="0" rtlCol="0" anchor="ctr"/>
           <a:lstStyle/>
           <a:p>
-            <a:pPr marL="0" indent="0" algn="ctr">
+            <a:pPr algn="ctr" indent="0" marL="0">
               <a:buNone/>
             </a:pPr>
             <a:r>
@@ -3155,13 +3342,12 @@
 
 <file path=ppt/slides/slide11.xml><?xml version="1.0" encoding="utf-8"?>
 <p:sld xmlns:a="http://schemas.openxmlformats.org/drawingml/2006/main" xmlns:r="http://schemas.openxmlformats.org/officeDocument/2006/relationships" xmlns:p="http://schemas.openxmlformats.org/presentationml/2006/main">
-  <p:cSld name="Slide 15">
+  <p:cSld name="Slide 11">
     <p:bg>
       <p:bgPr>
         <a:solidFill>
           <a:srgbClr val="17151F"/>
         </a:solidFill>
-        <a:effectLst/>
       </p:bgPr>
     </p:bg>
     <p:spTree>
@@ -3199,11 +3385,11 @@
           <a:bodyPr wrap="square" lIns="0" tIns="0" rIns="0" bIns="0" rtlCol="0" anchor="ctr"/>
           <a:lstStyle/>
           <a:p>
-            <a:pPr marL="0" indent="0">
-              <a:buNone/>
-            </a:pPr>
-            <a:r>
-              <a:rPr lang="en-US" sz="1200" b="1" kern="0" spc="200" dirty="0">
+            <a:pPr indent="0" marL="0">
+              <a:buNone/>
+            </a:pPr>
+            <a:r>
+              <a:rPr lang="en-US" sz="1200" b="1" spc="200" kern="0" dirty="0">
                 <a:solidFill>
                   <a:srgbClr val="5B3DF5"/>
                 </a:solidFill>
@@ -3238,7 +3424,7 @@
           <a:bodyPr wrap="square" lIns="0" tIns="0" rIns="0" bIns="0" rtlCol="0" anchor="ctr"/>
           <a:lstStyle/>
           <a:p>
-            <a:pPr marL="0" indent="0">
+            <a:pPr indent="0" marL="0">
               <a:buNone/>
             </a:pPr>
             <a:r>
@@ -3277,7 +3463,7 @@
           <a:bodyPr wrap="square" lIns="0" tIns="0" rIns="0" bIns="0" rtlCol="0" anchor="ctr"/>
           <a:lstStyle/>
           <a:p>
-            <a:pPr marL="0" indent="0">
+            <a:pPr indent="0" marL="0">
               <a:buNone/>
             </a:pPr>
             <a:r>
@@ -3316,7 +3502,7 @@
           <a:bodyPr wrap="square" lIns="0" tIns="0" rIns="0" bIns="0" rtlCol="0" anchor="ctr"/>
           <a:lstStyle/>
           <a:p>
-            <a:pPr marL="0" indent="0">
+            <a:pPr indent="0" marL="0">
               <a:buNone/>
             </a:pPr>
             <a:r>
@@ -3355,7 +3541,7 @@
           <a:bodyPr wrap="square" lIns="0" tIns="0" rIns="0" bIns="0" rtlCol="0" anchor="ctr"/>
           <a:lstStyle/>
           <a:p>
-            <a:pPr marL="0" indent="0">
+            <a:pPr indent="0" marL="0">
               <a:buNone/>
             </a:pPr>
             <a:r>
@@ -3394,7 +3580,7 @@
           <a:bodyPr wrap="square" lIns="0" tIns="0" rIns="0" bIns="0" rtlCol="0" anchor="ctr"/>
           <a:lstStyle/>
           <a:p>
-            <a:pPr marL="0" indent="0">
+            <a:pPr indent="0" marL="0">
               <a:buNone/>
             </a:pPr>
             <a:r>
@@ -3433,7 +3619,7 @@
           <a:bodyPr wrap="square" lIns="0" tIns="0" rIns="0" bIns="0" rtlCol="0" anchor="ctr"/>
           <a:lstStyle/>
           <a:p>
-            <a:pPr marL="0" indent="0">
+            <a:pPr indent="0" marL="0">
               <a:buNone/>
             </a:pPr>
             <a:r>
@@ -3472,7 +3658,7 @@
           <a:bodyPr wrap="square" lIns="0" tIns="0" rIns="0" bIns="0" rtlCol="0" anchor="ctr"/>
           <a:lstStyle/>
           <a:p>
-            <a:pPr marL="0" indent="0">
+            <a:pPr indent="0" marL="0">
               <a:buNone/>
             </a:pPr>
             <a:r>
@@ -3511,7 +3697,7 @@
           <a:bodyPr wrap="square" lIns="0" tIns="0" rIns="0" bIns="0" rtlCol="0" anchor="ctr"/>
           <a:lstStyle/>
           <a:p>
-            <a:pPr marL="0" indent="0">
+            <a:pPr indent="0" marL="0">
               <a:buNone/>
             </a:pPr>
             <a:r>
@@ -3550,7 +3736,7 @@
           <a:bodyPr wrap="square" lIns="0" tIns="0" rIns="0" bIns="0" rtlCol="0" anchor="ctr"/>
           <a:lstStyle/>
           <a:p>
-            <a:pPr marL="0" indent="0">
+            <a:pPr indent="0" marL="0">
               <a:buNone/>
             </a:pPr>
             <a:r>
@@ -3589,7 +3775,7 @@
           <a:bodyPr wrap="square" lIns="0" tIns="0" rIns="0" bIns="0" rtlCol="0" anchor="ctr"/>
           <a:lstStyle/>
           <a:p>
-            <a:pPr marL="0" indent="0">
+            <a:pPr indent="0" marL="0">
               <a:buNone/>
             </a:pPr>
             <a:r>
@@ -3628,7 +3814,7 @@
           <a:bodyPr wrap="square" lIns="0" tIns="0" rIns="0" bIns="0" rtlCol="0" anchor="ctr"/>
           <a:lstStyle/>
           <a:p>
-            <a:pPr marL="0" indent="0">
+            <a:pPr indent="0" marL="0">
               <a:buNone/>
             </a:pPr>
             <a:r>
@@ -3667,7 +3853,7 @@
           <a:bodyPr wrap="square" lIns="0" tIns="0" rIns="0" bIns="0" rtlCol="0" anchor="ctr"/>
           <a:lstStyle/>
           <a:p>
-            <a:pPr marL="0" indent="0">
+            <a:pPr indent="0" marL="0">
               <a:buNone/>
             </a:pPr>
             <a:r>
@@ -3695,13 +3881,12 @@
 
 <file path=ppt/slides/slide12.xml><?xml version="1.0" encoding="utf-8"?>
 <p:sld xmlns:a="http://schemas.openxmlformats.org/drawingml/2006/main" xmlns:r="http://schemas.openxmlformats.org/officeDocument/2006/relationships" xmlns:p="http://schemas.openxmlformats.org/presentationml/2006/main">
-  <p:cSld name="Slide 16">
+  <p:cSld name="Slide 12">
     <p:bg>
       <p:bgPr>
         <a:solidFill>
           <a:srgbClr val="FFFFFF"/>
         </a:solidFill>
-        <a:effectLst/>
       </p:bgPr>
     </p:bg>
     <p:spTree>
@@ -3739,11 +3924,11 @@
           <a:bodyPr wrap="square" lIns="0" tIns="0" rIns="0" bIns="0" rtlCol="0" anchor="ctr"/>
           <a:lstStyle/>
           <a:p>
-            <a:pPr marL="0" indent="0">
-              <a:buNone/>
-            </a:pPr>
-            <a:r>
-              <a:rPr lang="en-US" sz="1200" b="1" kern="0" spc="200" dirty="0">
+            <a:pPr indent="0" marL="0">
+              <a:buNone/>
+            </a:pPr>
+            <a:r>
+              <a:rPr lang="en-US" sz="1200" b="1" spc="200" kern="0" dirty="0">
                 <a:solidFill>
                   <a:srgbClr val="5B3DF5"/>
                 </a:solidFill>
@@ -3751,7 +3936,7 @@
                 <a:ea typeface="Consolas" pitchFamily="34" charset="-122"/>
                 <a:cs typeface="Consolas" pitchFamily="34" charset="-120"/>
               </a:rPr>
-              <a:t>13 — TAKE IT HOME</a:t>
+              <a:t>09 — TAKE IT HOME</a:t>
             </a:r>
             <a:endParaRPr lang="en-US" sz="1200" dirty="0"/>
           </a:p>
@@ -3778,7 +3963,7 @@
           <a:bodyPr wrap="square" lIns="0" tIns="0" rIns="0" bIns="0" rtlCol="0" anchor="t"/>
           <a:lstStyle/>
           <a:p>
-            <a:pPr marL="0" indent="0">
+            <a:pPr indent="0" marL="0">
               <a:buNone/>
             </a:pPr>
             <a:r>
@@ -3790,7 +3975,7 @@
                 <a:ea typeface="Georgia" pitchFamily="34" charset="-122"/>
                 <a:cs typeface="Georgia" pitchFamily="34" charset="-120"/>
               </a:rPr>
-              <a:t>Clone it. Point it at yourself.</a:t>
+              <a:t>Clone it. Point it at any project.</a:t>
             </a:r>
             <a:endParaRPr lang="en-US" sz="3400" dirty="0"/>
           </a:p>
@@ -3798,14 +3983,14 @@
       </p:sp>
       <p:pic>
         <p:nvPicPr>
-          <p:cNvPr id="4" name="Image 0" descr="preencoded.png"/>
+          <p:cNvPr id="4" name="Image 0" descr="preencoded.png">    </p:cNvPr>
           <p:cNvPicPr>
             <a:picLocks noChangeAspect="1"/>
           </p:cNvPicPr>
           <p:nvPr/>
         </p:nvPicPr>
         <p:blipFill>
-          <a:blip r:embed="rId3"/>
+          <a:blip r:embed="rId1"/>
           <a:stretch>
             <a:fillRect/>
           </a:stretch>
@@ -3846,13 +4031,6 @@
             <a:prstDash val="solid"/>
           </a:ln>
         </p:spPr>
-        <p:txBody>
-          <a:bodyPr/>
-          <a:lstStyle/>
-          <a:p>
-            <a:endParaRPr lang="en-US"/>
-          </a:p>
-        </p:txBody>
       </p:sp>
       <p:sp>
         <p:nvSpPr>
@@ -3875,7 +4053,7 @@
           <a:bodyPr wrap="square" lIns="0" tIns="0" rIns="0" bIns="0" rtlCol="0" anchor="ctr"/>
           <a:lstStyle/>
           <a:p>
-            <a:pPr marL="0" indent="0">
+            <a:pPr indent="0" marL="0">
               <a:buNone/>
             </a:pPr>
             <a:r>
@@ -3902,19 +4080,19 @@
         <p:spPr>
           <a:xfrm>
             <a:off x="3383280" y="3383280"/>
-            <a:ext cx="8229600" cy="914400"/>
-          </a:xfrm>
-          <a:prstGeom prst="rect">
-            <a:avLst/>
-          </a:prstGeom>
-          <a:noFill/>
-          <a:ln/>
-        </p:spPr>
-        <p:txBody>
-          <a:bodyPr wrap="square" lIns="0" tIns="0" rIns="0" bIns="0" rtlCol="0" anchor="ctr"/>
-          <a:lstStyle/>
-          <a:p>
-            <a:pPr marL="0" indent="0">
+            <a:ext cx="8229600" cy="1188720"/>
+          </a:xfrm>
+          <a:prstGeom prst="rect">
+            <a:avLst/>
+          </a:prstGeom>
+          <a:noFill/>
+          <a:ln/>
+        </p:spPr>
+        <p:txBody>
+          <a:bodyPr wrap="square" lIns="0" tIns="0" rIns="0" bIns="0" rtlCol="0" anchor="ctr"/>
+          <a:lstStyle/>
+          <a:p>
+            <a:pPr indent="0" marL="0">
               <a:lnSpc>
                 <a:spcPct val="115000"/>
               </a:lnSpc>
@@ -3931,6 +4109,12 @@
               </a:rPr>
               <a:t>Inside: </a:t>
             </a:r>
+            <a:pPr indent="0" marL="0">
+              <a:lnSpc>
+                <a:spcPct val="115000"/>
+              </a:lnSpc>
+              <a:buNone/>
+            </a:pPr>
             <a:r>
               <a:rPr lang="en-US" sz="1600" dirty="0">
                 <a:solidFill>
@@ -3940,7 +4124,7 @@
                 <a:ea typeface="Calibri" pitchFamily="34" charset="-122"/>
                 <a:cs typeface="Calibri" pitchFamily="34" charset="-120"/>
               </a:rPr>
-              <a:t>the ledger, the run-sheet, the command cheat-sheet, the deploy steps, and the whole Next.js + database app — ready to fork.</a:t>
+              <a:t>the /orchestrate skill chain, the TODO.md ledger, and a docs + core-context scaffold — a reusable boilerplate you point at any project, code or not.</a:t>
             </a:r>
             <a:endParaRPr lang="en-US" sz="1600" dirty="0"/>
           </a:p>
@@ -3967,7 +4151,7 @@
           <a:bodyPr wrap="square" lIns="0" tIns="0" rIns="0" bIns="0" rtlCol="0" anchor="ctr"/>
           <a:lstStyle/>
           <a:p>
-            <a:pPr marL="0" indent="0" algn="ctr">
+            <a:pPr algn="ctr" indent="0" marL="0">
               <a:buNone/>
             </a:pPr>
             <a:r>
@@ -3981,6 +4165,9 @@
               </a:rPr>
               <a:t>No terminal? </a:t>
             </a:r>
+            <a:pPr algn="ctr" indent="0" marL="0">
+              <a:buNone/>
+            </a:pPr>
             <a:r>
               <a:rPr lang="en-US" sz="1500" dirty="0">
                 <a:solidFill>
@@ -3992,6 +4179,9 @@
               </a:rPr>
               <a:t>Use the Claude app — a fresh chat per task.    </a:t>
             </a:r>
+            <a:pPr algn="ctr" indent="0" marL="0">
+              <a:buNone/>
+            </a:pPr>
             <a:r>
               <a:rPr lang="en-US" sz="1500" b="1" dirty="0">
                 <a:solidFill>
@@ -4003,6 +4193,9 @@
               </a:rPr>
               <a:t>Comfortable in one? </a:t>
             </a:r>
+            <a:pPr algn="ctr" indent="0" marL="0">
+              <a:buNone/>
+            </a:pPr>
             <a:r>
               <a:rPr lang="en-US" sz="1500" dirty="0">
                 <a:solidFill>
@@ -4039,7 +4232,7 @@
           <a:bodyPr wrap="square" lIns="0" tIns="0" rIns="0" bIns="0" rtlCol="0" anchor="ctr"/>
           <a:lstStyle/>
           <a:p>
-            <a:pPr marL="0" indent="0">
+            <a:pPr indent="0" marL="0">
               <a:buNone/>
             </a:pPr>
             <a:r>
@@ -4078,7 +4271,7 @@
           <a:bodyPr wrap="square" lIns="0" tIns="0" rIns="0" bIns="0" rtlCol="0" anchor="ctr"/>
           <a:lstStyle/>
           <a:p>
-            <a:pPr marL="0" indent="0" algn="r">
+            <a:pPr algn="r" indent="0" marL="0">
               <a:buNone/>
             </a:pPr>
             <a:r>
@@ -4090,7 +4283,7 @@
                 <a:ea typeface="Consolas" pitchFamily="34" charset="-122"/>
                 <a:cs typeface="Consolas" pitchFamily="34" charset="-120"/>
               </a:rPr>
-              <a:t>16</a:t>
+              <a:t>12</a:t>
             </a:r>
             <a:endParaRPr lang="en-US" sz="900" dirty="0"/>
           </a:p>
@@ -4106,13 +4299,12 @@
 
 <file path=ppt/slides/slide13.xml><?xml version="1.0" encoding="utf-8"?>
 <p:sld xmlns:a="http://schemas.openxmlformats.org/drawingml/2006/main" xmlns:r="http://schemas.openxmlformats.org/officeDocument/2006/relationships" xmlns:p="http://schemas.openxmlformats.org/presentationml/2006/main">
-  <p:cSld name="Slide 17">
+  <p:cSld name="Slide 13">
     <p:bg>
       <p:bgPr>
         <a:solidFill>
           <a:srgbClr val="17151F"/>
         </a:solidFill>
-        <a:effectLst/>
       </p:bgPr>
     </p:bg>
     <p:spTree>
@@ -4155,13 +4347,6 @@
             <a:prstDash val="solid"/>
           </a:ln>
         </p:spPr>
-        <p:txBody>
-          <a:bodyPr/>
-          <a:lstStyle/>
-          <a:p>
-            <a:endParaRPr lang="en-US"/>
-          </a:p>
-        </p:txBody>
       </p:sp>
       <p:sp>
         <p:nvSpPr>
@@ -4189,13 +4374,6 @@
             <a:prstDash val="solid"/>
           </a:ln>
         </p:spPr>
-        <p:txBody>
-          <a:bodyPr/>
-          <a:lstStyle/>
-          <a:p>
-            <a:endParaRPr lang="en-US"/>
-          </a:p>
-        </p:txBody>
       </p:sp>
       <p:sp>
         <p:nvSpPr>
@@ -4223,13 +4401,6 @@
             <a:prstDash val="solid"/>
           </a:ln>
         </p:spPr>
-        <p:txBody>
-          <a:bodyPr/>
-          <a:lstStyle/>
-          <a:p>
-            <a:endParaRPr lang="en-US"/>
-          </a:p>
-        </p:txBody>
       </p:sp>
       <p:sp>
         <p:nvSpPr>
@@ -4257,13 +4428,6 @@
             <a:prstDash val="solid"/>
           </a:ln>
         </p:spPr>
-        <p:txBody>
-          <a:bodyPr/>
-          <a:lstStyle/>
-          <a:p>
-            <a:endParaRPr lang="en-US"/>
-          </a:p>
-        </p:txBody>
       </p:sp>
       <p:sp>
         <p:nvSpPr>
@@ -4286,7 +4450,7 @@
           <a:bodyPr wrap="square" lIns="0" tIns="0" rIns="0" bIns="0" rtlCol="0" anchor="ctr"/>
           <a:lstStyle/>
           <a:p>
-            <a:pPr marL="0" indent="0">
+            <a:pPr indent="0" marL="0">
               <a:buNone/>
             </a:pPr>
             <a:r>
@@ -4325,7 +4489,7 @@
           <a:bodyPr wrap="square" lIns="0" tIns="0" rIns="0" bIns="0" rtlCol="0" anchor="ctr"/>
           <a:lstStyle/>
           <a:p>
-            <a:pPr marL="0" indent="0">
+            <a:pPr indent="0" marL="0">
               <a:buNone/>
             </a:pPr>
             <a:r>
@@ -4337,8 +4501,11 @@
                 <a:ea typeface="Calibri" pitchFamily="34" charset="-122"/>
                 <a:cs typeface="Calibri" pitchFamily="34" charset="-120"/>
               </a:rPr>
-              <a:t>Questions — and then, fittingly: </a:t>
-            </a:r>
+              <a:t>Questions — then go point it at </a:t>
+            </a:r>
+            <a:pPr indent="0" marL="0">
+              <a:buNone/>
+            </a:pPr>
             <a:r>
               <a:rPr lang="en-US" sz="2200" b="1" dirty="0">
                 <a:solidFill>
@@ -4348,7 +4515,7 @@
                 <a:ea typeface="Calibri" pitchFamily="34" charset="-122"/>
                 <a:cs typeface="Calibri" pitchFamily="34" charset="-120"/>
               </a:rPr>
-              <a:t>book time with me.</a:t>
+              <a:t>your own project.</a:t>
             </a:r>
             <a:endParaRPr lang="en-US" sz="2200" dirty="0"/>
           </a:p>
@@ -4375,7 +4542,7 @@
           <a:bodyPr wrap="square" lIns="0" tIns="0" rIns="0" bIns="0" rtlCol="0" anchor="ctr"/>
           <a:lstStyle/>
           <a:p>
-            <a:pPr marL="0" indent="0">
+            <a:pPr indent="0" marL="0">
               <a:buNone/>
             </a:pPr>
             <a:r>
@@ -4414,7 +4581,7 @@
           <a:bodyPr wrap="square" lIns="0" tIns="0" rIns="0" bIns="0" rtlCol="0" anchor="ctr"/>
           <a:lstStyle/>
           <a:p>
-            <a:pPr marL="0" indent="0">
+            <a:pPr indent="0" marL="0">
               <a:buNone/>
             </a:pPr>
             <a:r>
@@ -4448,7 +4615,6 @@
         <a:solidFill>
           <a:srgbClr val="FFFFFF"/>
         </a:solidFill>
-        <a:effectLst/>
       </p:bgPr>
     </p:bg>
     <p:spTree>
@@ -4486,11 +4652,11 @@
           <a:bodyPr wrap="square" lIns="0" tIns="0" rIns="0" bIns="0" rtlCol="0" anchor="ctr"/>
           <a:lstStyle/>
           <a:p>
-            <a:pPr marL="0" indent="0">
-              <a:buNone/>
-            </a:pPr>
-            <a:r>
-              <a:rPr lang="en-US" sz="1200" b="1" kern="0" spc="200" dirty="0">
+            <a:pPr indent="0" marL="0">
+              <a:buNone/>
+            </a:pPr>
+            <a:r>
+              <a:rPr lang="en-US" sz="1200" b="1" spc="200" kern="0" dirty="0">
                 <a:solidFill>
                   <a:srgbClr val="5B3DF5"/>
                 </a:solidFill>
@@ -4525,7 +4691,7 @@
           <a:bodyPr wrap="square" lIns="0" tIns="0" rIns="0" bIns="0" rtlCol="0" anchor="t"/>
           <a:lstStyle/>
           <a:p>
-            <a:pPr marL="0" indent="0">
+            <a:pPr indent="0" marL="0">
               <a:buNone/>
             </a:pPr>
             <a:r>
@@ -4542,7 +4708,7 @@
             <a:endParaRPr lang="en-US" sz="3400" dirty="0"/>
           </a:p>
           <a:p>
-            <a:pPr marL="0" indent="0">
+            <a:pPr indent="0" marL="0">
               <a:buNone/>
             </a:pPr>
             <a:r>
@@ -4581,7 +4747,7 @@
           <a:bodyPr wrap="square" lIns="0" tIns="0" rIns="0" bIns="0" rtlCol="0" anchor="ctr"/>
           <a:lstStyle/>
           <a:p>
-            <a:pPr marL="0" indent="0">
+            <a:pPr indent="0" marL="0">
               <a:lnSpc>
                 <a:spcPct val="110000"/>
               </a:lnSpc>
@@ -4628,20 +4794,13 @@
             <a:prstDash val="solid"/>
           </a:ln>
           <a:effectLst>
-            <a:outerShdw blurRad="114300" dist="38100" dir="8100000" algn="bl" rotWithShape="0">
+            <a:outerShdw sx="100000" sy="100000" kx="0" ky="0" algn="bl" rotWithShape="0" blurRad="114300" dist="38100" dir="8100000">
               <a:srgbClr val="17151F">
                 <a:alpha val="12000"/>
               </a:srgbClr>
             </a:outerShdw>
           </a:effectLst>
         </p:spPr>
-        <p:txBody>
-          <a:bodyPr/>
-          <a:lstStyle/>
-          <a:p>
-            <a:endParaRPr lang="en-US"/>
-          </a:p>
-        </p:txBody>
       </p:sp>
       <p:sp>
         <p:nvSpPr>
@@ -4664,7 +4823,7 @@
           <a:bodyPr wrap="square" lIns="0" tIns="0" rIns="0" bIns="0" rtlCol="0" anchor="ctr"/>
           <a:lstStyle/>
           <a:p>
-            <a:pPr marL="0" indent="0" algn="ctr">
+            <a:pPr algn="ctr" indent="0" marL="0">
               <a:buNone/>
             </a:pPr>
             <a:r>
@@ -4706,13 +4865,6 @@
             <a:prstDash val="solid"/>
           </a:ln>
         </p:spPr>
-        <p:txBody>
-          <a:bodyPr/>
-          <a:lstStyle/>
-          <a:p>
-            <a:endParaRPr lang="en-US"/>
-          </a:p>
-        </p:txBody>
       </p:sp>
       <p:sp>
         <p:nvSpPr>
@@ -4738,13 +4890,6 @@
             <a:prstDash val="solid"/>
           </a:ln>
         </p:spPr>
-        <p:txBody>
-          <a:bodyPr/>
-          <a:lstStyle/>
-          <a:p>
-            <a:endParaRPr lang="en-US"/>
-          </a:p>
-        </p:txBody>
       </p:sp>
       <p:sp>
         <p:nvSpPr>
@@ -4770,13 +4915,6 @@
             <a:prstDash val="solid"/>
           </a:ln>
         </p:spPr>
-        <p:txBody>
-          <a:bodyPr/>
-          <a:lstStyle/>
-          <a:p>
-            <a:endParaRPr lang="en-US"/>
-          </a:p>
-        </p:txBody>
       </p:sp>
       <p:sp>
         <p:nvSpPr>
@@ -4802,13 +4940,6 @@
             <a:prstDash val="solid"/>
           </a:ln>
         </p:spPr>
-        <p:txBody>
-          <a:bodyPr/>
-          <a:lstStyle/>
-          <a:p>
-            <a:endParaRPr lang="en-US"/>
-          </a:p>
-        </p:txBody>
       </p:sp>
       <p:sp>
         <p:nvSpPr>
@@ -4834,13 +4965,6 @@
             <a:prstDash val="solid"/>
           </a:ln>
         </p:spPr>
-        <p:txBody>
-          <a:bodyPr/>
-          <a:lstStyle/>
-          <a:p>
-            <a:endParaRPr lang="en-US"/>
-          </a:p>
-        </p:txBody>
       </p:sp>
       <p:sp>
         <p:nvSpPr>
@@ -4866,13 +4990,6 @@
             <a:prstDash val="solid"/>
           </a:ln>
         </p:spPr>
-        <p:txBody>
-          <a:bodyPr/>
-          <a:lstStyle/>
-          <a:p>
-            <a:endParaRPr lang="en-US"/>
-          </a:p>
-        </p:txBody>
       </p:sp>
       <p:sp>
         <p:nvSpPr>
@@ -4895,7 +5012,7 @@
           <a:bodyPr wrap="square" lIns="0" tIns="0" rIns="0" bIns="0" rtlCol="0" anchor="ctr"/>
           <a:lstStyle/>
           <a:p>
-            <a:pPr marL="0" indent="0" algn="ctr">
+            <a:pPr algn="ctr" indent="0" marL="0">
               <a:buNone/>
             </a:pPr>
             <a:r>
@@ -4934,7 +5051,7 @@
           <a:bodyPr wrap="square" lIns="0" tIns="0" rIns="0" bIns="0" rtlCol="0" anchor="ctr"/>
           <a:lstStyle/>
           <a:p>
-            <a:pPr marL="0" indent="0" algn="ctr">
+            <a:pPr algn="ctr" indent="0" marL="0">
               <a:buNone/>
             </a:pPr>
             <a:r>
@@ -4978,13 +5095,6 @@
             <a:prstDash val="solid"/>
           </a:ln>
         </p:spPr>
-        <p:txBody>
-          <a:bodyPr/>
-          <a:lstStyle/>
-          <a:p>
-            <a:endParaRPr lang="en-US"/>
-          </a:p>
-        </p:txBody>
       </p:sp>
       <p:sp>
         <p:nvSpPr>
@@ -5007,7 +5117,7 @@
           <a:bodyPr wrap="square" lIns="0" tIns="0" rIns="0" bIns="0" rtlCol="0" anchor="ctr"/>
           <a:lstStyle/>
           <a:p>
-            <a:pPr marL="0" indent="0" algn="ctr">
+            <a:pPr algn="ctr" indent="0" marL="0">
               <a:buNone/>
             </a:pPr>
             <a:r>
@@ -5051,13 +5161,6 @@
             <a:prstDash val="solid"/>
           </a:ln>
         </p:spPr>
-        <p:txBody>
-          <a:bodyPr/>
-          <a:lstStyle/>
-          <a:p>
-            <a:endParaRPr lang="en-US"/>
-          </a:p>
-        </p:txBody>
       </p:sp>
       <p:sp>
         <p:nvSpPr>
@@ -5080,7 +5183,7 @@
           <a:bodyPr wrap="square" lIns="0" tIns="0" rIns="0" bIns="0" rtlCol="0" anchor="ctr"/>
           <a:lstStyle/>
           <a:p>
-            <a:pPr marL="0" indent="0" algn="ctr">
+            <a:pPr algn="ctr" indent="0" marL="0">
               <a:buNone/>
             </a:pPr>
             <a:r>
@@ -5124,13 +5227,6 @@
             <a:prstDash val="solid"/>
           </a:ln>
         </p:spPr>
-        <p:txBody>
-          <a:bodyPr/>
-          <a:lstStyle/>
-          <a:p>
-            <a:endParaRPr lang="en-US"/>
-          </a:p>
-        </p:txBody>
       </p:sp>
       <p:sp>
         <p:nvSpPr>
@@ -5153,7 +5249,7 @@
           <a:bodyPr wrap="square" lIns="0" tIns="0" rIns="0" bIns="0" rtlCol="0" anchor="ctr"/>
           <a:lstStyle/>
           <a:p>
-            <a:pPr marL="0" indent="0" algn="ctr">
+            <a:pPr algn="ctr" indent="0" marL="0">
               <a:buNone/>
             </a:pPr>
             <a:r>
@@ -5197,13 +5293,6 @@
             <a:prstDash val="solid"/>
           </a:ln>
         </p:spPr>
-        <p:txBody>
-          <a:bodyPr/>
-          <a:lstStyle/>
-          <a:p>
-            <a:endParaRPr lang="en-US"/>
-          </a:p>
-        </p:txBody>
       </p:sp>
       <p:sp>
         <p:nvSpPr>
@@ -5226,7 +5315,7 @@
           <a:bodyPr wrap="square" lIns="0" tIns="0" rIns="0" bIns="0" rtlCol="0" anchor="ctr"/>
           <a:lstStyle/>
           <a:p>
-            <a:pPr marL="0" indent="0" algn="ctr">
+            <a:pPr algn="ctr" indent="0" marL="0">
               <a:buNone/>
             </a:pPr>
             <a:r>
@@ -5270,13 +5359,6 @@
             <a:prstDash val="solid"/>
           </a:ln>
         </p:spPr>
-        <p:txBody>
-          <a:bodyPr/>
-          <a:lstStyle/>
-          <a:p>
-            <a:endParaRPr lang="en-US"/>
-          </a:p>
-        </p:txBody>
       </p:sp>
       <p:sp>
         <p:nvSpPr>
@@ -5299,7 +5381,7 @@
           <a:bodyPr wrap="square" lIns="0" tIns="0" rIns="0" bIns="0" rtlCol="0" anchor="ctr"/>
           <a:lstStyle/>
           <a:p>
-            <a:pPr marL="0" indent="0" algn="ctr">
+            <a:pPr algn="ctr" indent="0" marL="0">
               <a:buNone/>
             </a:pPr>
             <a:r>
@@ -5338,7 +5420,7 @@
           <a:bodyPr wrap="square" lIns="0" tIns="0" rIns="0" bIns="0" rtlCol="0" anchor="ctr"/>
           <a:lstStyle/>
           <a:p>
-            <a:pPr marL="0" indent="0" algn="ctr">
+            <a:pPr algn="ctr" indent="0" marL="0">
               <a:buNone/>
             </a:pPr>
             <a:r>
@@ -5377,7 +5459,7 @@
           <a:bodyPr wrap="square" lIns="0" tIns="0" rIns="0" bIns="0" rtlCol="0" anchor="ctr"/>
           <a:lstStyle/>
           <a:p>
-            <a:pPr marL="0" indent="0">
+            <a:pPr indent="0" marL="0">
               <a:buNone/>
             </a:pPr>
             <a:r>
@@ -5416,7 +5498,7 @@
           <a:bodyPr wrap="square" lIns="0" tIns="0" rIns="0" bIns="0" rtlCol="0" anchor="ctr"/>
           <a:lstStyle/>
           <a:p>
-            <a:pPr marL="0" indent="0" algn="r">
+            <a:pPr algn="r" indent="0" marL="0">
               <a:buNone/>
             </a:pPr>
             <a:r>
@@ -5450,7 +5532,6 @@
         <a:solidFill>
           <a:srgbClr val="FFFFFF"/>
         </a:solidFill>
-        <a:effectLst/>
       </p:bgPr>
     </p:bg>
     <p:spTree>
@@ -5488,11 +5569,11 @@
           <a:bodyPr wrap="square" lIns="0" tIns="0" rIns="0" bIns="0" rtlCol="0" anchor="ctr"/>
           <a:lstStyle/>
           <a:p>
-            <a:pPr marL="0" indent="0">
-              <a:buNone/>
-            </a:pPr>
-            <a:r>
-              <a:rPr lang="en-US" sz="1200" b="1" kern="0" spc="200" dirty="0">
+            <a:pPr indent="0" marL="0">
+              <a:buNone/>
+            </a:pPr>
+            <a:r>
+              <a:rPr lang="en-US" sz="1200" b="1" spc="200" kern="0" dirty="0">
                 <a:solidFill>
                   <a:srgbClr val="5B3DF5"/>
                 </a:solidFill>
@@ -5527,7 +5608,7 @@
           <a:bodyPr wrap="square" lIns="0" tIns="0" rIns="0" bIns="0" rtlCol="0" anchor="t"/>
           <a:lstStyle/>
           <a:p>
-            <a:pPr marL="0" indent="0">
+            <a:pPr indent="0" marL="0">
               <a:buNone/>
             </a:pPr>
             <a:r>
@@ -5571,20 +5652,13 @@
             <a:prstDash val="solid"/>
           </a:ln>
           <a:effectLst>
-            <a:outerShdw blurRad="114300" dist="38100" dir="8100000" algn="bl" rotWithShape="0">
+            <a:outerShdw sx="100000" sy="100000" kx="0" ky="0" algn="bl" rotWithShape="0" blurRad="114300" dist="38100" dir="8100000">
               <a:srgbClr val="17151F">
                 <a:alpha val="12000"/>
               </a:srgbClr>
             </a:outerShdw>
           </a:effectLst>
         </p:spPr>
-        <p:txBody>
-          <a:bodyPr/>
-          <a:lstStyle/>
-          <a:p>
-            <a:endParaRPr lang="en-US"/>
-          </a:p>
-        </p:txBody>
       </p:sp>
       <p:sp>
         <p:nvSpPr>
@@ -5607,7 +5681,7 @@
           <a:bodyPr wrap="square" lIns="0" tIns="0" rIns="0" bIns="0" rtlCol="0" anchor="ctr"/>
           <a:lstStyle/>
           <a:p>
-            <a:pPr marL="0" indent="0" algn="ctr">
+            <a:pPr algn="ctr" indent="0" marL="0">
               <a:buNone/>
             </a:pPr>
             <a:r>
@@ -5646,7 +5720,7 @@
           <a:bodyPr wrap="square" lIns="0" tIns="0" rIns="0" bIns="0" rtlCol="0" anchor="ctr"/>
           <a:lstStyle/>
           <a:p>
-            <a:pPr marL="0" indent="0" algn="ctr">
+            <a:pPr algn="ctr" indent="0" marL="0">
               <a:buNone/>
             </a:pPr>
             <a:r>
@@ -5685,7 +5759,7 @@
           <a:bodyPr wrap="square" lIns="0" tIns="0" rIns="0" bIns="0" rtlCol="0" anchor="ctr"/>
           <a:lstStyle/>
           <a:p>
-            <a:pPr marL="0" indent="0" algn="ctr">
+            <a:pPr algn="ctr" indent="0" marL="0">
               <a:buNone/>
             </a:pPr>
             <a:r>
@@ -5697,7 +5771,7 @@
                 <a:ea typeface="Calibri" pitchFamily="34" charset="-122"/>
                 <a:cs typeface="Calibri" pitchFamily="34" charset="-120"/>
               </a:rPr>
-              <a:t>typed in 15 seconds</a:t>
+              <a:t>→ a spec, in minutes</a:t>
             </a:r>
             <a:endParaRPr lang="en-US" sz="1300" dirty="0"/>
           </a:p>
@@ -5729,20 +5803,13 @@
             <a:prstDash val="solid"/>
           </a:ln>
           <a:effectLst>
-            <a:outerShdw blurRad="114300" dist="38100" dir="8100000" algn="bl" rotWithShape="0">
+            <a:outerShdw sx="100000" sy="100000" kx="0" ky="0" algn="bl" rotWithShape="0" blurRad="114300" dist="38100" dir="8100000">
               <a:srgbClr val="17151F">
                 <a:alpha val="12000"/>
               </a:srgbClr>
             </a:outerShdw>
           </a:effectLst>
         </p:spPr>
-        <p:txBody>
-          <a:bodyPr/>
-          <a:lstStyle/>
-          <a:p>
-            <a:endParaRPr lang="en-US"/>
-          </a:p>
-        </p:txBody>
       </p:sp>
       <p:sp>
         <p:nvSpPr>
@@ -5765,7 +5832,7 @@
           <a:bodyPr wrap="square" lIns="0" tIns="0" rIns="0" bIns="0" rtlCol="0" anchor="ctr"/>
           <a:lstStyle/>
           <a:p>
-            <a:pPr marL="0" indent="0" algn="ctr">
+            <a:pPr algn="ctr" indent="0" marL="0">
               <a:buNone/>
             </a:pPr>
             <a:r>
@@ -5804,7 +5871,7 @@
           <a:bodyPr wrap="square" lIns="0" tIns="0" rIns="0" bIns="0" rtlCol="0" anchor="ctr"/>
           <a:lstStyle/>
           <a:p>
-            <a:pPr marL="0" indent="0" algn="ctr">
+            <a:pPr algn="ctr" indent="0" marL="0">
               <a:buNone/>
             </a:pPr>
             <a:r>
@@ -5843,7 +5910,7 @@
           <a:bodyPr wrap="square" lIns="0" tIns="0" rIns="0" bIns="0" rtlCol="0" anchor="ctr"/>
           <a:lstStyle/>
           <a:p>
-            <a:pPr marL="0" indent="0" algn="ctr">
+            <a:pPr algn="ctr" indent="0" marL="0">
               <a:buNone/>
             </a:pPr>
             <a:r>
@@ -5855,7 +5922,7 @@
                 <a:ea typeface="Calibri" pitchFamily="34" charset="-122"/>
                 <a:cs typeface="Calibri" pitchFamily="34" charset="-120"/>
               </a:rPr>
-              <a:t>research + build, in parallel</a:t>
+              <a:t>plan + build, in parallel</a:t>
             </a:r>
             <a:endParaRPr lang="en-US" sz="1300" dirty="0"/>
           </a:p>
@@ -5887,20 +5954,13 @@
             <a:prstDash val="solid"/>
           </a:ln>
           <a:effectLst>
-            <a:outerShdw blurRad="114300" dist="38100" dir="8100000" algn="bl" rotWithShape="0">
+            <a:outerShdw sx="100000" sy="100000" kx="0" ky="0" algn="bl" rotWithShape="0" blurRad="114300" dist="38100" dir="8100000">
               <a:srgbClr val="17151F">
                 <a:alpha val="12000"/>
               </a:srgbClr>
             </a:outerShdw>
           </a:effectLst>
         </p:spPr>
-        <p:txBody>
-          <a:bodyPr/>
-          <a:lstStyle/>
-          <a:p>
-            <a:endParaRPr lang="en-US"/>
-          </a:p>
-        </p:txBody>
       </p:sp>
       <p:sp>
         <p:nvSpPr>
@@ -5923,7 +5983,7 @@
           <a:bodyPr wrap="square" lIns="0" tIns="0" rIns="0" bIns="0" rtlCol="0" anchor="ctr"/>
           <a:lstStyle/>
           <a:p>
-            <a:pPr marL="0" indent="0" algn="ctr">
+            <a:pPr algn="ctr" indent="0" marL="0">
               <a:buNone/>
             </a:pPr>
             <a:r>
@@ -5962,7 +6022,7 @@
           <a:bodyPr wrap="square" lIns="0" tIns="0" rIns="0" bIns="0" rtlCol="0" anchor="ctr"/>
           <a:lstStyle/>
           <a:p>
-            <a:pPr marL="0" indent="0" algn="ctr">
+            <a:pPr algn="ctr" indent="0" marL="0">
               <a:buNone/>
             </a:pPr>
             <a:r>
@@ -5974,7 +6034,7 @@
                 <a:ea typeface="Calibri" pitchFamily="34" charset="-122"/>
                 <a:cs typeface="Calibri" pitchFamily="34" charset="-120"/>
               </a:rPr>
-              <a:t>live URL</a:t>
+              <a:t>ledger</a:t>
             </a:r>
             <a:endParaRPr lang="en-US" sz="2000" dirty="0"/>
           </a:p>
@@ -6001,7 +6061,7 @@
           <a:bodyPr wrap="square" lIns="0" tIns="0" rIns="0" bIns="0" rtlCol="0" anchor="ctr"/>
           <a:lstStyle/>
           <a:p>
-            <a:pPr marL="0" indent="0" algn="ctr">
+            <a:pPr algn="ctr" indent="0" marL="0">
               <a:buNone/>
             </a:pPr>
             <a:r>
@@ -6013,7 +6073,7 @@
                 <a:ea typeface="Calibri" pitchFamily="34" charset="-122"/>
                 <a:cs typeface="Calibri" pitchFamily="34" charset="-120"/>
               </a:rPr>
-              <a:t>real site + real database</a:t>
+              <a:t>every task driven to done</a:t>
             </a:r>
             <a:endParaRPr lang="en-US" sz="1300" dirty="0"/>
           </a:p>
@@ -6040,7 +6100,7 @@
           <a:bodyPr wrap="square" lIns="0" tIns="0" rIns="0" bIns="0" rtlCol="0" anchor="ctr"/>
           <a:lstStyle/>
           <a:p>
-            <a:pPr marL="0" indent="0" algn="ctr">
+            <a:pPr algn="ctr" indent="0" marL="0">
               <a:buNone/>
             </a:pPr>
             <a:r>
@@ -6054,6 +6114,9 @@
               </a:rPr>
               <a:t>And the method works for anything — </a:t>
             </a:r>
+            <a:pPr algn="ctr" indent="0" marL="0">
+              <a:buNone/>
+            </a:pPr>
             <a:r>
               <a:rPr lang="en-US" sz="1800" b="1" dirty="0">
                 <a:solidFill>
@@ -6090,7 +6153,7 @@
           <a:bodyPr wrap="square" lIns="0" tIns="0" rIns="0" bIns="0" rtlCol="0" anchor="ctr"/>
           <a:lstStyle/>
           <a:p>
-            <a:pPr marL="0" indent="0">
+            <a:pPr indent="0" marL="0">
               <a:buNone/>
             </a:pPr>
             <a:r>
@@ -6129,7 +6192,7 @@
           <a:bodyPr wrap="square" lIns="0" tIns="0" rIns="0" bIns="0" rtlCol="0" anchor="ctr"/>
           <a:lstStyle/>
           <a:p>
-            <a:pPr marL="0" indent="0" algn="r">
+            <a:pPr algn="r" indent="0" marL="0">
               <a:buNone/>
             </a:pPr>
             <a:r>
@@ -6163,7 +6226,6 @@
         <a:solidFill>
           <a:srgbClr val="FFFFFF"/>
         </a:solidFill>
-        <a:effectLst/>
       </p:bgPr>
     </p:bg>
     <p:spTree>
@@ -6201,11 +6263,11 @@
           <a:bodyPr wrap="square" lIns="0" tIns="0" rIns="0" bIns="0" rtlCol="0" anchor="ctr"/>
           <a:lstStyle/>
           <a:p>
-            <a:pPr marL="0" indent="0">
-              <a:buNone/>
-            </a:pPr>
-            <a:r>
-              <a:rPr lang="en-US" sz="1200" b="1" kern="0" spc="200" dirty="0">
+            <a:pPr indent="0" marL="0">
+              <a:buNone/>
+            </a:pPr>
+            <a:r>
+              <a:rPr lang="en-US" sz="1200" b="1" spc="200" kern="0" dirty="0">
                 <a:solidFill>
                   <a:srgbClr val="5B3DF5"/>
                 </a:solidFill>
@@ -6240,7 +6302,7 @@
           <a:bodyPr wrap="square" lIns="0" tIns="0" rIns="0" bIns="0" rtlCol="0" anchor="t"/>
           <a:lstStyle/>
           <a:p>
-            <a:pPr marL="0" indent="0">
+            <a:pPr indent="0" marL="0">
               <a:buNone/>
             </a:pPr>
             <a:r>
@@ -6282,13 +6344,6 @@
             <a:prstDash val="solid"/>
           </a:ln>
         </p:spPr>
-        <p:txBody>
-          <a:bodyPr/>
-          <a:lstStyle/>
-          <a:p>
-            <a:endParaRPr lang="en-US"/>
-          </a:p>
-        </p:txBody>
       </p:sp>
       <p:sp>
         <p:nvSpPr>
@@ -6311,7 +6366,7 @@
           <a:bodyPr wrap="square" lIns="0" tIns="0" rIns="0" bIns="0" rtlCol="0" anchor="ctr"/>
           <a:lstStyle/>
           <a:p>
-            <a:pPr marL="0" indent="0" algn="ctr">
+            <a:pPr algn="ctr" indent="0" marL="0">
               <a:buNone/>
             </a:pPr>
             <a:r>
@@ -6350,7 +6405,7 @@
           <a:bodyPr wrap="square" lIns="0" tIns="0" rIns="0" bIns="0" rtlCol="0" anchor="ctr"/>
           <a:lstStyle/>
           <a:p>
-            <a:pPr marL="0" indent="0">
+            <a:pPr indent="0" marL="0">
               <a:buNone/>
             </a:pPr>
             <a:r>
@@ -6389,7 +6444,7 @@
           <a:bodyPr wrap="square" lIns="0" tIns="0" rIns="0" bIns="0" rtlCol="0" anchor="ctr"/>
           <a:lstStyle/>
           <a:p>
-            <a:pPr marL="0" indent="0">
+            <a:pPr indent="0" marL="0">
               <a:buNone/>
             </a:pPr>
             <a:r>
@@ -6431,13 +6486,6 @@
             <a:prstDash val="solid"/>
           </a:ln>
         </p:spPr>
-        <p:txBody>
-          <a:bodyPr/>
-          <a:lstStyle/>
-          <a:p>
-            <a:endParaRPr lang="en-US"/>
-          </a:p>
-        </p:txBody>
       </p:sp>
       <p:sp>
         <p:nvSpPr>
@@ -6460,7 +6508,7 @@
           <a:bodyPr wrap="square" lIns="0" tIns="0" rIns="0" bIns="0" rtlCol="0" anchor="ctr"/>
           <a:lstStyle/>
           <a:p>
-            <a:pPr marL="0" indent="0" algn="ctr">
+            <a:pPr algn="ctr" indent="0" marL="0">
               <a:buNone/>
             </a:pPr>
             <a:r>
@@ -6499,7 +6547,7 @@
           <a:bodyPr wrap="square" lIns="0" tIns="0" rIns="0" bIns="0" rtlCol="0" anchor="ctr"/>
           <a:lstStyle/>
           <a:p>
-            <a:pPr marL="0" indent="0">
+            <a:pPr indent="0" marL="0">
               <a:buNone/>
             </a:pPr>
             <a:r>
@@ -6538,7 +6586,7 @@
           <a:bodyPr wrap="square" lIns="0" tIns="0" rIns="0" bIns="0" rtlCol="0" anchor="ctr"/>
           <a:lstStyle/>
           <a:p>
-            <a:pPr marL="0" indent="0">
+            <a:pPr indent="0" marL="0">
               <a:buNone/>
             </a:pPr>
             <a:r>
@@ -6580,13 +6628,6 @@
             <a:prstDash val="solid"/>
           </a:ln>
         </p:spPr>
-        <p:txBody>
-          <a:bodyPr/>
-          <a:lstStyle/>
-          <a:p>
-            <a:endParaRPr lang="en-US"/>
-          </a:p>
-        </p:txBody>
       </p:sp>
       <p:sp>
         <p:nvSpPr>
@@ -6609,7 +6650,7 @@
           <a:bodyPr wrap="square" lIns="0" tIns="0" rIns="0" bIns="0" rtlCol="0" anchor="ctr"/>
           <a:lstStyle/>
           <a:p>
-            <a:pPr marL="0" indent="0" algn="ctr">
+            <a:pPr algn="ctr" indent="0" marL="0">
               <a:buNone/>
             </a:pPr>
             <a:r>
@@ -6648,7 +6689,7 @@
           <a:bodyPr wrap="square" lIns="0" tIns="0" rIns="0" bIns="0" rtlCol="0" anchor="ctr"/>
           <a:lstStyle/>
           <a:p>
-            <a:pPr marL="0" indent="0">
+            <a:pPr indent="0" marL="0">
               <a:buNone/>
             </a:pPr>
             <a:r>
@@ -6687,7 +6728,7 @@
           <a:bodyPr wrap="square" lIns="0" tIns="0" rIns="0" bIns="0" rtlCol="0" anchor="ctr"/>
           <a:lstStyle/>
           <a:p>
-            <a:pPr marL="0" indent="0">
+            <a:pPr indent="0" marL="0">
               <a:buNone/>
             </a:pPr>
             <a:r>
@@ -6729,13 +6770,6 @@
             <a:prstDash val="solid"/>
           </a:ln>
         </p:spPr>
-        <p:txBody>
-          <a:bodyPr/>
-          <a:lstStyle/>
-          <a:p>
-            <a:endParaRPr lang="en-US"/>
-          </a:p>
-        </p:txBody>
       </p:sp>
       <p:sp>
         <p:nvSpPr>
@@ -6758,7 +6792,7 @@
           <a:bodyPr wrap="square" lIns="0" tIns="0" rIns="0" bIns="0" rtlCol="0" anchor="ctr"/>
           <a:lstStyle/>
           <a:p>
-            <a:pPr marL="0" indent="0" algn="ctr">
+            <a:pPr algn="ctr" indent="0" marL="0">
               <a:buNone/>
             </a:pPr>
             <a:r>
@@ -6797,7 +6831,7 @@
           <a:bodyPr wrap="square" lIns="0" tIns="0" rIns="0" bIns="0" rtlCol="0" anchor="ctr"/>
           <a:lstStyle/>
           <a:p>
-            <a:pPr marL="0" indent="0">
+            <a:pPr indent="0" marL="0">
               <a:buNone/>
             </a:pPr>
             <a:r>
@@ -6836,7 +6870,7 @@
           <a:bodyPr wrap="square" lIns="0" tIns="0" rIns="0" bIns="0" rtlCol="0" anchor="ctr"/>
           <a:lstStyle/>
           <a:p>
-            <a:pPr marL="0" indent="0">
+            <a:pPr indent="0" marL="0">
               <a:buNone/>
             </a:pPr>
             <a:r>
@@ -6878,13 +6912,6 @@
             <a:prstDash val="solid"/>
           </a:ln>
         </p:spPr>
-        <p:txBody>
-          <a:bodyPr/>
-          <a:lstStyle/>
-          <a:p>
-            <a:endParaRPr lang="en-US"/>
-          </a:p>
-        </p:txBody>
       </p:sp>
       <p:sp>
         <p:nvSpPr>
@@ -6907,7 +6934,7 @@
           <a:bodyPr wrap="square" lIns="0" tIns="0" rIns="0" bIns="0" rtlCol="0" anchor="ctr"/>
           <a:lstStyle/>
           <a:p>
-            <a:pPr marL="0" indent="0" algn="ctr">
+            <a:pPr algn="ctr" indent="0" marL="0">
               <a:buNone/>
             </a:pPr>
             <a:r>
@@ -6946,7 +6973,7 @@
           <a:bodyPr wrap="square" lIns="0" tIns="0" rIns="0" bIns="0" rtlCol="0" anchor="ctr"/>
           <a:lstStyle/>
           <a:p>
-            <a:pPr marL="0" indent="0">
+            <a:pPr indent="0" marL="0">
               <a:buNone/>
             </a:pPr>
             <a:r>
@@ -6985,7 +7012,7 @@
           <a:bodyPr wrap="square" lIns="0" tIns="0" rIns="0" bIns="0" rtlCol="0" anchor="ctr"/>
           <a:lstStyle/>
           <a:p>
-            <a:pPr marL="0" indent="0">
+            <a:pPr indent="0" marL="0">
               <a:buNone/>
             </a:pPr>
             <a:r>
@@ -7024,7 +7051,7 @@
           <a:bodyPr wrap="square" lIns="0" tIns="0" rIns="0" bIns="0" rtlCol="0" anchor="ctr"/>
           <a:lstStyle/>
           <a:p>
-            <a:pPr marL="0" indent="0">
+            <a:pPr indent="0" marL="0">
               <a:buNone/>
             </a:pPr>
             <a:r>
@@ -7063,7 +7090,7 @@
           <a:bodyPr wrap="square" lIns="0" tIns="0" rIns="0" bIns="0" rtlCol="0" anchor="ctr"/>
           <a:lstStyle/>
           <a:p>
-            <a:pPr marL="0" indent="0" algn="r">
+            <a:pPr algn="r" indent="0" marL="0">
               <a:buNone/>
             </a:pPr>
             <a:r>
@@ -7097,7 +7124,6 @@
         <a:solidFill>
           <a:srgbClr val="FFFFFF"/>
         </a:solidFill>
-        <a:effectLst/>
       </p:bgPr>
     </p:bg>
     <p:spTree>
@@ -7135,11 +7161,11 @@
           <a:bodyPr wrap="square" lIns="0" tIns="0" rIns="0" bIns="0" rtlCol="0" anchor="ctr"/>
           <a:lstStyle/>
           <a:p>
-            <a:pPr marL="0" indent="0">
-              <a:buNone/>
-            </a:pPr>
-            <a:r>
-              <a:rPr lang="en-US" sz="1200" b="1" kern="0" spc="200" dirty="0">
+            <a:pPr indent="0" marL="0">
+              <a:buNone/>
+            </a:pPr>
+            <a:r>
+              <a:rPr lang="en-US" sz="1200" b="1" spc="200" kern="0" dirty="0">
                 <a:solidFill>
                   <a:srgbClr val="5B3DF5"/>
                 </a:solidFill>
@@ -7174,7 +7200,7 @@
           <a:bodyPr wrap="square" lIns="0" tIns="0" rIns="0" bIns="0" rtlCol="0" anchor="t"/>
           <a:lstStyle/>
           <a:p>
-            <a:pPr marL="0" indent="0">
+            <a:pPr indent="0" marL="0">
               <a:buNone/>
             </a:pPr>
             <a:r>
@@ -7213,11 +7239,11 @@
           <a:bodyPr wrap="square" lIns="0" tIns="0" rIns="0" bIns="0" rtlCol="0" anchor="ctr"/>
           <a:lstStyle/>
           <a:p>
-            <a:pPr marL="0" indent="0">
-              <a:buNone/>
-            </a:pPr>
-            <a:r>
-              <a:rPr lang="en-US" sz="1200" b="1" kern="0" spc="100" dirty="0">
+            <a:pPr indent="0" marL="0">
+              <a:buNone/>
+            </a:pPr>
+            <a:r>
+              <a:rPr lang="en-US" sz="1200" b="1" spc="100" kern="0" dirty="0">
                 <a:solidFill>
                   <a:srgbClr val="6B6770"/>
                 </a:solidFill>
@@ -7253,13 +7279,6 @@
             <a:prstDash val="solid"/>
           </a:ln>
         </p:spPr>
-        <p:txBody>
-          <a:bodyPr/>
-          <a:lstStyle/>
-          <a:p>
-            <a:endParaRPr lang="en-US"/>
-          </a:p>
-        </p:txBody>
       </p:sp>
       <p:sp>
         <p:nvSpPr>
@@ -7287,20 +7306,13 @@
             <a:prstDash val="solid"/>
           </a:ln>
           <a:effectLst>
-            <a:outerShdw blurRad="114300" dist="38100" dir="8100000" algn="bl" rotWithShape="0">
+            <a:outerShdw sx="100000" sy="100000" kx="0" ky="0" algn="bl" rotWithShape="0" blurRad="114300" dist="38100" dir="8100000">
               <a:srgbClr val="17151F">
                 <a:alpha val="12000"/>
               </a:srgbClr>
             </a:outerShdw>
           </a:effectLst>
         </p:spPr>
-        <p:txBody>
-          <a:bodyPr/>
-          <a:lstStyle/>
-          <a:p>
-            <a:endParaRPr lang="en-US"/>
-          </a:p>
-        </p:txBody>
       </p:sp>
       <p:sp>
         <p:nvSpPr>
@@ -7323,7 +7335,7 @@
           <a:bodyPr wrap="square" lIns="0" tIns="0" rIns="0" bIns="0" rtlCol="0" anchor="ctr"/>
           <a:lstStyle/>
           <a:p>
-            <a:pPr marL="0" indent="0">
+            <a:pPr indent="0" marL="0">
               <a:buNone/>
             </a:pPr>
             <a:r>
@@ -7335,7 +7347,7 @@
                 <a:ea typeface="Calibri" pitchFamily="34" charset="-122"/>
                 <a:cs typeface="Calibri" pitchFamily="34" charset="-120"/>
               </a:rPr>
-              <a:t>T-0001 Site launch</a:t>
+              <a:t>T-0001 First task</a:t>
             </a:r>
             <a:endParaRPr lang="en-US" sz="1350" dirty="0"/>
           </a:p>
@@ -7362,11 +7374,11 @@
           <a:bodyPr wrap="square" lIns="0" tIns="0" rIns="0" bIns="0" rtlCol="0" anchor="ctr"/>
           <a:lstStyle/>
           <a:p>
-            <a:pPr marL="0" indent="0">
-              <a:buNone/>
-            </a:pPr>
-            <a:r>
-              <a:rPr lang="en-US" sz="1200" b="1" kern="0" spc="100" dirty="0">
+            <a:pPr indent="0" marL="0">
+              <a:buNone/>
+            </a:pPr>
+            <a:r>
+              <a:rPr lang="en-US" sz="1200" b="1" spc="100" kern="0" dirty="0">
                 <a:solidFill>
                   <a:srgbClr val="6B6770"/>
                 </a:solidFill>
@@ -7402,13 +7414,6 @@
             <a:prstDash val="solid"/>
           </a:ln>
         </p:spPr>
-        <p:txBody>
-          <a:bodyPr/>
-          <a:lstStyle/>
-          <a:p>
-            <a:endParaRPr lang="en-US"/>
-          </a:p>
-        </p:txBody>
       </p:sp>
       <p:sp>
         <p:nvSpPr>
@@ -7436,20 +7441,13 @@
             <a:prstDash val="solid"/>
           </a:ln>
           <a:effectLst>
-            <a:outerShdw blurRad="114300" dist="38100" dir="8100000" algn="bl" rotWithShape="0">
+            <a:outerShdw sx="100000" sy="100000" kx="0" ky="0" algn="bl" rotWithShape="0" blurRad="114300" dist="38100" dir="8100000">
               <a:srgbClr val="17151F">
                 <a:alpha val="12000"/>
               </a:srgbClr>
             </a:outerShdw>
           </a:effectLst>
         </p:spPr>
-        <p:txBody>
-          <a:bodyPr/>
-          <a:lstStyle/>
-          <a:p>
-            <a:endParaRPr lang="en-US"/>
-          </a:p>
-        </p:txBody>
       </p:sp>
       <p:sp>
         <p:nvSpPr>
@@ -7472,7 +7470,7 @@
           <a:bodyPr wrap="square" lIns="0" tIns="0" rIns="0" bIns="0" rtlCol="0" anchor="ctr"/>
           <a:lstStyle/>
           <a:p>
-            <a:pPr marL="0" indent="0">
+            <a:pPr indent="0" marL="0">
               <a:buNone/>
             </a:pPr>
             <a:r>
@@ -7511,11 +7509,11 @@
           <a:bodyPr wrap="square" lIns="0" tIns="0" rIns="0" bIns="0" rtlCol="0" anchor="ctr"/>
           <a:lstStyle/>
           <a:p>
-            <a:pPr marL="0" indent="0">
-              <a:buNone/>
-            </a:pPr>
-            <a:r>
-              <a:rPr lang="en-US" sz="1200" b="1" kern="0" spc="100" dirty="0">
+            <a:pPr indent="0" marL="0">
+              <a:buNone/>
+            </a:pPr>
+            <a:r>
+              <a:rPr lang="en-US" sz="1200" b="1" spc="100" kern="0" dirty="0">
                 <a:solidFill>
                   <a:srgbClr val="B5791A"/>
                 </a:solidFill>
@@ -7551,13 +7549,6 @@
             <a:prstDash val="solid"/>
           </a:ln>
         </p:spPr>
-        <p:txBody>
-          <a:bodyPr/>
-          <a:lstStyle/>
-          <a:p>
-            <a:endParaRPr lang="en-US"/>
-          </a:p>
-        </p:txBody>
       </p:sp>
       <p:sp>
         <p:nvSpPr>
@@ -7585,20 +7576,13 @@
             <a:prstDash val="solid"/>
           </a:ln>
           <a:effectLst>
-            <a:outerShdw blurRad="114300" dist="38100" dir="8100000" algn="bl" rotWithShape="0">
+            <a:outerShdw sx="100000" sy="100000" kx="0" ky="0" algn="bl" rotWithShape="0" blurRad="114300" dist="38100" dir="8100000">
               <a:srgbClr val="17151F">
                 <a:alpha val="12000"/>
               </a:srgbClr>
             </a:outerShdw>
           </a:effectLst>
         </p:spPr>
-        <p:txBody>
-          <a:bodyPr/>
-          <a:lstStyle/>
-          <a:p>
-            <a:endParaRPr lang="en-US"/>
-          </a:p>
-        </p:txBody>
       </p:sp>
       <p:sp>
         <p:nvSpPr>
@@ -7621,7 +7605,7 @@
           <a:bodyPr wrap="square" lIns="0" tIns="0" rIns="0" bIns="0" rtlCol="0" anchor="ctr"/>
           <a:lstStyle/>
           <a:p>
-            <a:pPr marL="0" indent="0">
+            <a:pPr indent="0" marL="0">
               <a:buNone/>
             </a:pPr>
             <a:r>
@@ -7633,7 +7617,7 @@
                 <a:ea typeface="Calibri" pitchFamily="34" charset="-122"/>
                 <a:cs typeface="Calibri" pitchFamily="34" charset="-120"/>
               </a:rPr>
-              <a:t>T-0007 Calendar sync</a:t>
+              <a:t>T-0007 Integration</a:t>
             </a:r>
             <a:endParaRPr lang="en-US" sz="1350" dirty="0"/>
           </a:p>
@@ -7665,20 +7649,13 @@
             <a:prstDash val="solid"/>
           </a:ln>
           <a:effectLst>
-            <a:outerShdw blurRad="114300" dist="38100" dir="8100000" algn="bl" rotWithShape="0">
+            <a:outerShdw sx="100000" sy="100000" kx="0" ky="0" algn="bl" rotWithShape="0" blurRad="114300" dist="38100" dir="8100000">
               <a:srgbClr val="17151F">
                 <a:alpha val="12000"/>
               </a:srgbClr>
             </a:outerShdw>
           </a:effectLst>
         </p:spPr>
-        <p:txBody>
-          <a:bodyPr/>
-          <a:lstStyle/>
-          <a:p>
-            <a:endParaRPr lang="en-US"/>
-          </a:p>
-        </p:txBody>
       </p:sp>
       <p:sp>
         <p:nvSpPr>
@@ -7701,7 +7678,7 @@
           <a:bodyPr wrap="square" lIns="0" tIns="0" rIns="0" bIns="0" rtlCol="0" anchor="ctr"/>
           <a:lstStyle/>
           <a:p>
-            <a:pPr marL="0" indent="0">
+            <a:pPr indent="0" marL="0">
               <a:buNone/>
             </a:pPr>
             <a:r>
@@ -7713,7 +7690,7 @@
                 <a:ea typeface="Calibri" pitchFamily="34" charset="-122"/>
                 <a:cs typeface="Calibri" pitchFamily="34" charset="-120"/>
               </a:rPr>
-              <a:t>T-0008 Multi-user</a:t>
+              <a:t>T-0008 Polish</a:t>
             </a:r>
             <a:endParaRPr lang="en-US" sz="1350" dirty="0"/>
           </a:p>
@@ -7745,20 +7722,13 @@
             <a:prstDash val="solid"/>
           </a:ln>
           <a:effectLst>
-            <a:outerShdw blurRad="114300" dist="38100" dir="8100000" algn="bl" rotWithShape="0">
+            <a:outerShdw sx="100000" sy="100000" kx="0" ky="0" algn="bl" rotWithShape="0" blurRad="114300" dist="38100" dir="8100000">
               <a:srgbClr val="17151F">
                 <a:alpha val="12000"/>
               </a:srgbClr>
             </a:outerShdw>
           </a:effectLst>
         </p:spPr>
-        <p:txBody>
-          <a:bodyPr/>
-          <a:lstStyle/>
-          <a:p>
-            <a:endParaRPr lang="en-US"/>
-          </a:p>
-        </p:txBody>
       </p:sp>
       <p:sp>
         <p:nvSpPr>
@@ -7781,7 +7751,7 @@
           <a:bodyPr wrap="square" lIns="0" tIns="0" rIns="0" bIns="0" rtlCol="0" anchor="ctr"/>
           <a:lstStyle/>
           <a:p>
-            <a:pPr marL="0" indent="0">
+            <a:pPr indent="0" marL="0">
               <a:buNone/>
             </a:pPr>
             <a:r>
@@ -7793,7 +7763,7 @@
                 <a:ea typeface="Calibri" pitchFamily="34" charset="-122"/>
                 <a:cs typeface="Calibri" pitchFamily="34" charset="-120"/>
               </a:rPr>
-              <a:t>T-0009 Booking email</a:t>
+              <a:t>T-0009 Docs</a:t>
             </a:r>
             <a:endParaRPr lang="en-US" sz="1350" dirty="0"/>
           </a:p>
@@ -7820,11 +7790,11 @@
           <a:bodyPr wrap="square" lIns="0" tIns="0" rIns="0" bIns="0" rtlCol="0" anchor="ctr"/>
           <a:lstStyle/>
           <a:p>
-            <a:pPr marL="0" indent="0">
-              <a:buNone/>
-            </a:pPr>
-            <a:r>
-              <a:rPr lang="en-US" sz="1200" b="1" kern="0" spc="100" dirty="0">
+            <a:pPr indent="0" marL="0">
+              <a:buNone/>
+            </a:pPr>
+            <a:r>
+              <a:rPr lang="en-US" sz="1200" b="1" spc="100" kern="0" dirty="0">
                 <a:solidFill>
                   <a:srgbClr val="6B6770"/>
                 </a:solidFill>
@@ -7860,13 +7830,6 @@
             <a:prstDash val="solid"/>
           </a:ln>
         </p:spPr>
-        <p:txBody>
-          <a:bodyPr/>
-          <a:lstStyle/>
-          <a:p>
-            <a:endParaRPr lang="en-US"/>
-          </a:p>
-        </p:txBody>
       </p:sp>
       <p:sp>
         <p:nvSpPr>
@@ -7894,20 +7857,13 @@
             <a:prstDash val="solid"/>
           </a:ln>
           <a:effectLst>
-            <a:outerShdw blurRad="114300" dist="38100" dir="8100000" algn="bl" rotWithShape="0">
+            <a:outerShdw sx="100000" sy="100000" kx="0" ky="0" algn="bl" rotWithShape="0" blurRad="114300" dist="38100" dir="8100000">
               <a:srgbClr val="17151F">
                 <a:alpha val="12000"/>
               </a:srgbClr>
             </a:outerShdw>
           </a:effectLst>
         </p:spPr>
-        <p:txBody>
-          <a:bodyPr/>
-          <a:lstStyle/>
-          <a:p>
-            <a:endParaRPr lang="en-US"/>
-          </a:p>
-        </p:txBody>
       </p:sp>
       <p:sp>
         <p:nvSpPr>
@@ -7930,7 +7886,7 @@
           <a:bodyPr wrap="square" lIns="0" tIns="0" rIns="0" bIns="0" rtlCol="0" anchor="ctr"/>
           <a:lstStyle/>
           <a:p>
-            <a:pPr marL="0" indent="0">
+            <a:pPr indent="0" marL="0">
               <a:buNone/>
             </a:pPr>
             <a:r>
@@ -7974,20 +7930,13 @@
             <a:prstDash val="solid"/>
           </a:ln>
           <a:effectLst>
-            <a:outerShdw blurRad="114300" dist="38100" dir="8100000" algn="bl" rotWithShape="0">
+            <a:outerShdw sx="100000" sy="100000" kx="0" ky="0" algn="bl" rotWithShape="0" blurRad="114300" dist="38100" dir="8100000">
               <a:srgbClr val="17151F">
                 <a:alpha val="12000"/>
               </a:srgbClr>
             </a:outerShdw>
           </a:effectLst>
         </p:spPr>
-        <p:txBody>
-          <a:bodyPr/>
-          <a:lstStyle/>
-          <a:p>
-            <a:endParaRPr lang="en-US"/>
-          </a:p>
-        </p:txBody>
       </p:sp>
       <p:sp>
         <p:nvSpPr>
@@ -8010,7 +7959,7 @@
           <a:bodyPr wrap="square" lIns="0" tIns="0" rIns="0" bIns="0" rtlCol="0" anchor="ctr"/>
           <a:lstStyle/>
           <a:p>
-            <a:pPr marL="0" indent="0">
+            <a:pPr indent="0" marL="0">
               <a:buNone/>
             </a:pPr>
             <a:r>
@@ -8022,7 +7971,7 @@
                 <a:ea typeface="Calibri" pitchFamily="34" charset="-122"/>
                 <a:cs typeface="Calibri" pitchFamily="34" charset="-120"/>
               </a:rPr>
-              <a:t>T-0003 Identity</a:t>
+              <a:t>T-0003 Spec</a:t>
             </a:r>
             <a:endParaRPr lang="en-US" sz="1350" dirty="0"/>
           </a:p>
@@ -8054,20 +8003,13 @@
             <a:prstDash val="solid"/>
           </a:ln>
           <a:effectLst>
-            <a:outerShdw blurRad="114300" dist="38100" dir="8100000" algn="bl" rotWithShape="0">
+            <a:outerShdw sx="100000" sy="100000" kx="0" ky="0" algn="bl" rotWithShape="0" blurRad="114300" dist="38100" dir="8100000">
               <a:srgbClr val="17151F">
                 <a:alpha val="12000"/>
               </a:srgbClr>
             </a:outerShdw>
           </a:effectLst>
         </p:spPr>
-        <p:txBody>
-          <a:bodyPr/>
-          <a:lstStyle/>
-          <a:p>
-            <a:endParaRPr lang="en-US"/>
-          </a:p>
-        </p:txBody>
       </p:sp>
       <p:sp>
         <p:nvSpPr>
@@ -8090,7 +8032,7 @@
           <a:bodyPr wrap="square" lIns="0" tIns="0" rIns="0" bIns="0" rtlCol="0" anchor="ctr"/>
           <a:lstStyle/>
           <a:p>
-            <a:pPr marL="0" indent="0">
+            <a:pPr indent="0" marL="0">
               <a:buNone/>
             </a:pPr>
             <a:r>
@@ -8102,7 +8044,7 @@
                 <a:ea typeface="Calibri" pitchFamily="34" charset="-122"/>
                 <a:cs typeface="Calibri" pitchFamily="34" charset="-120"/>
               </a:rPr>
-              <a:t>T-0004 Copy</a:t>
+              <a:t>T-0004 Todo</a:t>
             </a:r>
             <a:endParaRPr lang="en-US" sz="1350" dirty="0"/>
           </a:p>
@@ -8129,7 +8071,7 @@
           <a:bodyPr wrap="square" lIns="0" tIns="0" rIns="0" bIns="0" rtlCol="0" anchor="ctr"/>
           <a:lstStyle/>
           <a:p>
-            <a:pPr marL="0" indent="0">
+            <a:pPr indent="0" marL="0">
               <a:buNone/>
             </a:pPr>
             <a:r>
@@ -8143,6 +8085,9 @@
               </a:rPr>
               <a:t>The ledger tracks everything — </a:t>
             </a:r>
+            <a:pPr indent="0" marL="0">
+              <a:buNone/>
+            </a:pPr>
             <a:r>
               <a:rPr lang="en-US" sz="1600" b="1" dirty="0">
                 <a:solidFill>
@@ -8179,7 +8124,7 @@
           <a:bodyPr wrap="square" lIns="0" tIns="0" rIns="0" bIns="0" rtlCol="0" anchor="ctr"/>
           <a:lstStyle/>
           <a:p>
-            <a:pPr marL="0" indent="0">
+            <a:pPr indent="0" marL="0">
               <a:buNone/>
             </a:pPr>
             <a:r>
@@ -8218,7 +8163,7 @@
           <a:bodyPr wrap="square" lIns="0" tIns="0" rIns="0" bIns="0" rtlCol="0" anchor="ctr"/>
           <a:lstStyle/>
           <a:p>
-            <a:pPr marL="0" indent="0" algn="r">
+            <a:pPr algn="r" indent="0" marL="0">
               <a:buNone/>
             </a:pPr>
             <a:r>
@@ -8252,7 +8197,6 @@
         <a:solidFill>
           <a:srgbClr val="FFFFFF"/>
         </a:solidFill>
-        <a:effectLst/>
       </p:bgPr>
     </p:bg>
     <p:spTree>
@@ -8290,11 +8234,11 @@
           <a:bodyPr wrap="square" lIns="0" tIns="0" rIns="0" bIns="0" rtlCol="0" anchor="ctr"/>
           <a:lstStyle/>
           <a:p>
-            <a:pPr marL="0" indent="0">
-              <a:buNone/>
-            </a:pPr>
-            <a:r>
-              <a:rPr lang="en-US" sz="1200" b="1" kern="0" spc="200" dirty="0">
+            <a:pPr indent="0" marL="0">
+              <a:buNone/>
+            </a:pPr>
+            <a:r>
+              <a:rPr lang="en-US" sz="1200" b="1" spc="200" kern="0" dirty="0">
                 <a:solidFill>
                   <a:srgbClr val="5B3DF5"/>
                 </a:solidFill>
@@ -8329,7 +8273,7 @@
           <a:bodyPr wrap="square" lIns="0" tIns="0" rIns="0" bIns="0" rtlCol="0" anchor="t"/>
           <a:lstStyle/>
           <a:p>
-            <a:pPr marL="0" indent="0">
+            <a:pPr indent="0" marL="0">
               <a:buNone/>
             </a:pPr>
             <a:r>
@@ -8368,7 +8312,7 @@
           <a:bodyPr wrap="square" lIns="0" tIns="0" rIns="0" bIns="0" rtlCol="0" anchor="ctr"/>
           <a:lstStyle/>
           <a:p>
-            <a:pPr marL="0" indent="0" algn="ctr">
+            <a:pPr algn="ctr" indent="0" marL="0">
               <a:buNone/>
             </a:pPr>
             <a:r>
@@ -8412,20 +8356,13 @@
             <a:prstDash val="solid"/>
           </a:ln>
           <a:effectLst>
-            <a:outerShdw blurRad="114300" dist="38100" dir="8100000" algn="bl" rotWithShape="0">
+            <a:outerShdw sx="100000" sy="100000" kx="0" ky="0" algn="bl" rotWithShape="0" blurRad="114300" dist="38100" dir="8100000">
               <a:srgbClr val="17151F">
                 <a:alpha val="12000"/>
               </a:srgbClr>
             </a:outerShdw>
           </a:effectLst>
         </p:spPr>
-        <p:txBody>
-          <a:bodyPr/>
-          <a:lstStyle/>
-          <a:p>
-            <a:endParaRPr lang="en-US"/>
-          </a:p>
-        </p:txBody>
       </p:sp>
       <p:sp>
         <p:nvSpPr>
@@ -8453,20 +8390,13 @@
             <a:prstDash val="solid"/>
           </a:ln>
           <a:effectLst>
-            <a:outerShdw blurRad="114300" dist="38100" dir="8100000" algn="bl" rotWithShape="0">
+            <a:outerShdw sx="100000" sy="100000" kx="0" ky="0" algn="bl" rotWithShape="0" blurRad="114300" dist="38100" dir="8100000">
               <a:srgbClr val="17151F">
                 <a:alpha val="12000"/>
               </a:srgbClr>
             </a:outerShdw>
           </a:effectLst>
         </p:spPr>
-        <p:txBody>
-          <a:bodyPr/>
-          <a:lstStyle/>
-          <a:p>
-            <a:endParaRPr lang="en-US"/>
-          </a:p>
-        </p:txBody>
       </p:sp>
       <p:sp>
         <p:nvSpPr>
@@ -8494,20 +8424,13 @@
             <a:prstDash val="solid"/>
           </a:ln>
           <a:effectLst>
-            <a:outerShdw blurRad="114300" dist="38100" dir="8100000" algn="bl" rotWithShape="0">
+            <a:outerShdw sx="100000" sy="100000" kx="0" ky="0" algn="bl" rotWithShape="0" blurRad="114300" dist="38100" dir="8100000">
               <a:srgbClr val="17151F">
                 <a:alpha val="12000"/>
               </a:srgbClr>
             </a:outerShdw>
           </a:effectLst>
         </p:spPr>
-        <p:txBody>
-          <a:bodyPr/>
-          <a:lstStyle/>
-          <a:p>
-            <a:endParaRPr lang="en-US"/>
-          </a:p>
-        </p:txBody>
       </p:sp>
       <p:sp>
         <p:nvSpPr>
@@ -8530,7 +8453,7 @@
           <a:bodyPr wrap="square" lIns="0" tIns="0" rIns="0" bIns="0" rtlCol="0" anchor="ctr"/>
           <a:lstStyle/>
           <a:p>
-            <a:pPr marL="0" indent="0" algn="ctr">
+            <a:pPr algn="ctr" indent="0" marL="0">
               <a:buNone/>
             </a:pPr>
             <a:r>
@@ -8569,7 +8492,7 @@
           <a:bodyPr wrap="square" lIns="0" tIns="0" rIns="0" bIns="0" rtlCol="0" anchor="ctr"/>
           <a:lstStyle/>
           <a:p>
-            <a:pPr marL="0" indent="0" algn="ctr">
+            <a:pPr algn="ctr" indent="0" marL="0">
               <a:buNone/>
             </a:pPr>
             <a:r>
@@ -8608,7 +8531,7 @@
           <a:bodyPr wrap="square" lIns="0" tIns="0" rIns="0" bIns="0" rtlCol="0" anchor="ctr"/>
           <a:lstStyle/>
           <a:p>
-            <a:pPr marL="0" indent="0" algn="ctr">
+            <a:pPr algn="ctr" indent="0" marL="0">
               <a:buNone/>
             </a:pPr>
             <a:r>
@@ -8652,20 +8575,13 @@
             <a:prstDash val="solid"/>
           </a:ln>
           <a:effectLst>
-            <a:outerShdw blurRad="114300" dist="38100" dir="8100000" algn="bl" rotWithShape="0">
+            <a:outerShdw sx="100000" sy="100000" kx="0" ky="0" algn="bl" rotWithShape="0" blurRad="114300" dist="38100" dir="8100000">
               <a:srgbClr val="17151F">
                 <a:alpha val="12000"/>
               </a:srgbClr>
             </a:outerShdw>
           </a:effectLst>
         </p:spPr>
-        <p:txBody>
-          <a:bodyPr/>
-          <a:lstStyle/>
-          <a:p>
-            <a:endParaRPr lang="en-US"/>
-          </a:p>
-        </p:txBody>
       </p:sp>
       <p:sp>
         <p:nvSpPr>
@@ -8688,7 +8604,7 @@
           <a:bodyPr wrap="square" lIns="0" tIns="0" rIns="0" bIns="0" rtlCol="0" anchor="ctr"/>
           <a:lstStyle/>
           <a:p>
-            <a:pPr marL="0" indent="0" algn="ctr">
+            <a:pPr algn="ctr" indent="0" marL="0">
               <a:buNone/>
             </a:pPr>
             <a:r>
@@ -8727,7 +8643,7 @@
           <a:bodyPr wrap="square" lIns="0" tIns="0" rIns="0" bIns="0" rtlCol="0" anchor="ctr"/>
           <a:lstStyle/>
           <a:p>
-            <a:pPr marL="0" indent="0" algn="ctr">
+            <a:pPr algn="ctr" indent="0" marL="0">
               <a:buNone/>
             </a:pPr>
             <a:r>
@@ -8766,7 +8682,7 @@
           <a:bodyPr wrap="square" lIns="0" tIns="0" rIns="0" bIns="0" rtlCol="0" anchor="ctr"/>
           <a:lstStyle/>
           <a:p>
-            <a:pPr marL="0" indent="0" algn="ctr">
+            <a:pPr algn="ctr" indent="0" marL="0">
               <a:buNone/>
             </a:pPr>
             <a:r>
@@ -8810,20 +8726,13 @@
             <a:prstDash val="solid"/>
           </a:ln>
           <a:effectLst>
-            <a:outerShdw blurRad="114300" dist="38100" dir="8100000" algn="bl" rotWithShape="0">
+            <a:outerShdw sx="100000" sy="100000" kx="0" ky="0" algn="bl" rotWithShape="0" blurRad="114300" dist="38100" dir="8100000">
               <a:srgbClr val="17151F">
                 <a:alpha val="12000"/>
               </a:srgbClr>
             </a:outerShdw>
           </a:effectLst>
         </p:spPr>
-        <p:txBody>
-          <a:bodyPr/>
-          <a:lstStyle/>
-          <a:p>
-            <a:endParaRPr lang="en-US"/>
-          </a:p>
-        </p:txBody>
       </p:sp>
       <p:sp>
         <p:nvSpPr>
@@ -8846,7 +8755,7 @@
           <a:bodyPr wrap="square" lIns="0" tIns="0" rIns="0" bIns="0" rtlCol="0" anchor="ctr"/>
           <a:lstStyle/>
           <a:p>
-            <a:pPr marL="0" indent="0" algn="ctr">
+            <a:pPr algn="ctr" indent="0" marL="0">
               <a:buNone/>
             </a:pPr>
             <a:r>
@@ -8885,7 +8794,7 @@
           <a:bodyPr wrap="square" lIns="0" tIns="0" rIns="0" bIns="0" rtlCol="0" anchor="ctr"/>
           <a:lstStyle/>
           <a:p>
-            <a:pPr marL="0" indent="0" algn="ctr">
+            <a:pPr algn="ctr" indent="0" marL="0">
               <a:buNone/>
             </a:pPr>
             <a:r>
@@ -8924,7 +8833,7 @@
           <a:bodyPr wrap="square" lIns="0" tIns="0" rIns="0" bIns="0" rtlCol="0" anchor="ctr"/>
           <a:lstStyle/>
           <a:p>
-            <a:pPr marL="0" indent="0" algn="ctr">
+            <a:pPr algn="ctr" indent="0" marL="0">
               <a:buNone/>
             </a:pPr>
             <a:r>
@@ -8968,20 +8877,13 @@
             <a:prstDash val="solid"/>
           </a:ln>
           <a:effectLst>
-            <a:outerShdw blurRad="114300" dist="38100" dir="8100000" algn="bl" rotWithShape="0">
+            <a:outerShdw sx="100000" sy="100000" kx="0" ky="0" algn="bl" rotWithShape="0" blurRad="114300" dist="38100" dir="8100000">
               <a:srgbClr val="17151F">
                 <a:alpha val="12000"/>
               </a:srgbClr>
             </a:outerShdw>
           </a:effectLst>
         </p:spPr>
-        <p:txBody>
-          <a:bodyPr/>
-          <a:lstStyle/>
-          <a:p>
-            <a:endParaRPr lang="en-US"/>
-          </a:p>
-        </p:txBody>
       </p:sp>
       <p:sp>
         <p:nvSpPr>
@@ -9009,20 +8911,13 @@
             <a:prstDash val="solid"/>
           </a:ln>
           <a:effectLst>
-            <a:outerShdw blurRad="114300" dist="38100" dir="8100000" algn="bl" rotWithShape="0">
+            <a:outerShdw sx="100000" sy="100000" kx="0" ky="0" algn="bl" rotWithShape="0" blurRad="114300" dist="38100" dir="8100000">
               <a:srgbClr val="17151F">
                 <a:alpha val="12000"/>
               </a:srgbClr>
             </a:outerShdw>
           </a:effectLst>
         </p:spPr>
-        <p:txBody>
-          <a:bodyPr/>
-          <a:lstStyle/>
-          <a:p>
-            <a:endParaRPr lang="en-US"/>
-          </a:p>
-        </p:txBody>
       </p:sp>
       <p:sp>
         <p:nvSpPr>
@@ -9050,20 +8945,13 @@
             <a:prstDash val="solid"/>
           </a:ln>
           <a:effectLst>
-            <a:outerShdw blurRad="114300" dist="38100" dir="8100000" algn="bl" rotWithShape="0">
+            <a:outerShdw sx="100000" sy="100000" kx="0" ky="0" algn="bl" rotWithShape="0" blurRad="114300" dist="38100" dir="8100000">
               <a:srgbClr val="17151F">
                 <a:alpha val="12000"/>
               </a:srgbClr>
             </a:outerShdw>
           </a:effectLst>
         </p:spPr>
-        <p:txBody>
-          <a:bodyPr/>
-          <a:lstStyle/>
-          <a:p>
-            <a:endParaRPr lang="en-US"/>
-          </a:p>
-        </p:txBody>
       </p:sp>
       <p:sp>
         <p:nvSpPr>
@@ -9091,20 +8979,13 @@
             <a:prstDash val="solid"/>
           </a:ln>
           <a:effectLst>
-            <a:outerShdw blurRad="114300" dist="38100" dir="8100000" algn="bl" rotWithShape="0">
+            <a:outerShdw sx="100000" sy="100000" kx="0" ky="0" algn="bl" rotWithShape="0" blurRad="114300" dist="38100" dir="8100000">
               <a:srgbClr val="17151F">
                 <a:alpha val="12000"/>
               </a:srgbClr>
             </a:outerShdw>
           </a:effectLst>
         </p:spPr>
-        <p:txBody>
-          <a:bodyPr/>
-          <a:lstStyle/>
-          <a:p>
-            <a:endParaRPr lang="en-US"/>
-          </a:p>
-        </p:txBody>
       </p:sp>
       <p:sp>
         <p:nvSpPr>
@@ -9127,7 +9008,7 @@
           <a:bodyPr wrap="square" lIns="0" tIns="0" rIns="0" bIns="0" rtlCol="0" anchor="ctr"/>
           <a:lstStyle/>
           <a:p>
-            <a:pPr marL="0" indent="0" algn="ctr">
+            <a:pPr algn="ctr" indent="0" marL="0">
               <a:buNone/>
             </a:pPr>
             <a:r>
@@ -9166,7 +9047,7 @@
           <a:bodyPr wrap="square" lIns="0" tIns="0" rIns="0" bIns="0" rtlCol="0" anchor="ctr"/>
           <a:lstStyle/>
           <a:p>
-            <a:pPr marL="0" indent="0" algn="ctr">
+            <a:pPr algn="ctr" indent="0" marL="0">
               <a:buNone/>
             </a:pPr>
             <a:r>
@@ -9205,7 +9086,7 @@
           <a:bodyPr wrap="square" lIns="0" tIns="0" rIns="0" bIns="0" rtlCol="0" anchor="ctr"/>
           <a:lstStyle/>
           <a:p>
-            <a:pPr marL="0" indent="0" algn="ctr">
+            <a:pPr algn="ctr" indent="0" marL="0">
               <a:buNone/>
             </a:pPr>
             <a:r>
@@ -9249,20 +9130,13 @@
             <a:prstDash val="solid"/>
           </a:ln>
           <a:effectLst>
-            <a:outerShdw blurRad="114300" dist="38100" dir="8100000" algn="bl" rotWithShape="0">
+            <a:outerShdw sx="100000" sy="100000" kx="0" ky="0" algn="bl" rotWithShape="0" blurRad="114300" dist="38100" dir="8100000">
               <a:srgbClr val="17151F">
                 <a:alpha val="12000"/>
               </a:srgbClr>
             </a:outerShdw>
           </a:effectLst>
         </p:spPr>
-        <p:txBody>
-          <a:bodyPr/>
-          <a:lstStyle/>
-          <a:p>
-            <a:endParaRPr lang="en-US"/>
-          </a:p>
-        </p:txBody>
       </p:sp>
       <p:sp>
         <p:nvSpPr>
@@ -9285,7 +9159,7 @@
           <a:bodyPr wrap="square" lIns="0" tIns="0" rIns="0" bIns="0" rtlCol="0" anchor="ctr"/>
           <a:lstStyle/>
           <a:p>
-            <a:pPr marL="0" indent="0" algn="ctr">
+            <a:pPr algn="ctr" indent="0" marL="0">
               <a:buNone/>
             </a:pPr>
             <a:r>
@@ -9324,7 +9198,7 @@
           <a:bodyPr wrap="square" lIns="0" tIns="0" rIns="0" bIns="0" rtlCol="0" anchor="ctr"/>
           <a:lstStyle/>
           <a:p>
-            <a:pPr marL="0" indent="0" algn="ctr">
+            <a:pPr algn="ctr" indent="0" marL="0">
               <a:buNone/>
             </a:pPr>
             <a:r>
@@ -9338,6 +9212,9 @@
               </a:rPr>
               <a:t>Parallel where independent</a:t>
             </a:r>
+            <a:pPr algn="ctr" indent="0" marL="0">
+              <a:buNone/>
+            </a:pPr>
             <a:r>
               <a:rPr lang="en-US" sz="1700" dirty="0">
                 <a:solidFill>
@@ -9374,7 +9251,7 @@
           <a:bodyPr wrap="square" lIns="0" tIns="0" rIns="0" bIns="0" rtlCol="0" anchor="ctr"/>
           <a:lstStyle/>
           <a:p>
-            <a:pPr marL="0" indent="0">
+            <a:pPr indent="0" marL="0">
               <a:buNone/>
             </a:pPr>
             <a:r>
@@ -9413,7 +9290,7 @@
           <a:bodyPr wrap="square" lIns="0" tIns="0" rIns="0" bIns="0" rtlCol="0" anchor="ctr"/>
           <a:lstStyle/>
           <a:p>
-            <a:pPr marL="0" indent="0" algn="r">
+            <a:pPr algn="r" indent="0" marL="0">
               <a:buNone/>
             </a:pPr>
             <a:r>
@@ -9447,7 +9324,6 @@
         <a:solidFill>
           <a:srgbClr val="FFFFFF"/>
         </a:solidFill>
-        <a:effectLst/>
       </p:bgPr>
     </p:bg>
     <p:spTree>
@@ -9485,11 +9361,11 @@
           <a:bodyPr wrap="square" lIns="0" tIns="0" rIns="0" bIns="0" rtlCol="0" anchor="ctr"/>
           <a:lstStyle/>
           <a:p>
-            <a:pPr marL="0" indent="0">
-              <a:buNone/>
-            </a:pPr>
-            <a:r>
-              <a:rPr lang="en-US" sz="1200" b="1" kern="0" spc="200" dirty="0">
+            <a:pPr indent="0" marL="0">
+              <a:buNone/>
+            </a:pPr>
+            <a:r>
+              <a:rPr lang="en-US" sz="1200" b="1" spc="200" kern="0" dirty="0">
                 <a:solidFill>
                   <a:srgbClr val="5B3DF5"/>
                 </a:solidFill>
@@ -9524,7 +9400,7 @@
           <a:bodyPr wrap="square" lIns="0" tIns="0" rIns="0" bIns="0" rtlCol="0" anchor="t"/>
           <a:lstStyle/>
           <a:p>
-            <a:pPr marL="0" indent="0">
+            <a:pPr indent="0" marL="0">
               <a:buNone/>
             </a:pPr>
             <a:r>
@@ -9568,20 +9444,13 @@
             <a:prstDash val="solid"/>
           </a:ln>
           <a:effectLst>
-            <a:outerShdw blurRad="114300" dist="38100" dir="8100000" algn="bl" rotWithShape="0">
+            <a:outerShdw sx="100000" sy="100000" kx="0" ky="0" algn="bl" rotWithShape="0" blurRad="114300" dist="38100" dir="8100000">
               <a:srgbClr val="17151F">
                 <a:alpha val="12000"/>
               </a:srgbClr>
             </a:outerShdw>
           </a:effectLst>
         </p:spPr>
-        <p:txBody>
-          <a:bodyPr/>
-          <a:lstStyle/>
-          <a:p>
-            <a:endParaRPr lang="en-US"/>
-          </a:p>
-        </p:txBody>
       </p:sp>
       <p:sp>
         <p:nvSpPr>
@@ -9602,13 +9471,6 @@
           </a:solidFill>
           <a:ln/>
         </p:spPr>
-        <p:txBody>
-          <a:bodyPr/>
-          <a:lstStyle/>
-          <a:p>
-            <a:endParaRPr lang="en-US"/>
-          </a:p>
-        </p:txBody>
       </p:sp>
       <p:sp>
         <p:nvSpPr>
@@ -9631,7 +9493,7 @@
           <a:bodyPr wrap="square" lIns="0" tIns="0" rIns="0" bIns="0" rtlCol="0" anchor="ctr"/>
           <a:lstStyle/>
           <a:p>
-            <a:pPr marL="0" indent="0">
+            <a:pPr indent="0" marL="0">
               <a:buNone/>
             </a:pPr>
             <a:r>
@@ -9670,7 +9532,7 @@
           <a:bodyPr wrap="square" lIns="0" tIns="0" rIns="0" bIns="0" rtlCol="0" anchor="ctr"/>
           <a:lstStyle/>
           <a:p>
-            <a:pPr marL="0" indent="0">
+            <a:pPr indent="0" marL="0">
               <a:lnSpc>
                 <a:spcPct val="105000"/>
               </a:lnSpc>
@@ -9712,7 +9574,7 @@
           <a:bodyPr wrap="square" lIns="0" tIns="0" rIns="0" bIns="0" rtlCol="0" anchor="ctr"/>
           <a:lstStyle/>
           <a:p>
-            <a:pPr marL="0" indent="0">
+            <a:pPr indent="0" marL="0">
               <a:buNone/>
             </a:pPr>
             <a:r>
@@ -9756,20 +9618,13 @@
             <a:prstDash val="solid"/>
           </a:ln>
           <a:effectLst>
-            <a:outerShdw blurRad="114300" dist="38100" dir="8100000" algn="bl" rotWithShape="0">
+            <a:outerShdw sx="100000" sy="100000" kx="0" ky="0" algn="bl" rotWithShape="0" blurRad="114300" dist="38100" dir="8100000">
               <a:srgbClr val="17151F">
                 <a:alpha val="12000"/>
               </a:srgbClr>
             </a:outerShdw>
           </a:effectLst>
         </p:spPr>
-        <p:txBody>
-          <a:bodyPr/>
-          <a:lstStyle/>
-          <a:p>
-            <a:endParaRPr lang="en-US"/>
-          </a:p>
-        </p:txBody>
       </p:sp>
       <p:sp>
         <p:nvSpPr>
@@ -9790,13 +9645,6 @@
           </a:solidFill>
           <a:ln/>
         </p:spPr>
-        <p:txBody>
-          <a:bodyPr/>
-          <a:lstStyle/>
-          <a:p>
-            <a:endParaRPr lang="en-US"/>
-          </a:p>
-        </p:txBody>
       </p:sp>
       <p:sp>
         <p:nvSpPr>
@@ -9819,7 +9667,7 @@
           <a:bodyPr wrap="square" lIns="0" tIns="0" rIns="0" bIns="0" rtlCol="0" anchor="ctr"/>
           <a:lstStyle/>
           <a:p>
-            <a:pPr marL="0" indent="0">
+            <a:pPr indent="0" marL="0">
               <a:buNone/>
             </a:pPr>
             <a:r>
@@ -9858,7 +9706,7 @@
           <a:bodyPr wrap="square" lIns="0" tIns="0" rIns="0" bIns="0" rtlCol="0" anchor="ctr"/>
           <a:lstStyle/>
           <a:p>
-            <a:pPr marL="0" indent="0">
+            <a:pPr indent="0" marL="0">
               <a:lnSpc>
                 <a:spcPct val="105000"/>
               </a:lnSpc>
@@ -9900,7 +9748,7 @@
           <a:bodyPr wrap="square" lIns="0" tIns="0" rIns="0" bIns="0" rtlCol="0" anchor="ctr"/>
           <a:lstStyle/>
           <a:p>
-            <a:pPr marL="0" indent="0">
+            <a:pPr indent="0" marL="0">
               <a:buNone/>
             </a:pPr>
             <a:r>
@@ -9944,20 +9792,13 @@
             <a:prstDash val="solid"/>
           </a:ln>
           <a:effectLst>
-            <a:outerShdw blurRad="114300" dist="38100" dir="8100000" algn="bl" rotWithShape="0">
+            <a:outerShdw sx="100000" sy="100000" kx="0" ky="0" algn="bl" rotWithShape="0" blurRad="114300" dist="38100" dir="8100000">
               <a:srgbClr val="17151F">
                 <a:alpha val="12000"/>
               </a:srgbClr>
             </a:outerShdw>
           </a:effectLst>
         </p:spPr>
-        <p:txBody>
-          <a:bodyPr/>
-          <a:lstStyle/>
-          <a:p>
-            <a:endParaRPr lang="en-US"/>
-          </a:p>
-        </p:txBody>
       </p:sp>
       <p:sp>
         <p:nvSpPr>
@@ -9978,13 +9819,6 @@
           </a:solidFill>
           <a:ln/>
         </p:spPr>
-        <p:txBody>
-          <a:bodyPr/>
-          <a:lstStyle/>
-          <a:p>
-            <a:endParaRPr lang="en-US"/>
-          </a:p>
-        </p:txBody>
       </p:sp>
       <p:sp>
         <p:nvSpPr>
@@ -10007,7 +9841,7 @@
           <a:bodyPr wrap="square" lIns="0" tIns="0" rIns="0" bIns="0" rtlCol="0" anchor="ctr"/>
           <a:lstStyle/>
           <a:p>
-            <a:pPr marL="0" indent="0">
+            <a:pPr indent="0" marL="0">
               <a:buNone/>
             </a:pPr>
             <a:r>
@@ -10046,7 +9880,7 @@
           <a:bodyPr wrap="square" lIns="0" tIns="0" rIns="0" bIns="0" rtlCol="0" anchor="ctr"/>
           <a:lstStyle/>
           <a:p>
-            <a:pPr marL="0" indent="0">
+            <a:pPr indent="0" marL="0">
               <a:lnSpc>
                 <a:spcPct val="105000"/>
               </a:lnSpc>
@@ -10088,7 +9922,7 @@
           <a:bodyPr wrap="square" lIns="0" tIns="0" rIns="0" bIns="0" rtlCol="0" anchor="ctr"/>
           <a:lstStyle/>
           <a:p>
-            <a:pPr marL="0" indent="0">
+            <a:pPr indent="0" marL="0">
               <a:buNone/>
             </a:pPr>
             <a:r>
@@ -10132,20 +9966,13 @@
             <a:prstDash val="solid"/>
           </a:ln>
           <a:effectLst>
-            <a:outerShdw blurRad="114300" dist="38100" dir="8100000" algn="bl" rotWithShape="0">
+            <a:outerShdw sx="100000" sy="100000" kx="0" ky="0" algn="bl" rotWithShape="0" blurRad="114300" dist="38100" dir="8100000">
               <a:srgbClr val="17151F">
                 <a:alpha val="12000"/>
               </a:srgbClr>
             </a:outerShdw>
           </a:effectLst>
         </p:spPr>
-        <p:txBody>
-          <a:bodyPr/>
-          <a:lstStyle/>
-          <a:p>
-            <a:endParaRPr lang="en-US"/>
-          </a:p>
-        </p:txBody>
       </p:sp>
       <p:sp>
         <p:nvSpPr>
@@ -10166,13 +9993,6 @@
           </a:solidFill>
           <a:ln/>
         </p:spPr>
-        <p:txBody>
-          <a:bodyPr/>
-          <a:lstStyle/>
-          <a:p>
-            <a:endParaRPr lang="en-US"/>
-          </a:p>
-        </p:txBody>
       </p:sp>
       <p:sp>
         <p:nvSpPr>
@@ -10195,7 +10015,7 @@
           <a:bodyPr wrap="square" lIns="0" tIns="0" rIns="0" bIns="0" rtlCol="0" anchor="ctr"/>
           <a:lstStyle/>
           <a:p>
-            <a:pPr marL="0" indent="0">
+            <a:pPr indent="0" marL="0">
               <a:buNone/>
             </a:pPr>
             <a:r>
@@ -10234,7 +10054,7 @@
           <a:bodyPr wrap="square" lIns="0" tIns="0" rIns="0" bIns="0" rtlCol="0" anchor="ctr"/>
           <a:lstStyle/>
           <a:p>
-            <a:pPr marL="0" indent="0">
+            <a:pPr indent="0" marL="0">
               <a:lnSpc>
                 <a:spcPct val="105000"/>
               </a:lnSpc>
@@ -10276,7 +10096,7 @@
           <a:bodyPr wrap="square" lIns="0" tIns="0" rIns="0" bIns="0" rtlCol="0" anchor="ctr"/>
           <a:lstStyle/>
           <a:p>
-            <a:pPr marL="0" indent="0">
+            <a:pPr indent="0" marL="0">
               <a:buNone/>
             </a:pPr>
             <a:r>
@@ -10315,7 +10135,7 @@
           <a:bodyPr wrap="square" lIns="0" tIns="0" rIns="0" bIns="0" rtlCol="0" anchor="ctr"/>
           <a:lstStyle/>
           <a:p>
-            <a:pPr marL="0" indent="0">
+            <a:pPr indent="0" marL="0">
               <a:buNone/>
             </a:pPr>
             <a:r>
@@ -10354,7 +10174,7 @@
           <a:bodyPr wrap="square" lIns="0" tIns="0" rIns="0" bIns="0" rtlCol="0" anchor="ctr"/>
           <a:lstStyle/>
           <a:p>
-            <a:pPr marL="0" indent="0" algn="r">
+            <a:pPr algn="r" indent="0" marL="0">
               <a:buNone/>
             </a:pPr>
             <a:r>
@@ -10388,7 +10208,6 @@
         <a:solidFill>
           <a:srgbClr val="FFFFFF"/>
         </a:solidFill>
-        <a:effectLst/>
       </p:bgPr>
     </p:bg>
     <p:spTree>
@@ -10426,11 +10245,11 @@
           <a:bodyPr wrap="square" lIns="0" tIns="0" rIns="0" bIns="0" rtlCol="0" anchor="ctr"/>
           <a:lstStyle/>
           <a:p>
-            <a:pPr marL="0" indent="0">
-              <a:buNone/>
-            </a:pPr>
-            <a:r>
-              <a:rPr lang="en-US" sz="1200" b="1" kern="0" spc="200" dirty="0">
+            <a:pPr indent="0" marL="0">
+              <a:buNone/>
+            </a:pPr>
+            <a:r>
+              <a:rPr lang="en-US" sz="1200" b="1" spc="200" kern="0" dirty="0">
                 <a:solidFill>
                   <a:srgbClr val="5B3DF5"/>
                 </a:solidFill>
@@ -10465,7 +10284,7 @@
           <a:bodyPr wrap="square" lIns="0" tIns="0" rIns="0" bIns="0" rtlCol="0" anchor="t"/>
           <a:lstStyle/>
           <a:p>
-            <a:pPr marL="0" indent="0">
+            <a:pPr indent="0" marL="0">
               <a:buNone/>
             </a:pPr>
             <a:r>
@@ -10504,7 +10323,7 @@
           <a:bodyPr wrap="square" lIns="0" tIns="0" rIns="0" bIns="0" rtlCol="0" anchor="ctr"/>
           <a:lstStyle/>
           <a:p>
-            <a:pPr marL="0" indent="0">
+            <a:pPr indent="0" marL="0">
               <a:buNone/>
             </a:pPr>
             <a:r>
@@ -10548,13 +10367,6 @@
             <a:prstDash val="solid"/>
           </a:ln>
         </p:spPr>
-        <p:txBody>
-          <a:bodyPr/>
-          <a:lstStyle/>
-          <a:p>
-            <a:endParaRPr lang="en-US"/>
-          </a:p>
-        </p:txBody>
       </p:sp>
       <p:sp>
         <p:nvSpPr>
@@ -10582,13 +10394,6 @@
             <a:prstDash val="solid"/>
           </a:ln>
         </p:spPr>
-        <p:txBody>
-          <a:bodyPr/>
-          <a:lstStyle/>
-          <a:p>
-            <a:endParaRPr lang="en-US"/>
-          </a:p>
-        </p:txBody>
       </p:sp>
       <p:sp>
         <p:nvSpPr>
@@ -10611,7 +10416,7 @@
           <a:bodyPr wrap="square" lIns="0" tIns="0" rIns="0" bIns="0" rtlCol="0" anchor="ctr"/>
           <a:lstStyle/>
           <a:p>
-            <a:pPr marL="0" indent="0">
+            <a:pPr indent="0" marL="0">
               <a:buNone/>
             </a:pPr>
             <a:r>
@@ -10650,7 +10455,7 @@
           <a:bodyPr wrap="square" lIns="0" tIns="0" rIns="0" bIns="0" rtlCol="0" anchor="ctr"/>
           <a:lstStyle/>
           <a:p>
-            <a:pPr marL="0" indent="0">
+            <a:pPr indent="0" marL="0">
               <a:buNone/>
             </a:pPr>
             <a:r>
@@ -10694,13 +10499,6 @@
             <a:prstDash val="solid"/>
           </a:ln>
         </p:spPr>
-        <p:txBody>
-          <a:bodyPr/>
-          <a:lstStyle/>
-          <a:p>
-            <a:endParaRPr lang="en-US"/>
-          </a:p>
-        </p:txBody>
       </p:sp>
       <p:sp>
         <p:nvSpPr>
@@ -10728,13 +10526,6 @@
             <a:prstDash val="solid"/>
           </a:ln>
         </p:spPr>
-        <p:txBody>
-          <a:bodyPr/>
-          <a:lstStyle/>
-          <a:p>
-            <a:endParaRPr lang="en-US"/>
-          </a:p>
-        </p:txBody>
       </p:sp>
       <p:sp>
         <p:nvSpPr>
@@ -10757,7 +10548,7 @@
           <a:bodyPr wrap="square" lIns="0" tIns="0" rIns="0" bIns="0" rtlCol="0" anchor="ctr"/>
           <a:lstStyle/>
           <a:p>
-            <a:pPr marL="0" indent="0">
+            <a:pPr indent="0" marL="0">
               <a:buNone/>
             </a:pPr>
             <a:r>
@@ -10796,7 +10587,7 @@
           <a:bodyPr wrap="square" lIns="0" tIns="0" rIns="0" bIns="0" rtlCol="0" anchor="ctr"/>
           <a:lstStyle/>
           <a:p>
-            <a:pPr marL="0" indent="0">
+            <a:pPr indent="0" marL="0">
               <a:lnSpc>
                 <a:spcPct val="110000"/>
               </a:lnSpc>
@@ -10813,6 +10604,12 @@
               </a:rPr>
               <a:t>Give the right context at the right step. </a:t>
             </a:r>
+            <a:pPr indent="0" marL="0">
+              <a:lnSpc>
+                <a:spcPct val="110000"/>
+              </a:lnSpc>
+              <a:buNone/>
+            </a:pPr>
             <a:r>
               <a:rPr lang="en-US" sz="1700" dirty="0">
                 <a:solidFill>
@@ -10849,7 +10646,7 @@
           <a:bodyPr wrap="square" lIns="0" tIns="0" rIns="0" bIns="0" rtlCol="0" anchor="ctr"/>
           <a:lstStyle/>
           <a:p>
-            <a:pPr marL="0" indent="0">
+            <a:pPr indent="0" marL="0">
               <a:buNone/>
             </a:pPr>
             <a:r>
@@ -10888,7 +10685,7 @@
           <a:bodyPr wrap="square" lIns="0" tIns="0" rIns="0" bIns="0" rtlCol="0" anchor="ctr"/>
           <a:lstStyle/>
           <a:p>
-            <a:pPr marL="0" indent="0" algn="r">
+            <a:pPr algn="r" indent="0" marL="0">
               <a:buNone/>
             </a:pPr>
             <a:r>
@@ -10922,7 +10719,6 @@
         <a:solidFill>
           <a:srgbClr val="FFFFFF"/>
         </a:solidFill>
-        <a:effectLst/>
       </p:bgPr>
     </p:bg>
     <p:spTree>
@@ -10960,11 +10756,11 @@
           <a:bodyPr wrap="square" lIns="0" tIns="0" rIns="0" bIns="0" rtlCol="0" anchor="ctr"/>
           <a:lstStyle/>
           <a:p>
-            <a:pPr marL="0" indent="0">
-              <a:buNone/>
-            </a:pPr>
-            <a:r>
-              <a:rPr lang="en-US" sz="1200" b="1" kern="0" spc="200" dirty="0">
+            <a:pPr indent="0" marL="0">
+              <a:buNone/>
+            </a:pPr>
+            <a:r>
+              <a:rPr lang="en-US" sz="1200" b="1" spc="200" kern="0" dirty="0">
                 <a:solidFill>
                   <a:srgbClr val="5B3DF5"/>
                 </a:solidFill>
@@ -10999,7 +10795,7 @@
           <a:bodyPr wrap="square" lIns="0" tIns="0" rIns="0" bIns="0" rtlCol="0" anchor="t"/>
           <a:lstStyle/>
           <a:p>
-            <a:pPr marL="0" indent="0">
+            <a:pPr indent="0" marL="0">
               <a:buNone/>
             </a:pPr>
             <a:r>
@@ -11043,20 +10839,13 @@
             <a:prstDash val="solid"/>
           </a:ln>
           <a:effectLst>
-            <a:outerShdw blurRad="114300" dist="38100" dir="8100000" algn="bl" rotWithShape="0">
+            <a:outerShdw sx="100000" sy="100000" kx="0" ky="0" algn="bl" rotWithShape="0" blurRad="114300" dist="38100" dir="8100000">
               <a:srgbClr val="17151F">
                 <a:alpha val="12000"/>
               </a:srgbClr>
             </a:outerShdw>
           </a:effectLst>
         </p:spPr>
-        <p:txBody>
-          <a:bodyPr/>
-          <a:lstStyle/>
-          <a:p>
-            <a:endParaRPr lang="en-US"/>
-          </a:p>
-        </p:txBody>
       </p:sp>
       <p:sp>
         <p:nvSpPr>
@@ -11077,13 +10866,6 @@
           </a:solidFill>
           <a:ln/>
         </p:spPr>
-        <p:txBody>
-          <a:bodyPr/>
-          <a:lstStyle/>
-          <a:p>
-            <a:endParaRPr lang="en-US"/>
-          </a:p>
-        </p:txBody>
       </p:sp>
       <p:sp>
         <p:nvSpPr>
@@ -11106,7 +10888,7 @@
           <a:bodyPr wrap="square" lIns="0" tIns="0" rIns="0" bIns="0" rtlCol="0" anchor="ctr"/>
           <a:lstStyle/>
           <a:p>
-            <a:pPr marL="0" indent="0">
+            <a:pPr indent="0" marL="0">
               <a:buNone/>
             </a:pPr>
             <a:r>
@@ -11145,7 +10927,7 @@
           <a:bodyPr wrap="square" lIns="0" tIns="0" rIns="0" bIns="0" rtlCol="0" anchor="t"/>
           <a:lstStyle/>
           <a:p>
-            <a:pPr marL="0" indent="0">
+            <a:pPr indent="0" marL="0">
               <a:lnSpc>
                 <a:spcPct val="115000"/>
               </a:lnSpc>
@@ -11192,20 +10974,13 @@
             <a:prstDash val="solid"/>
           </a:ln>
           <a:effectLst>
-            <a:outerShdw blurRad="114300" dist="38100" dir="8100000" algn="bl" rotWithShape="0">
+            <a:outerShdw sx="100000" sy="100000" kx="0" ky="0" algn="bl" rotWithShape="0" blurRad="114300" dist="38100" dir="8100000">
               <a:srgbClr val="17151F">
                 <a:alpha val="12000"/>
               </a:srgbClr>
             </a:outerShdw>
           </a:effectLst>
         </p:spPr>
-        <p:txBody>
-          <a:bodyPr/>
-          <a:lstStyle/>
-          <a:p>
-            <a:endParaRPr lang="en-US"/>
-          </a:p>
-        </p:txBody>
       </p:sp>
       <p:sp>
         <p:nvSpPr>
@@ -11226,13 +11001,6 @@
           </a:solidFill>
           <a:ln/>
         </p:spPr>
-        <p:txBody>
-          <a:bodyPr/>
-          <a:lstStyle/>
-          <a:p>
-            <a:endParaRPr lang="en-US"/>
-          </a:p>
-        </p:txBody>
       </p:sp>
       <p:sp>
         <p:nvSpPr>
@@ -11255,7 +11023,7 @@
           <a:bodyPr wrap="square" lIns="0" tIns="0" rIns="0" bIns="0" rtlCol="0" anchor="ctr"/>
           <a:lstStyle/>
           <a:p>
-            <a:pPr marL="0" indent="0">
+            <a:pPr indent="0" marL="0">
               <a:buNone/>
             </a:pPr>
             <a:r>
@@ -11294,7 +11062,7 @@
           <a:bodyPr wrap="square" lIns="0" tIns="0" rIns="0" bIns="0" rtlCol="0" anchor="t"/>
           <a:lstStyle/>
           <a:p>
-            <a:pPr marL="0" indent="0">
+            <a:pPr indent="0" marL="0">
               <a:lnSpc>
                 <a:spcPct val="115000"/>
               </a:lnSpc>
@@ -11341,20 +11109,13 @@
             <a:prstDash val="solid"/>
           </a:ln>
           <a:effectLst>
-            <a:outerShdw blurRad="114300" dist="38100" dir="8100000" algn="bl" rotWithShape="0">
+            <a:outerShdw sx="100000" sy="100000" kx="0" ky="0" algn="bl" rotWithShape="0" blurRad="114300" dist="38100" dir="8100000">
               <a:srgbClr val="17151F">
                 <a:alpha val="12000"/>
               </a:srgbClr>
             </a:outerShdw>
           </a:effectLst>
         </p:spPr>
-        <p:txBody>
-          <a:bodyPr/>
-          <a:lstStyle/>
-          <a:p>
-            <a:endParaRPr lang="en-US"/>
-          </a:p>
-        </p:txBody>
       </p:sp>
       <p:sp>
         <p:nvSpPr>
@@ -11375,13 +11136,6 @@
           </a:solidFill>
           <a:ln/>
         </p:spPr>
-        <p:txBody>
-          <a:bodyPr/>
-          <a:lstStyle/>
-          <a:p>
-            <a:endParaRPr lang="en-US"/>
-          </a:p>
-        </p:txBody>
       </p:sp>
       <p:sp>
         <p:nvSpPr>
@@ -11404,7 +11158,7 @@
           <a:bodyPr wrap="square" lIns="0" tIns="0" rIns="0" bIns="0" rtlCol="0" anchor="ctr"/>
           <a:lstStyle/>
           <a:p>
-            <a:pPr marL="0" indent="0">
+            <a:pPr indent="0" marL="0">
               <a:buNone/>
             </a:pPr>
             <a:r>
@@ -11443,7 +11197,7 @@
           <a:bodyPr wrap="square" lIns="0" tIns="0" rIns="0" bIns="0" rtlCol="0" anchor="t"/>
           <a:lstStyle/>
           <a:p>
-            <a:pPr marL="0" indent="0">
+            <a:pPr indent="0" marL="0">
               <a:lnSpc>
                 <a:spcPct val="115000"/>
               </a:lnSpc>
@@ -11485,7 +11239,7 @@
           <a:bodyPr wrap="square" lIns="0" tIns="0" rIns="0" bIns="0" rtlCol="0" anchor="ctr"/>
           <a:lstStyle/>
           <a:p>
-            <a:pPr marL="0" indent="0" algn="ctr">
+            <a:pPr algn="ctr" indent="0" marL="0">
               <a:buNone/>
             </a:pPr>
             <a:r>
@@ -11524,7 +11278,7 @@
           <a:bodyPr wrap="square" lIns="0" tIns="0" rIns="0" bIns="0" rtlCol="0" anchor="ctr"/>
           <a:lstStyle/>
           <a:p>
-            <a:pPr marL="0" indent="0">
+            <a:pPr indent="0" marL="0">
               <a:buNone/>
             </a:pPr>
             <a:r>
@@ -11563,7 +11317,7 @@
           <a:bodyPr wrap="square" lIns="0" tIns="0" rIns="0" bIns="0" rtlCol="0" anchor="ctr"/>
           <a:lstStyle/>
           <a:p>
-            <a:pPr marL="0" indent="0" algn="r">
+            <a:pPr algn="r" indent="0" marL="0">
               <a:buNone/>
             </a:pPr>
             <a:r>
@@ -11882,319 +11636,4 @@
     </a:ext>
   </a:extLst>
 </a:theme>
-</file>
-
-<file path=ppt/theme/theme2.xml><?xml version="1.0" encoding="utf-8"?>
-<a:theme xmlns:a="http://schemas.openxmlformats.org/drawingml/2006/main" name="Office Theme">
-  <a:themeElements>
-    <a:clrScheme name="Office">
-      <a:dk1>
-        <a:sysClr val="windowText" lastClr="000000"/>
-      </a:dk1>
-      <a:lt1>
-        <a:sysClr val="window" lastClr="FFFFFF"/>
-      </a:lt1>
-      <a:dk2>
-        <a:srgbClr val="0E2841"/>
-      </a:dk2>
-      <a:lt2>
-        <a:srgbClr val="E8E8E8"/>
-      </a:lt2>
-      <a:accent1>
-        <a:srgbClr val="156082"/>
-      </a:accent1>
-      <a:accent2>
-        <a:srgbClr val="E97132"/>
-      </a:accent2>
-      <a:accent3>
-        <a:srgbClr val="196B24"/>
-      </a:accent3>
-      <a:accent4>
-        <a:srgbClr val="0F9ED5"/>
-      </a:accent4>
-      <a:accent5>
-        <a:srgbClr val="A02B93"/>
-      </a:accent5>
-      <a:accent6>
-        <a:srgbClr val="4EA72E"/>
-      </a:accent6>
-      <a:hlink>
-        <a:srgbClr val="467886"/>
-      </a:hlink>
-      <a:folHlink>
-        <a:srgbClr val="96607D"/>
-      </a:folHlink>
-    </a:clrScheme>
-    <a:fontScheme name="Office">
-      <a:majorFont>
-        <a:latin typeface="Aptos Display" panose="02110004020202020204"/>
-        <a:ea typeface=""/>
-        <a:cs typeface=""/>
-        <a:font script="Jpan" typeface="游ゴシック Light"/>
-        <a:font script="Hang" typeface="맑은 고딕"/>
-        <a:font script="Hans" typeface="等线 Light"/>
-        <a:font script="Hant" typeface="新細明體"/>
-        <a:font script="Arab" typeface="Times New Roman"/>
-        <a:font script="Hebr" typeface="Times New Roman"/>
-        <a:font script="Thai" typeface="Angsana New"/>
-        <a:font script="Ethi" typeface="Nyala"/>
-        <a:font script="Beng" typeface="Vrinda"/>
-        <a:font script="Gujr" typeface="Shruti"/>
-        <a:font script="Khmr" typeface="MoolBoran"/>
-        <a:font script="Knda" typeface="Tunga"/>
-        <a:font script="Guru" typeface="Raavi"/>
-        <a:font script="Cans" typeface="Euphemia"/>
-        <a:font script="Cher" typeface="Plantagenet Cherokee"/>
-        <a:font script="Yiii" typeface="Microsoft Yi Baiti"/>
-        <a:font script="Tibt" typeface="Microsoft Himalaya"/>
-        <a:font script="Thaa" typeface="MV Boli"/>
-        <a:font script="Deva" typeface="Mangal"/>
-        <a:font script="Telu" typeface="Gautami"/>
-        <a:font script="Taml" typeface="Latha"/>
-        <a:font script="Syrc" typeface="Estrangelo Edessa"/>
-        <a:font script="Orya" typeface="Kalinga"/>
-        <a:font script="Mlym" typeface="Kartika"/>
-        <a:font script="Laoo" typeface="DokChampa"/>
-        <a:font script="Sinh" typeface="Iskoola Pota"/>
-        <a:font script="Mong" typeface="Mongolian Baiti"/>
-        <a:font script="Viet" typeface="Times New Roman"/>
-        <a:font script="Uigh" typeface="Microsoft Uighur"/>
-        <a:font script="Geor" typeface="Sylfaen"/>
-        <a:font script="Armn" typeface="Arial"/>
-        <a:font script="Bugi" typeface="Leelawadee UI"/>
-        <a:font script="Bopo" typeface="Microsoft JhengHei"/>
-        <a:font script="Java" typeface="Javanese Text"/>
-        <a:font script="Lisu" typeface="Segoe UI"/>
-        <a:font script="Mymr" typeface="Myanmar Text"/>
-        <a:font script="Nkoo" typeface="Ebrima"/>
-        <a:font script="Olck" typeface="Nirmala UI"/>
-        <a:font script="Osma" typeface="Ebrima"/>
-        <a:font script="Phag" typeface="Phagspa"/>
-        <a:font script="Syrn" typeface="Estrangelo Edessa"/>
-        <a:font script="Syrj" typeface="Estrangelo Edessa"/>
-        <a:font script="Syre" typeface="Estrangelo Edessa"/>
-        <a:font script="Sora" typeface="Nirmala UI"/>
-        <a:font script="Tale" typeface="Microsoft Tai Le"/>
-        <a:font script="Talu" typeface="Microsoft New Tai Lue"/>
-        <a:font script="Tfng" typeface="Ebrima"/>
-      </a:majorFont>
-      <a:minorFont>
-        <a:latin typeface="Aptos" panose="02110004020202020204"/>
-        <a:ea typeface=""/>
-        <a:cs typeface=""/>
-        <a:font script="Jpan" typeface="游ゴシック"/>
-        <a:font script="Hang" typeface="맑은 고딕"/>
-        <a:font script="Hans" typeface="等线"/>
-        <a:font script="Hant" typeface="新細明體"/>
-        <a:font script="Arab" typeface="Arial"/>
-        <a:font script="Hebr" typeface="Arial"/>
-        <a:font script="Thai" typeface="Cordia New"/>
-        <a:font script="Ethi" typeface="Nyala"/>
-        <a:font script="Beng" typeface="Vrinda"/>
-        <a:font script="Gujr" typeface="Shruti"/>
-        <a:font script="Khmr" typeface="DaunPenh"/>
-        <a:font script="Knda" typeface="Tunga"/>
-        <a:font script="Guru" typeface="Raavi"/>
-        <a:font script="Cans" typeface="Euphemia"/>
-        <a:font script="Cher" typeface="Plantagenet Cherokee"/>
-        <a:font script="Yiii" typeface="Microsoft Yi Baiti"/>
-        <a:font script="Tibt" typeface="Microsoft Himalaya"/>
-        <a:font script="Thaa" typeface="MV Boli"/>
-        <a:font script="Deva" typeface="Mangal"/>
-        <a:font script="Telu" typeface="Gautami"/>
-        <a:font script="Taml" typeface="Latha"/>
-        <a:font script="Syrc" typeface="Estrangelo Edessa"/>
-        <a:font script="Orya" typeface="Kalinga"/>
-        <a:font script="Mlym" typeface="Kartika"/>
-        <a:font script="Laoo" typeface="DokChampa"/>
-        <a:font script="Sinh" typeface="Iskoola Pota"/>
-        <a:font script="Mong" typeface="Mongolian Baiti"/>
-        <a:font script="Viet" typeface="Arial"/>
-        <a:font script="Uigh" typeface="Microsoft Uighur"/>
-        <a:font script="Geor" typeface="Sylfaen"/>
-        <a:font script="Armn" typeface="Arial"/>
-        <a:font script="Bugi" typeface="Leelawadee UI"/>
-        <a:font script="Bopo" typeface="Microsoft JhengHei"/>
-        <a:font script="Java" typeface="Javanese Text"/>
-        <a:font script="Lisu" typeface="Segoe UI"/>
-        <a:font script="Mymr" typeface="Myanmar Text"/>
-        <a:font script="Nkoo" typeface="Ebrima"/>
-        <a:font script="Olck" typeface="Nirmala UI"/>
-        <a:font script="Osma" typeface="Ebrima"/>
-        <a:font script="Phag" typeface="Phagspa"/>
-        <a:font script="Syrn" typeface="Estrangelo Edessa"/>
-        <a:font script="Syrj" typeface="Estrangelo Edessa"/>
-        <a:font script="Syre" typeface="Estrangelo Edessa"/>
-        <a:font script="Sora" typeface="Nirmala UI"/>
-        <a:font script="Tale" typeface="Microsoft Tai Le"/>
-        <a:font script="Talu" typeface="Microsoft New Tai Lue"/>
-        <a:font script="Tfng" typeface="Ebrima"/>
-      </a:minorFont>
-    </a:fontScheme>
-    <a:fmtScheme name="Office">
-      <a:fillStyleLst>
-        <a:solidFill>
-          <a:schemeClr val="phClr"/>
-        </a:solidFill>
-        <a:gradFill rotWithShape="1">
-          <a:gsLst>
-            <a:gs pos="0">
-              <a:schemeClr val="phClr">
-                <a:lumMod val="110000"/>
-                <a:satMod val="105000"/>
-                <a:tint val="67000"/>
-              </a:schemeClr>
-            </a:gs>
-            <a:gs pos="50000">
-              <a:schemeClr val="phClr">
-                <a:lumMod val="105000"/>
-                <a:satMod val="103000"/>
-                <a:tint val="73000"/>
-              </a:schemeClr>
-            </a:gs>
-            <a:gs pos="100000">
-              <a:schemeClr val="phClr">
-                <a:lumMod val="105000"/>
-                <a:satMod val="109000"/>
-                <a:tint val="81000"/>
-              </a:schemeClr>
-            </a:gs>
-          </a:gsLst>
-          <a:lin ang="5400000" scaled="0"/>
-        </a:gradFill>
-        <a:gradFill rotWithShape="1">
-          <a:gsLst>
-            <a:gs pos="0">
-              <a:schemeClr val="phClr">
-                <a:satMod val="103000"/>
-                <a:lumMod val="102000"/>
-                <a:tint val="94000"/>
-              </a:schemeClr>
-            </a:gs>
-            <a:gs pos="50000">
-              <a:schemeClr val="phClr">
-                <a:satMod val="110000"/>
-                <a:lumMod val="100000"/>
-                <a:shade val="100000"/>
-              </a:schemeClr>
-            </a:gs>
-            <a:gs pos="100000">
-              <a:schemeClr val="phClr">
-                <a:lumMod val="99000"/>
-                <a:satMod val="120000"/>
-                <a:shade val="78000"/>
-              </a:schemeClr>
-            </a:gs>
-          </a:gsLst>
-          <a:lin ang="5400000" scaled="0"/>
-        </a:gradFill>
-      </a:fillStyleLst>
-      <a:lnStyleLst>
-        <a:ln w="12700" cap="flat" cmpd="sng" algn="ctr">
-          <a:solidFill>
-            <a:schemeClr val="phClr"/>
-          </a:solidFill>
-          <a:prstDash val="solid"/>
-          <a:miter lim="800000"/>
-        </a:ln>
-        <a:ln w="19050" cap="flat" cmpd="sng" algn="ctr">
-          <a:solidFill>
-            <a:schemeClr val="phClr"/>
-          </a:solidFill>
-          <a:prstDash val="solid"/>
-          <a:miter lim="800000"/>
-        </a:ln>
-        <a:ln w="25400" cap="flat" cmpd="sng" algn="ctr">
-          <a:solidFill>
-            <a:schemeClr val="phClr"/>
-          </a:solidFill>
-          <a:prstDash val="solid"/>
-          <a:miter lim="800000"/>
-        </a:ln>
-      </a:lnStyleLst>
-      <a:effectStyleLst>
-        <a:effectStyle>
-          <a:effectLst/>
-        </a:effectStyle>
-        <a:effectStyle>
-          <a:effectLst/>
-        </a:effectStyle>
-        <a:effectStyle>
-          <a:effectLst>
-            <a:outerShdw blurRad="57150" dist="19050" dir="5400000" algn="ctr" rotWithShape="0">
-              <a:srgbClr val="000000">
-                <a:alpha val="63000"/>
-              </a:srgbClr>
-            </a:outerShdw>
-          </a:effectLst>
-        </a:effectStyle>
-      </a:effectStyleLst>
-      <a:bgFillStyleLst>
-        <a:solidFill>
-          <a:schemeClr val="phClr"/>
-        </a:solidFill>
-        <a:solidFill>
-          <a:schemeClr val="phClr">
-            <a:tint val="95000"/>
-            <a:satMod val="170000"/>
-          </a:schemeClr>
-        </a:solidFill>
-        <a:gradFill rotWithShape="1">
-          <a:gsLst>
-            <a:gs pos="0">
-              <a:schemeClr val="phClr">
-                <a:tint val="93000"/>
-                <a:satMod val="150000"/>
-                <a:shade val="98000"/>
-                <a:lumMod val="102000"/>
-              </a:schemeClr>
-            </a:gs>
-            <a:gs pos="50000">
-              <a:schemeClr val="phClr">
-                <a:tint val="98000"/>
-                <a:satMod val="130000"/>
-                <a:shade val="90000"/>
-                <a:lumMod val="103000"/>
-              </a:schemeClr>
-            </a:gs>
-            <a:gs pos="100000">
-              <a:schemeClr val="phClr">
-                <a:shade val="63000"/>
-                <a:satMod val="120000"/>
-              </a:schemeClr>
-            </a:gs>
-          </a:gsLst>
-          <a:lin ang="5400000" scaled="0"/>
-        </a:gradFill>
-      </a:bgFillStyleLst>
-    </a:fmtScheme>
-  </a:themeElements>
-  <a:objectDefaults>
-    <a:lnDef>
-      <a:spPr/>
-      <a:bodyPr/>
-      <a:lstStyle/>
-      <a:style>
-        <a:lnRef idx="2">
-          <a:schemeClr val="accent1"/>
-        </a:lnRef>
-        <a:fillRef idx="0">
-          <a:schemeClr val="accent1"/>
-        </a:fillRef>
-        <a:effectRef idx="1">
-          <a:schemeClr val="accent1"/>
-        </a:effectRef>
-        <a:fontRef idx="minor">
-          <a:schemeClr val="tx1"/>
-        </a:fontRef>
-      </a:style>
-    </a:lnDef>
-  </a:objectDefaults>
-  <a:extraClrSchemeLst/>
-  <a:extLst>
-    <a:ext uri="{05A4C25C-085E-4340-85A3-A5531E510DB2}">
-      <thm15:themeFamily xmlns:thm15="http://schemas.microsoft.com/office/thememl/2012/main" name="Office Theme" id="{2E142A2C-CD16-42D6-873A-C26D2A0506FA}" vid="{1BDDFF52-6CD6-40A5-AB3C-68EB2F1E4D0A}"/>
-    </a:ext>
-  </a:extLst>
-</a:theme>
 </file>
</xml_diff>

<commit_message>
chore(slides): commit saved deck binary (content matches the aligned build.js)
</commit_message>
<xml_diff>
--- a/slides/founder-site-workshop.pptx
+++ b/slides/founder-site-workshop.pptx
@@ -4,6 +4,9 @@
   <p:sldMasterIdLst>
     <p:sldMasterId id="2147483648" r:id="rId1"/>
   </p:sldMasterIdLst>
+  <p:notesMasterIdLst>
+    <p:notesMasterId r:id="rId15"/>
+  </p:notesMasterIdLst>
   <p:sldIdLst>
     <p:sldId id="256" r:id="rId2"/>
     <p:sldId id="257" r:id="rId3"/>
@@ -19,9 +22,6 @@
     <p:sldId id="267" r:id="rId13"/>
     <p:sldId id="268" r:id="rId14"/>
   </p:sldIdLst>
-  <p:notesMasterIdLst>
-    <p:notesMasterId r:id="rId15"/>
-  </p:notesMasterIdLst>
   <p:sldSz cx="12192000" cy="6858000"/>
   <p:notesSz cx="6858000" cy="12192000"/>
   <p:defaultTextStyle>
@@ -116,6 +116,11 @@
       </a:defRPr>
     </a:lvl9pPr>
   </p:defaultTextStyle>
+  <p:extLst>
+    <p:ext uri="{EFAFB233-063F-42B5-8137-9DF3F51BA10A}">
+      <p15:sldGuideLst xmlns:p15="http://schemas.microsoft.com/office/powerpoint/2012/main"/>
+    </p:ext>
+  </p:extLst>
 </p:presentation>
 </file>
 
@@ -141,234 +146,10 @@
           <a:chExt cx="0" cy="0"/>
         </a:xfrm>
       </p:grpSpPr>
-      <p:sp>
-        <p:nvSpPr>
-          <p:cNvPr id="2" name="Header Placeholder 1"/>
-          <p:cNvSpPr>
-            <a:spLocks noGrp="1"/>
-          </p:cNvSpPr>
-          <p:nvPr>
-            <p:ph type="hdr" sz="quarter"/>
-          </p:nvPr>
-        </p:nvSpPr>
-        <p:spPr>
-          <a:xfrm>
-            <a:off x="0" y="0"/>
-            <a:ext cx="2971800" cy="458788"/>
-          </a:xfrm>
-          <a:prstGeom prst="rect">
-            <a:avLst/>
-          </a:prstGeom>
-        </p:spPr>
-        <p:txBody>
-          <a:bodyPr vert="horz" lIns="91440" tIns="45720" rIns="91440" bIns="45720" rtlCol="0"/>
-          <a:lstStyle>
-            <a:lvl1pPr algn="l">
-              <a:defRPr sz="1200"/>
-            </a:lvl1pPr>
-          </a:lstStyle>
-          <a:p>
-            <a:endParaRPr lang="en-US"/>
-          </a:p>
-        </p:txBody>
-      </p:sp>
-      <p:sp>
-        <p:nvSpPr>
-          <p:cNvPr id="3" name="Date Placeholder 2"/>
-          <p:cNvSpPr>
-            <a:spLocks noGrp="1"/>
-          </p:cNvSpPr>
-          <p:nvPr>
-            <p:ph type="dt" idx="1"/>
-          </p:nvPr>
-        </p:nvSpPr>
-        <p:spPr>
-          <a:xfrm>
-            <a:off x="3884613" y="0"/>
-            <a:ext cx="2971800" cy="458788"/>
-          </a:xfrm>
-          <a:prstGeom prst="rect">
-            <a:avLst/>
-          </a:prstGeom>
-        </p:spPr>
-        <p:txBody>
-          <a:bodyPr vert="horz" lIns="91440" tIns="45720" rIns="91440" bIns="45720" rtlCol="0"/>
-          <a:lstStyle>
-            <a:lvl1pPr algn="r">
-              <a:defRPr sz="1200"/>
-            </a:lvl1pPr>
-          </a:lstStyle>
-          <a:p>
-            <a:fld id="{5282F153-3F37-0F45-9E97-73ACFA13230C}" type="datetimeFigureOut">
-              <a:rPr lang="en-US"/>
-              <a:t>7/23/19</a:t>
-            </a:fld>
-            <a:endParaRPr lang="en-US"/>
-          </a:p>
-        </p:txBody>
-      </p:sp>
-      <p:sp>
-        <p:nvSpPr>
-          <p:cNvPr id="4" name="Slide Image Placeholder 3"/>
-          <p:cNvSpPr>
-            <a:spLocks noGrp="1" noRot="1" noChangeAspect="1"/>
-          </p:cNvSpPr>
-          <p:nvPr>
-            <p:ph type="sldImg" idx="2"/>
-          </p:nvPr>
-        </p:nvSpPr>
-        <p:spPr>
-          <a:xfrm>
-            <a:off x="685800" y="1143000"/>
-            <a:ext cx="5486400" cy="3086100"/>
-          </a:xfrm>
-          <a:prstGeom prst="rect">
-            <a:avLst/>
-          </a:prstGeom>
-          <a:noFill/>
-          <a:ln w="12700">
-            <a:solidFill>
-              <a:prstClr val="black"/>
-            </a:solidFill>
-          </a:ln>
-        </p:spPr>
-        <p:txBody>
-          <a:bodyPr vert="horz" lIns="91440" tIns="45720" rIns="91440" bIns="45720" rtlCol="0" anchor="ctr"/>
-          <a:lstStyle/>
-          <a:p>
-            <a:endParaRPr lang="en-US"/>
-          </a:p>
-        </p:txBody>
-      </p:sp>
-      <p:sp>
-        <p:nvSpPr>
-          <p:cNvPr id="5" name="Notes Placeholder 4"/>
-          <p:cNvSpPr>
-            <a:spLocks noGrp="1"/>
-          </p:cNvSpPr>
-          <p:nvPr>
-            <p:ph type="body" sz="quarter" idx="3"/>
-          </p:nvPr>
-        </p:nvSpPr>
-        <p:spPr>
-          <a:xfrm>
-            <a:off x="685800" y="4400550"/>
-            <a:ext cx="5486400" cy="3600450"/>
-          </a:xfrm>
-          <a:prstGeom prst="rect">
-            <a:avLst/>
-          </a:prstGeom>
-        </p:spPr>
-        <p:txBody>
-          <a:bodyPr vert="horz" lIns="91440" tIns="45720" rIns="91440" bIns="45720" rtlCol="0"/>
-          <a:lstStyle/>
-          <a:p>
-            <a:pPr lvl="0"/>
-            <a:r>
-              <a:rPr lang="en-US"/>
-              <a:t>Click to edit Master text styles</a:t>
-            </a:r>
-          </a:p>
-          <a:p>
-            <a:pPr lvl="1"/>
-            <a:r>
-              <a:rPr lang="en-US"/>
-              <a:t>Second level</a:t>
-            </a:r>
-          </a:p>
-          <a:p>
-            <a:pPr lvl="2"/>
-            <a:r>
-              <a:rPr lang="en-US"/>
-              <a:t>Third level</a:t>
-            </a:r>
-          </a:p>
-          <a:p>
-            <a:pPr lvl="3"/>
-            <a:r>
-              <a:rPr lang="en-US"/>
-              <a:t>Fourth level</a:t>
-            </a:r>
-          </a:p>
-          <a:p>
-            <a:pPr lvl="4"/>
-            <a:r>
-              <a:rPr lang="en-US"/>
-              <a:t>Fifth level</a:t>
-            </a:r>
-          </a:p>
-        </p:txBody>
-      </p:sp>
-      <p:sp>
-        <p:nvSpPr>
-          <p:cNvPr id="6" name="Footer Placeholder 5"/>
-          <p:cNvSpPr>
-            <a:spLocks noGrp="1"/>
-          </p:cNvSpPr>
-          <p:nvPr>
-            <p:ph type="ftr" sz="quarter" idx="4"/>
-          </p:nvPr>
-        </p:nvSpPr>
-        <p:spPr>
-          <a:xfrm>
-            <a:off x="0" y="8685213"/>
-            <a:ext cx="2971800" cy="458787"/>
-          </a:xfrm>
-          <a:prstGeom prst="rect">
-            <a:avLst/>
-          </a:prstGeom>
-        </p:spPr>
-        <p:txBody>
-          <a:bodyPr vert="horz" lIns="91440" tIns="45720" rIns="91440" bIns="45720" rtlCol="0" anchor="b"/>
-          <a:lstStyle>
-            <a:lvl1pPr algn="l">
-              <a:defRPr sz="1200"/>
-            </a:lvl1pPr>
-          </a:lstStyle>
-          <a:p>
-            <a:endParaRPr lang="en-US"/>
-          </a:p>
-        </p:txBody>
-      </p:sp>
-      <p:sp>
-        <p:nvSpPr>
-          <p:cNvPr id="7" name="Slide Number Placeholder 6"/>
-          <p:cNvSpPr>
-            <a:spLocks noGrp="1"/>
-          </p:cNvSpPr>
-          <p:nvPr>
-            <p:ph type="sldNum" sz="quarter" idx="5"/>
-          </p:nvPr>
-        </p:nvSpPr>
-        <p:spPr>
-          <a:xfrm>
-            <a:off x="3884613" y="8685213"/>
-            <a:ext cx="2971800" cy="458787"/>
-          </a:xfrm>
-          <a:prstGeom prst="rect">
-            <a:avLst/>
-          </a:prstGeom>
-        </p:spPr>
-        <p:txBody>
-          <a:bodyPr vert="horz" lIns="91440" tIns="45720" rIns="91440" bIns="45720" rtlCol="0" anchor="b"/>
-          <a:lstStyle>
-            <a:lvl1pPr algn="r">
-              <a:defRPr sz="1200"/>
-            </a:lvl1pPr>
-          </a:lstStyle>
-          <a:p>
-            <a:fld id="{CE5E9CC1-C706-0F49-92D6-E571CC5EEA8F}" type="slidenum">
-              <a:rPr lang="en-US"/>
-              <a:t>‹#›</a:t>
-            </a:fld>
-            <a:endParaRPr lang="en-US"/>
-          </a:p>
-        </p:txBody>
-      </p:sp>
     </p:spTree>
     <p:extLst>
       <p:ext uri="{BB962C8B-B14F-4D97-AF65-F5344CB8AC3E}">
-        <p14:creationId xmlns:p14="http://schemas.microsoft.com/office/powerpoint/2010/main" val="1024086991"/>
+        <p14:creationId xmlns:p14="http://schemas.microsoft.com/office/powerpoint/2010/main" val="2516799876"/>
       </p:ext>
     </p:extLst>
   </p:cSld>
@@ -512,10 +293,6 @@
           <a:bodyPr/>
           <a:lstStyle/>
           <a:p>
-            <a:r>
-              <a:rPr lang="en-US" dirty="0"/>
-              <a:t/>
-            </a:r>
             <a:endParaRPr lang="en-US" dirty="0"/>
           </a:p>
         </p:txBody>
@@ -600,10 +377,6 @@
           <a:bodyPr/>
           <a:lstStyle/>
           <a:p>
-            <a:r>
-              <a:rPr lang="en-US" dirty="0"/>
-              <a:t/>
-            </a:r>
             <a:endParaRPr lang="en-US" dirty="0"/>
           </a:p>
         </p:txBody>
@@ -688,10 +461,6 @@
           <a:bodyPr/>
           <a:lstStyle/>
           <a:p>
-            <a:r>
-              <a:rPr lang="en-US" dirty="0"/>
-              <a:t/>
-            </a:r>
             <a:endParaRPr lang="en-US" dirty="0"/>
           </a:p>
         </p:txBody>
@@ -776,10 +545,6 @@
           <a:bodyPr/>
           <a:lstStyle/>
           <a:p>
-            <a:r>
-              <a:rPr lang="en-US" dirty="0"/>
-              <a:t/>
-            </a:r>
             <a:endParaRPr lang="en-US" dirty="0"/>
           </a:p>
         </p:txBody>
@@ -864,10 +629,6 @@
           <a:bodyPr/>
           <a:lstStyle/>
           <a:p>
-            <a:r>
-              <a:rPr lang="en-US" dirty="0"/>
-              <a:t/>
-            </a:r>
             <a:endParaRPr lang="en-US" dirty="0"/>
           </a:p>
         </p:txBody>
@@ -952,10 +713,6 @@
           <a:bodyPr/>
           <a:lstStyle/>
           <a:p>
-            <a:r>
-              <a:rPr lang="en-US" dirty="0"/>
-              <a:t/>
-            </a:r>
             <a:endParaRPr lang="en-US" dirty="0"/>
           </a:p>
         </p:txBody>
@@ -1040,10 +797,6 @@
           <a:bodyPr/>
           <a:lstStyle/>
           <a:p>
-            <a:r>
-              <a:rPr lang="en-US" dirty="0"/>
-              <a:t/>
-            </a:r>
             <a:endParaRPr lang="en-US" dirty="0"/>
           </a:p>
         </p:txBody>
@@ -1128,10 +881,6 @@
           <a:bodyPr/>
           <a:lstStyle/>
           <a:p>
-            <a:r>
-              <a:rPr lang="en-US" dirty="0"/>
-              <a:t/>
-            </a:r>
             <a:endParaRPr lang="en-US" dirty="0"/>
           </a:p>
         </p:txBody>
@@ -1216,10 +965,6 @@
           <a:bodyPr/>
           <a:lstStyle/>
           <a:p>
-            <a:r>
-              <a:rPr lang="en-US" dirty="0"/>
-              <a:t/>
-            </a:r>
             <a:endParaRPr lang="en-US" dirty="0"/>
           </a:p>
         </p:txBody>
@@ -1304,10 +1049,6 @@
           <a:bodyPr/>
           <a:lstStyle/>
           <a:p>
-            <a:r>
-              <a:rPr lang="en-US" dirty="0"/>
-              <a:t/>
-            </a:r>
             <a:endParaRPr lang="en-US" dirty="0"/>
           </a:p>
         </p:txBody>
@@ -1392,10 +1133,6 @@
           <a:bodyPr/>
           <a:lstStyle/>
           <a:p>
-            <a:r>
-              <a:rPr lang="en-US" dirty="0"/>
-              <a:t/>
-            </a:r>
             <a:endParaRPr lang="en-US" dirty="0"/>
           </a:p>
         </p:txBody>
@@ -1480,10 +1217,6 @@
           <a:bodyPr/>
           <a:lstStyle/>
           <a:p>
-            <a:r>
-              <a:rPr lang="en-US" dirty="0"/>
-              <a:t/>
-            </a:r>
             <a:endParaRPr lang="en-US" dirty="0"/>
           </a:p>
         </p:txBody>
@@ -1568,10 +1301,6 @@
           <a:bodyPr/>
           <a:lstStyle/>
           <a:p>
-            <a:r>
-              <a:rPr lang="en-US" dirty="0"/>
-              <a:t/>
-            </a:r>
             <a:endParaRPr lang="en-US" dirty="0"/>
           </a:p>
         </p:txBody>
@@ -1645,6 +1374,11 @@
 <file path=ppt/slideMasters/slideMaster1.xml><?xml version="1.0" encoding="utf-8"?>
 <p:sldMaster xmlns:a="http://schemas.openxmlformats.org/drawingml/2006/main" xmlns:r="http://schemas.openxmlformats.org/officeDocument/2006/relationships" xmlns:p="http://schemas.openxmlformats.org/presentationml/2006/main">
   <p:cSld>
+    <p:bg>
+      <p:bgRef idx="1001">
+        <a:schemeClr val="bg1"/>
+      </p:bgRef>
+    </p:bg>
     <p:spTree>
       <p:nvGrpSpPr>
         <p:cNvPr id="1" name=""/>
@@ -1927,6 +1661,7 @@
         <a:solidFill>
           <a:srgbClr val="17151F"/>
         </a:solidFill>
+        <a:effectLst/>
       </p:bgPr>
     </p:bg>
     <p:spTree>
@@ -1964,7 +1699,7 @@
           <a:bodyPr wrap="square" lIns="0" tIns="0" rIns="0" bIns="0" rtlCol="0" anchor="ctr"/>
           <a:lstStyle/>
           <a:p>
-            <a:pPr indent="0" marL="0">
+            <a:pPr marL="0" indent="0">
               <a:buNone/>
             </a:pPr>
             <a:r>
@@ -2003,11 +1738,11 @@
           <a:bodyPr wrap="square" lIns="0" tIns="0" rIns="0" bIns="0" rtlCol="0" anchor="ctr"/>
           <a:lstStyle/>
           <a:p>
-            <a:pPr indent="0" marL="0">
-              <a:buNone/>
-            </a:pPr>
-            <a:r>
-              <a:rPr lang="en-US" sz="1200" spc="200" kern="0" dirty="0">
+            <a:pPr marL="0" indent="0">
+              <a:buNone/>
+            </a:pPr>
+            <a:r>
+              <a:rPr lang="en-US" sz="1200" kern="0" spc="200" dirty="0">
                 <a:solidFill>
                   <a:srgbClr val="C3BCE0"/>
                 </a:solidFill>
@@ -2042,7 +1777,7 @@
           <a:bodyPr wrap="square" lIns="0" tIns="0" rIns="0" bIns="0" rtlCol="0" anchor="ctr"/>
           <a:lstStyle/>
           <a:p>
-            <a:pPr indent="0" marL="0">
+            <a:pPr marL="0" indent="0">
               <a:lnSpc>
                 <a:spcPct val="98000"/>
               </a:lnSpc>
@@ -2062,7 +1797,7 @@
             <a:endParaRPr lang="en-US" sz="5800" dirty="0"/>
           </a:p>
           <a:p>
-            <a:pPr indent="0" marL="0">
+            <a:pPr marL="0" indent="0">
               <a:lnSpc>
                 <a:spcPct val="98000"/>
               </a:lnSpc>
@@ -2104,7 +1839,7 @@
           <a:bodyPr wrap="square" lIns="0" tIns="0" rIns="0" bIns="0" rtlCol="0" anchor="ctr"/>
           <a:lstStyle/>
           <a:p>
-            <a:pPr indent="0" marL="0">
+            <a:pPr marL="0" indent="0">
               <a:buNone/>
             </a:pPr>
             <a:r>
@@ -2148,6 +1883,13 @@
             <a:prstDash val="solid"/>
           </a:ln>
         </p:spPr>
+        <p:txBody>
+          <a:bodyPr/>
+          <a:lstStyle/>
+          <a:p>
+            <a:endParaRPr lang="en-US"/>
+          </a:p>
+        </p:txBody>
       </p:sp>
       <p:sp>
         <p:nvSpPr>
@@ -2175,6 +1917,13 @@
             <a:prstDash val="solid"/>
           </a:ln>
         </p:spPr>
+        <p:txBody>
+          <a:bodyPr/>
+          <a:lstStyle/>
+          <a:p>
+            <a:endParaRPr lang="en-US"/>
+          </a:p>
+        </p:txBody>
       </p:sp>
       <p:sp>
         <p:nvSpPr>
@@ -2202,6 +1951,13 @@
             <a:prstDash val="solid"/>
           </a:ln>
         </p:spPr>
+        <p:txBody>
+          <a:bodyPr/>
+          <a:lstStyle/>
+          <a:p>
+            <a:endParaRPr lang="en-US"/>
+          </a:p>
+        </p:txBody>
       </p:sp>
       <p:sp>
         <p:nvSpPr>
@@ -2229,6 +1985,13 @@
             <a:prstDash val="solid"/>
           </a:ln>
         </p:spPr>
+        <p:txBody>
+          <a:bodyPr/>
+          <a:lstStyle/>
+          <a:p>
+            <a:endParaRPr lang="en-US"/>
+          </a:p>
+        </p:txBody>
       </p:sp>
       <p:sp>
         <p:nvSpPr>
@@ -2251,7 +2014,7 @@
           <a:bodyPr wrap="square" lIns="0" tIns="0" rIns="0" bIns="0" rtlCol="0" anchor="ctr"/>
           <a:lstStyle/>
           <a:p>
-            <a:pPr indent="0" marL="0">
+            <a:pPr marL="0" indent="0">
               <a:buNone/>
             </a:pPr>
             <a:r>
@@ -2290,7 +2053,7 @@
           <a:bodyPr wrap="square" lIns="0" tIns="0" rIns="0" bIns="0" rtlCol="0" anchor="ctr"/>
           <a:lstStyle/>
           <a:p>
-            <a:pPr indent="0" marL="0">
+            <a:pPr marL="0" indent="0">
               <a:buNone/>
             </a:pPr>
             <a:r>
@@ -2324,6 +2087,7 @@
         <a:solidFill>
           <a:srgbClr val="17151F"/>
         </a:solidFill>
+        <a:effectLst/>
       </p:bgPr>
     </p:bg>
     <p:spTree>
@@ -2361,11 +2125,11 @@
           <a:bodyPr wrap="square" lIns="0" tIns="0" rIns="0" bIns="0" rtlCol="0" anchor="ctr"/>
           <a:lstStyle/>
           <a:p>
-            <a:pPr indent="0" marL="0">
-              <a:buNone/>
-            </a:pPr>
-            <a:r>
-              <a:rPr lang="en-US" sz="1200" b="1" spc="200" kern="0" dirty="0">
+            <a:pPr marL="0" indent="0">
+              <a:buNone/>
+            </a:pPr>
+            <a:r>
+              <a:rPr lang="en-US" sz="1200" b="1" kern="0" spc="200" dirty="0">
                 <a:solidFill>
                   <a:srgbClr val="5B3DF5"/>
                 </a:solidFill>
@@ -2400,7 +2164,7 @@
           <a:bodyPr wrap="square" lIns="0" tIns="0" rIns="0" bIns="0" rtlCol="0" anchor="ctr"/>
           <a:lstStyle/>
           <a:p>
-            <a:pPr indent="0" marL="0">
+            <a:pPr marL="0" indent="0">
               <a:buNone/>
             </a:pPr>
             <a:r>
@@ -2440,6 +2204,13 @@
             <a:prstDash val="solid"/>
           </a:ln>
         </p:spPr>
+        <p:txBody>
+          <a:bodyPr/>
+          <a:lstStyle/>
+          <a:p>
+            <a:endParaRPr lang="en-US"/>
+          </a:p>
+        </p:txBody>
       </p:sp>
       <p:sp>
         <p:nvSpPr>
@@ -2465,6 +2236,13 @@
             <a:prstDash val="solid"/>
           </a:ln>
         </p:spPr>
+        <p:txBody>
+          <a:bodyPr/>
+          <a:lstStyle/>
+          <a:p>
+            <a:endParaRPr lang="en-US"/>
+          </a:p>
+        </p:txBody>
       </p:sp>
       <p:sp>
         <p:nvSpPr>
@@ -2487,7 +2265,7 @@
           <a:bodyPr wrap="square" lIns="0" tIns="0" rIns="0" bIns="0" rtlCol="0" anchor="ctr"/>
           <a:lstStyle/>
           <a:p>
-            <a:pPr algn="ctr" indent="0" marL="0">
+            <a:pPr marL="0" indent="0" algn="ctr">
               <a:buNone/>
             </a:pPr>
             <a:r>
@@ -2526,7 +2304,7 @@
           <a:bodyPr wrap="square" lIns="0" tIns="0" rIns="0" bIns="0" rtlCol="0" anchor="ctr"/>
           <a:lstStyle/>
           <a:p>
-            <a:pPr algn="ctr" indent="0" marL="0">
+            <a:pPr marL="0" indent="0" algn="ctr">
               <a:buNone/>
             </a:pPr>
             <a:r>
@@ -2565,7 +2343,7 @@
           <a:bodyPr wrap="square" lIns="0" tIns="0" rIns="0" bIns="0" rtlCol="0" anchor="ctr"/>
           <a:lstStyle/>
           <a:p>
-            <a:pPr algn="ctr" indent="0" marL="0">
+            <a:pPr marL="0" indent="0" algn="ctr">
               <a:buNone/>
             </a:pPr>
             <a:r>
@@ -2607,6 +2385,13 @@
             <a:prstDash val="solid"/>
           </a:ln>
         </p:spPr>
+        <p:txBody>
+          <a:bodyPr/>
+          <a:lstStyle/>
+          <a:p>
+            <a:endParaRPr lang="en-US"/>
+          </a:p>
+        </p:txBody>
       </p:sp>
       <p:sp>
         <p:nvSpPr>
@@ -2629,7 +2414,7 @@
           <a:bodyPr wrap="square" lIns="0" tIns="0" rIns="0" bIns="0" rtlCol="0" anchor="ctr"/>
           <a:lstStyle/>
           <a:p>
-            <a:pPr algn="ctr" indent="0" marL="0">
+            <a:pPr marL="0" indent="0" algn="ctr">
               <a:buNone/>
             </a:pPr>
             <a:r>
@@ -2668,7 +2453,7 @@
           <a:bodyPr wrap="square" lIns="0" tIns="0" rIns="0" bIns="0" rtlCol="0" anchor="ctr"/>
           <a:lstStyle/>
           <a:p>
-            <a:pPr algn="ctr" indent="0" marL="0">
+            <a:pPr marL="0" indent="0" algn="ctr">
               <a:buNone/>
             </a:pPr>
             <a:r>
@@ -2707,7 +2492,7 @@
           <a:bodyPr wrap="square" lIns="0" tIns="0" rIns="0" bIns="0" rtlCol="0" anchor="ctr"/>
           <a:lstStyle/>
           <a:p>
-            <a:pPr algn="ctr" indent="0" marL="0">
+            <a:pPr marL="0" indent="0" algn="ctr">
               <a:buNone/>
             </a:pPr>
             <a:r>
@@ -2749,6 +2534,13 @@
             <a:prstDash val="solid"/>
           </a:ln>
         </p:spPr>
+        <p:txBody>
+          <a:bodyPr/>
+          <a:lstStyle/>
+          <a:p>
+            <a:endParaRPr lang="en-US"/>
+          </a:p>
+        </p:txBody>
       </p:sp>
       <p:sp>
         <p:nvSpPr>
@@ -2771,7 +2563,7 @@
           <a:bodyPr wrap="square" lIns="0" tIns="0" rIns="0" bIns="0" rtlCol="0" anchor="ctr"/>
           <a:lstStyle/>
           <a:p>
-            <a:pPr algn="ctr" indent="0" marL="0">
+            <a:pPr marL="0" indent="0" algn="ctr">
               <a:buNone/>
             </a:pPr>
             <a:r>
@@ -2810,7 +2602,7 @@
           <a:bodyPr wrap="square" lIns="0" tIns="0" rIns="0" bIns="0" rtlCol="0" anchor="ctr"/>
           <a:lstStyle/>
           <a:p>
-            <a:pPr algn="ctr" indent="0" marL="0">
+            <a:pPr marL="0" indent="0" algn="ctr">
               <a:buNone/>
             </a:pPr>
             <a:r>
@@ -2849,7 +2641,7 @@
           <a:bodyPr wrap="square" lIns="0" tIns="0" rIns="0" bIns="0" rtlCol="0" anchor="ctr"/>
           <a:lstStyle/>
           <a:p>
-            <a:pPr algn="ctr" indent="0" marL="0">
+            <a:pPr marL="0" indent="0" algn="ctr">
               <a:buNone/>
             </a:pPr>
             <a:r>
@@ -2891,6 +2683,13 @@
             <a:prstDash val="solid"/>
           </a:ln>
         </p:spPr>
+        <p:txBody>
+          <a:bodyPr/>
+          <a:lstStyle/>
+          <a:p>
+            <a:endParaRPr lang="en-US"/>
+          </a:p>
+        </p:txBody>
       </p:sp>
       <p:sp>
         <p:nvSpPr>
@@ -2913,7 +2712,7 @@
           <a:bodyPr wrap="square" lIns="0" tIns="0" rIns="0" bIns="0" rtlCol="0" anchor="ctr"/>
           <a:lstStyle/>
           <a:p>
-            <a:pPr algn="ctr" indent="0" marL="0">
+            <a:pPr marL="0" indent="0" algn="ctr">
               <a:buNone/>
             </a:pPr>
             <a:r>
@@ -2952,7 +2751,7 @@
           <a:bodyPr wrap="square" lIns="0" tIns="0" rIns="0" bIns="0" rtlCol="0" anchor="ctr"/>
           <a:lstStyle/>
           <a:p>
-            <a:pPr algn="ctr" indent="0" marL="0">
+            <a:pPr marL="0" indent="0" algn="ctr">
               <a:buNone/>
             </a:pPr>
             <a:r>
@@ -2991,7 +2790,7 @@
           <a:bodyPr wrap="square" lIns="0" tIns="0" rIns="0" bIns="0" rtlCol="0" anchor="ctr"/>
           <a:lstStyle/>
           <a:p>
-            <a:pPr algn="ctr" indent="0" marL="0">
+            <a:pPr marL="0" indent="0" algn="ctr">
               <a:buNone/>
             </a:pPr>
             <a:r>
@@ -3033,6 +2832,13 @@
             <a:prstDash val="solid"/>
           </a:ln>
         </p:spPr>
+        <p:txBody>
+          <a:bodyPr/>
+          <a:lstStyle/>
+          <a:p>
+            <a:endParaRPr lang="en-US"/>
+          </a:p>
+        </p:txBody>
       </p:sp>
       <p:sp>
         <p:nvSpPr>
@@ -3055,7 +2861,7 @@
           <a:bodyPr wrap="square" lIns="0" tIns="0" rIns="0" bIns="0" rtlCol="0" anchor="ctr"/>
           <a:lstStyle/>
           <a:p>
-            <a:pPr algn="ctr" indent="0" marL="0">
+            <a:pPr marL="0" indent="0" algn="ctr">
               <a:buNone/>
             </a:pPr>
             <a:r>
@@ -3094,7 +2900,7 @@
           <a:bodyPr wrap="square" lIns="0" tIns="0" rIns="0" bIns="0" rtlCol="0" anchor="ctr"/>
           <a:lstStyle/>
           <a:p>
-            <a:pPr algn="ctr" indent="0" marL="0">
+            <a:pPr marL="0" indent="0" algn="ctr">
               <a:buNone/>
             </a:pPr>
             <a:r>
@@ -3133,7 +2939,7 @@
           <a:bodyPr wrap="square" lIns="0" tIns="0" rIns="0" bIns="0" rtlCol="0" anchor="ctr"/>
           <a:lstStyle/>
           <a:p>
-            <a:pPr algn="ctr" indent="0" marL="0">
+            <a:pPr marL="0" indent="0" algn="ctr">
               <a:buNone/>
             </a:pPr>
             <a:r>
@@ -3175,6 +2981,13 @@
             <a:prstDash val="solid"/>
           </a:ln>
         </p:spPr>
+        <p:txBody>
+          <a:bodyPr/>
+          <a:lstStyle/>
+          <a:p>
+            <a:endParaRPr lang="en-US"/>
+          </a:p>
+        </p:txBody>
       </p:sp>
       <p:sp>
         <p:nvSpPr>
@@ -3197,7 +3010,7 @@
           <a:bodyPr wrap="square" lIns="0" tIns="0" rIns="0" bIns="0" rtlCol="0" anchor="ctr"/>
           <a:lstStyle/>
           <a:p>
-            <a:pPr algn="ctr" indent="0" marL="0">
+            <a:pPr marL="0" indent="0" algn="ctr">
               <a:buNone/>
             </a:pPr>
             <a:r>
@@ -3236,7 +3049,7 @@
           <a:bodyPr wrap="square" lIns="0" tIns="0" rIns="0" bIns="0" rtlCol="0" anchor="ctr"/>
           <a:lstStyle/>
           <a:p>
-            <a:pPr algn="ctr" indent="0" marL="0">
+            <a:pPr marL="0" indent="0" algn="ctr">
               <a:buNone/>
             </a:pPr>
             <a:r>
@@ -3275,7 +3088,7 @@
           <a:bodyPr wrap="square" lIns="0" tIns="0" rIns="0" bIns="0" rtlCol="0" anchor="ctr"/>
           <a:lstStyle/>
           <a:p>
-            <a:pPr algn="ctr" indent="0" marL="0">
+            <a:pPr marL="0" indent="0" algn="ctr">
               <a:buNone/>
             </a:pPr>
             <a:r>
@@ -3314,7 +3127,7 @@
           <a:bodyPr wrap="square" lIns="0" tIns="0" rIns="0" bIns="0" rtlCol="0" anchor="ctr"/>
           <a:lstStyle/>
           <a:p>
-            <a:pPr algn="ctr" indent="0" marL="0">
+            <a:pPr marL="0" indent="0" algn="ctr">
               <a:buNone/>
             </a:pPr>
             <a:r>
@@ -3348,6 +3161,7 @@
         <a:solidFill>
           <a:srgbClr val="17151F"/>
         </a:solidFill>
+        <a:effectLst/>
       </p:bgPr>
     </p:bg>
     <p:spTree>
@@ -3385,11 +3199,11 @@
           <a:bodyPr wrap="square" lIns="0" tIns="0" rIns="0" bIns="0" rtlCol="0" anchor="ctr"/>
           <a:lstStyle/>
           <a:p>
-            <a:pPr indent="0" marL="0">
-              <a:buNone/>
-            </a:pPr>
-            <a:r>
-              <a:rPr lang="en-US" sz="1200" b="1" spc="200" kern="0" dirty="0">
+            <a:pPr marL="0" indent="0">
+              <a:buNone/>
+            </a:pPr>
+            <a:r>
+              <a:rPr lang="en-US" sz="1200" b="1" kern="0" spc="200" dirty="0">
                 <a:solidFill>
                   <a:srgbClr val="5B3DF5"/>
                 </a:solidFill>
@@ -3424,7 +3238,7 @@
           <a:bodyPr wrap="square" lIns="0" tIns="0" rIns="0" bIns="0" rtlCol="0" anchor="ctr"/>
           <a:lstStyle/>
           <a:p>
-            <a:pPr indent="0" marL="0">
+            <a:pPr marL="0" indent="0">
               <a:buNone/>
             </a:pPr>
             <a:r>
@@ -3463,7 +3277,7 @@
           <a:bodyPr wrap="square" lIns="0" tIns="0" rIns="0" bIns="0" rtlCol="0" anchor="ctr"/>
           <a:lstStyle/>
           <a:p>
-            <a:pPr indent="0" marL="0">
+            <a:pPr marL="0" indent="0">
               <a:buNone/>
             </a:pPr>
             <a:r>
@@ -3502,7 +3316,7 @@
           <a:bodyPr wrap="square" lIns="0" tIns="0" rIns="0" bIns="0" rtlCol="0" anchor="ctr"/>
           <a:lstStyle/>
           <a:p>
-            <a:pPr indent="0" marL="0">
+            <a:pPr marL="0" indent="0">
               <a:buNone/>
             </a:pPr>
             <a:r>
@@ -3541,7 +3355,7 @@
           <a:bodyPr wrap="square" lIns="0" tIns="0" rIns="0" bIns="0" rtlCol="0" anchor="ctr"/>
           <a:lstStyle/>
           <a:p>
-            <a:pPr indent="0" marL="0">
+            <a:pPr marL="0" indent="0">
               <a:buNone/>
             </a:pPr>
             <a:r>
@@ -3580,7 +3394,7 @@
           <a:bodyPr wrap="square" lIns="0" tIns="0" rIns="0" bIns="0" rtlCol="0" anchor="ctr"/>
           <a:lstStyle/>
           <a:p>
-            <a:pPr indent="0" marL="0">
+            <a:pPr marL="0" indent="0">
               <a:buNone/>
             </a:pPr>
             <a:r>
@@ -3619,7 +3433,7 @@
           <a:bodyPr wrap="square" lIns="0" tIns="0" rIns="0" bIns="0" rtlCol="0" anchor="ctr"/>
           <a:lstStyle/>
           <a:p>
-            <a:pPr indent="0" marL="0">
+            <a:pPr marL="0" indent="0">
               <a:buNone/>
             </a:pPr>
             <a:r>
@@ -3658,7 +3472,7 @@
           <a:bodyPr wrap="square" lIns="0" tIns="0" rIns="0" bIns="0" rtlCol="0" anchor="ctr"/>
           <a:lstStyle/>
           <a:p>
-            <a:pPr indent="0" marL="0">
+            <a:pPr marL="0" indent="0">
               <a:buNone/>
             </a:pPr>
             <a:r>
@@ -3697,7 +3511,7 @@
           <a:bodyPr wrap="square" lIns="0" tIns="0" rIns="0" bIns="0" rtlCol="0" anchor="ctr"/>
           <a:lstStyle/>
           <a:p>
-            <a:pPr indent="0" marL="0">
+            <a:pPr marL="0" indent="0">
               <a:buNone/>
             </a:pPr>
             <a:r>
@@ -3736,7 +3550,7 @@
           <a:bodyPr wrap="square" lIns="0" tIns="0" rIns="0" bIns="0" rtlCol="0" anchor="ctr"/>
           <a:lstStyle/>
           <a:p>
-            <a:pPr indent="0" marL="0">
+            <a:pPr marL="0" indent="0">
               <a:buNone/>
             </a:pPr>
             <a:r>
@@ -3775,7 +3589,7 @@
           <a:bodyPr wrap="square" lIns="0" tIns="0" rIns="0" bIns="0" rtlCol="0" anchor="ctr"/>
           <a:lstStyle/>
           <a:p>
-            <a:pPr indent="0" marL="0">
+            <a:pPr marL="0" indent="0">
               <a:buNone/>
             </a:pPr>
             <a:r>
@@ -3814,7 +3628,7 @@
           <a:bodyPr wrap="square" lIns="0" tIns="0" rIns="0" bIns="0" rtlCol="0" anchor="ctr"/>
           <a:lstStyle/>
           <a:p>
-            <a:pPr indent="0" marL="0">
+            <a:pPr marL="0" indent="0">
               <a:buNone/>
             </a:pPr>
             <a:r>
@@ -3853,7 +3667,7 @@
           <a:bodyPr wrap="square" lIns="0" tIns="0" rIns="0" bIns="0" rtlCol="0" anchor="ctr"/>
           <a:lstStyle/>
           <a:p>
-            <a:pPr indent="0" marL="0">
+            <a:pPr marL="0" indent="0">
               <a:buNone/>
             </a:pPr>
             <a:r>
@@ -3887,6 +3701,7 @@
         <a:solidFill>
           <a:srgbClr val="FFFFFF"/>
         </a:solidFill>
+        <a:effectLst/>
       </p:bgPr>
     </p:bg>
     <p:spTree>
@@ -3924,11 +3739,11 @@
           <a:bodyPr wrap="square" lIns="0" tIns="0" rIns="0" bIns="0" rtlCol="0" anchor="ctr"/>
           <a:lstStyle/>
           <a:p>
-            <a:pPr indent="0" marL="0">
-              <a:buNone/>
-            </a:pPr>
-            <a:r>
-              <a:rPr lang="en-US" sz="1200" b="1" spc="200" kern="0" dirty="0">
+            <a:pPr marL="0" indent="0">
+              <a:buNone/>
+            </a:pPr>
+            <a:r>
+              <a:rPr lang="en-US" sz="1200" b="1" kern="0" spc="200" dirty="0">
                 <a:solidFill>
                   <a:srgbClr val="5B3DF5"/>
                 </a:solidFill>
@@ -3963,7 +3778,7 @@
           <a:bodyPr wrap="square" lIns="0" tIns="0" rIns="0" bIns="0" rtlCol="0" anchor="t"/>
           <a:lstStyle/>
           <a:p>
-            <a:pPr indent="0" marL="0">
+            <a:pPr marL="0" indent="0">
               <a:buNone/>
             </a:pPr>
             <a:r>
@@ -3983,14 +3798,14 @@
       </p:sp>
       <p:pic>
         <p:nvPicPr>
-          <p:cNvPr id="4" name="Image 0" descr="preencoded.png">    </p:cNvPr>
+          <p:cNvPr id="4" name="Image 0" descr="preencoded.png"/>
           <p:cNvPicPr>
             <a:picLocks noChangeAspect="1"/>
           </p:cNvPicPr>
           <p:nvPr/>
         </p:nvPicPr>
         <p:blipFill>
-          <a:blip r:embed="rId1"/>
+          <a:blip r:embed="rId3"/>
           <a:stretch>
             <a:fillRect/>
           </a:stretch>
@@ -4031,6 +3846,13 @@
             <a:prstDash val="solid"/>
           </a:ln>
         </p:spPr>
+        <p:txBody>
+          <a:bodyPr/>
+          <a:lstStyle/>
+          <a:p>
+            <a:endParaRPr lang="en-US"/>
+          </a:p>
+        </p:txBody>
       </p:sp>
       <p:sp>
         <p:nvSpPr>
@@ -4053,7 +3875,7 @@
           <a:bodyPr wrap="square" lIns="0" tIns="0" rIns="0" bIns="0" rtlCol="0" anchor="ctr"/>
           <a:lstStyle/>
           <a:p>
-            <a:pPr indent="0" marL="0">
+            <a:pPr marL="0" indent="0">
               <a:buNone/>
             </a:pPr>
             <a:r>
@@ -4092,7 +3914,7 @@
           <a:bodyPr wrap="square" lIns="0" tIns="0" rIns="0" bIns="0" rtlCol="0" anchor="ctr"/>
           <a:lstStyle/>
           <a:p>
-            <a:pPr indent="0" marL="0">
+            <a:pPr marL="0" indent="0">
               <a:lnSpc>
                 <a:spcPct val="115000"/>
               </a:lnSpc>
@@ -4109,12 +3931,6 @@
               </a:rPr>
               <a:t>Inside: </a:t>
             </a:r>
-            <a:pPr indent="0" marL="0">
-              <a:lnSpc>
-                <a:spcPct val="115000"/>
-              </a:lnSpc>
-              <a:buNone/>
-            </a:pPr>
             <a:r>
               <a:rPr lang="en-US" sz="1600" dirty="0">
                 <a:solidFill>
@@ -4151,7 +3967,7 @@
           <a:bodyPr wrap="square" lIns="0" tIns="0" rIns="0" bIns="0" rtlCol="0" anchor="ctr"/>
           <a:lstStyle/>
           <a:p>
-            <a:pPr algn="ctr" indent="0" marL="0">
+            <a:pPr marL="0" indent="0" algn="ctr">
               <a:buNone/>
             </a:pPr>
             <a:r>
@@ -4165,9 +3981,6 @@
               </a:rPr>
               <a:t>No terminal? </a:t>
             </a:r>
-            <a:pPr algn="ctr" indent="0" marL="0">
-              <a:buNone/>
-            </a:pPr>
             <a:r>
               <a:rPr lang="en-US" sz="1500" dirty="0">
                 <a:solidFill>
@@ -4179,9 +3992,6 @@
               </a:rPr>
               <a:t>Use the Claude app — a fresh chat per task.    </a:t>
             </a:r>
-            <a:pPr algn="ctr" indent="0" marL="0">
-              <a:buNone/>
-            </a:pPr>
             <a:r>
               <a:rPr lang="en-US" sz="1500" b="1" dirty="0">
                 <a:solidFill>
@@ -4193,9 +4003,6 @@
               </a:rPr>
               <a:t>Comfortable in one? </a:t>
             </a:r>
-            <a:pPr algn="ctr" indent="0" marL="0">
-              <a:buNone/>
-            </a:pPr>
             <a:r>
               <a:rPr lang="en-US" sz="1500" dirty="0">
                 <a:solidFill>
@@ -4232,7 +4039,7 @@
           <a:bodyPr wrap="square" lIns="0" tIns="0" rIns="0" bIns="0" rtlCol="0" anchor="ctr"/>
           <a:lstStyle/>
           <a:p>
-            <a:pPr indent="0" marL="0">
+            <a:pPr marL="0" indent="0">
               <a:buNone/>
             </a:pPr>
             <a:r>
@@ -4271,7 +4078,7 @@
           <a:bodyPr wrap="square" lIns="0" tIns="0" rIns="0" bIns="0" rtlCol="0" anchor="ctr"/>
           <a:lstStyle/>
           <a:p>
-            <a:pPr algn="r" indent="0" marL="0">
+            <a:pPr marL="0" indent="0" algn="r">
               <a:buNone/>
             </a:pPr>
             <a:r>
@@ -4305,6 +4112,7 @@
         <a:solidFill>
           <a:srgbClr val="17151F"/>
         </a:solidFill>
+        <a:effectLst/>
       </p:bgPr>
     </p:bg>
     <p:spTree>
@@ -4347,6 +4155,13 @@
             <a:prstDash val="solid"/>
           </a:ln>
         </p:spPr>
+        <p:txBody>
+          <a:bodyPr/>
+          <a:lstStyle/>
+          <a:p>
+            <a:endParaRPr lang="en-US"/>
+          </a:p>
+        </p:txBody>
       </p:sp>
       <p:sp>
         <p:nvSpPr>
@@ -4374,6 +4189,13 @@
             <a:prstDash val="solid"/>
           </a:ln>
         </p:spPr>
+        <p:txBody>
+          <a:bodyPr/>
+          <a:lstStyle/>
+          <a:p>
+            <a:endParaRPr lang="en-US"/>
+          </a:p>
+        </p:txBody>
       </p:sp>
       <p:sp>
         <p:nvSpPr>
@@ -4401,6 +4223,13 @@
             <a:prstDash val="solid"/>
           </a:ln>
         </p:spPr>
+        <p:txBody>
+          <a:bodyPr/>
+          <a:lstStyle/>
+          <a:p>
+            <a:endParaRPr lang="en-US"/>
+          </a:p>
+        </p:txBody>
       </p:sp>
       <p:sp>
         <p:nvSpPr>
@@ -4428,6 +4257,13 @@
             <a:prstDash val="solid"/>
           </a:ln>
         </p:spPr>
+        <p:txBody>
+          <a:bodyPr/>
+          <a:lstStyle/>
+          <a:p>
+            <a:endParaRPr lang="en-US"/>
+          </a:p>
+        </p:txBody>
       </p:sp>
       <p:sp>
         <p:nvSpPr>
@@ -4450,7 +4286,7 @@
           <a:bodyPr wrap="square" lIns="0" tIns="0" rIns="0" bIns="0" rtlCol="0" anchor="ctr"/>
           <a:lstStyle/>
           <a:p>
-            <a:pPr indent="0" marL="0">
+            <a:pPr marL="0" indent="0">
               <a:buNone/>
             </a:pPr>
             <a:r>
@@ -4489,7 +4325,7 @@
           <a:bodyPr wrap="square" lIns="0" tIns="0" rIns="0" bIns="0" rtlCol="0" anchor="ctr"/>
           <a:lstStyle/>
           <a:p>
-            <a:pPr indent="0" marL="0">
+            <a:pPr marL="0" indent="0">
               <a:buNone/>
             </a:pPr>
             <a:r>
@@ -4503,9 +4339,6 @@
               </a:rPr>
               <a:t>Questions — then go point it at </a:t>
             </a:r>
-            <a:pPr indent="0" marL="0">
-              <a:buNone/>
-            </a:pPr>
             <a:r>
               <a:rPr lang="en-US" sz="2200" b="1" dirty="0">
                 <a:solidFill>
@@ -4542,7 +4375,7 @@
           <a:bodyPr wrap="square" lIns="0" tIns="0" rIns="0" bIns="0" rtlCol="0" anchor="ctr"/>
           <a:lstStyle/>
           <a:p>
-            <a:pPr indent="0" marL="0">
+            <a:pPr marL="0" indent="0">
               <a:buNone/>
             </a:pPr>
             <a:r>
@@ -4554,7 +4387,29 @@
                 <a:ea typeface="Calibri" pitchFamily="34" charset="-122"/>
                 <a:cs typeface="Calibri" pitchFamily="34" charset="-120"/>
               </a:rPr>
-              <a:t>Fernando Torres — Founder &amp; CEO, Memori</a:t>
+              <a:t>Fernando </a:t>
+            </a:r>
+            <a:r>
+              <a:rPr lang="en-US" sz="1500" b="1">
+                <a:solidFill>
+                  <a:srgbClr val="FFFFFF"/>
+                </a:solidFill>
+                <a:latin typeface="Calibri" pitchFamily="34" charset="0"/>
+                <a:ea typeface="Calibri" pitchFamily="34" charset="-122"/>
+                <a:cs typeface="Calibri" pitchFamily="34" charset="-120"/>
+              </a:rPr>
+              <a:t>Torres —, </a:t>
+            </a:r>
+            <a:r>
+              <a:rPr lang="en-US" sz="1500" b="1" dirty="0">
+                <a:solidFill>
+                  <a:srgbClr val="FFFFFF"/>
+                </a:solidFill>
+                <a:latin typeface="Calibri" pitchFamily="34" charset="0"/>
+                <a:ea typeface="Calibri" pitchFamily="34" charset="-122"/>
+                <a:cs typeface="Calibri" pitchFamily="34" charset="-120"/>
+              </a:rPr>
+              <a:t>Memori</a:t>
             </a:r>
             <a:endParaRPr lang="en-US" sz="1500" dirty="0"/>
           </a:p>
@@ -4581,7 +4436,7 @@
           <a:bodyPr wrap="square" lIns="0" tIns="0" rIns="0" bIns="0" rtlCol="0" anchor="ctr"/>
           <a:lstStyle/>
           <a:p>
-            <a:pPr indent="0" marL="0">
+            <a:pPr marL="0" indent="0">
               <a:buNone/>
             </a:pPr>
             <a:r>
@@ -4615,6 +4470,7 @@
         <a:solidFill>
           <a:srgbClr val="FFFFFF"/>
         </a:solidFill>
+        <a:effectLst/>
       </p:bgPr>
     </p:bg>
     <p:spTree>
@@ -4652,11 +4508,11 @@
           <a:bodyPr wrap="square" lIns="0" tIns="0" rIns="0" bIns="0" rtlCol="0" anchor="ctr"/>
           <a:lstStyle/>
           <a:p>
-            <a:pPr indent="0" marL="0">
-              <a:buNone/>
-            </a:pPr>
-            <a:r>
-              <a:rPr lang="en-US" sz="1200" b="1" spc="200" kern="0" dirty="0">
+            <a:pPr marL="0" indent="0">
+              <a:buNone/>
+            </a:pPr>
+            <a:r>
+              <a:rPr lang="en-US" sz="1200" b="1" kern="0" spc="200" dirty="0">
                 <a:solidFill>
                   <a:srgbClr val="5B3DF5"/>
                 </a:solidFill>
@@ -4691,7 +4547,7 @@
           <a:bodyPr wrap="square" lIns="0" tIns="0" rIns="0" bIns="0" rtlCol="0" anchor="t"/>
           <a:lstStyle/>
           <a:p>
-            <a:pPr indent="0" marL="0">
+            <a:pPr marL="0" indent="0">
               <a:buNone/>
             </a:pPr>
             <a:r>
@@ -4708,7 +4564,7 @@
             <a:endParaRPr lang="en-US" sz="3400" dirty="0"/>
           </a:p>
           <a:p>
-            <a:pPr indent="0" marL="0">
+            <a:pPr marL="0" indent="0">
               <a:buNone/>
             </a:pPr>
             <a:r>
@@ -4747,7 +4603,7 @@
           <a:bodyPr wrap="square" lIns="0" tIns="0" rIns="0" bIns="0" rtlCol="0" anchor="ctr"/>
           <a:lstStyle/>
           <a:p>
-            <a:pPr indent="0" marL="0">
+            <a:pPr marL="0" indent="0">
               <a:lnSpc>
                 <a:spcPct val="110000"/>
               </a:lnSpc>
@@ -4794,13 +4650,20 @@
             <a:prstDash val="solid"/>
           </a:ln>
           <a:effectLst>
-            <a:outerShdw sx="100000" sy="100000" kx="0" ky="0" algn="bl" rotWithShape="0" blurRad="114300" dist="38100" dir="8100000">
+            <a:outerShdw blurRad="114300" dist="38100" dir="8100000" algn="bl" rotWithShape="0">
               <a:srgbClr val="17151F">
                 <a:alpha val="12000"/>
               </a:srgbClr>
             </a:outerShdw>
           </a:effectLst>
         </p:spPr>
+        <p:txBody>
+          <a:bodyPr/>
+          <a:lstStyle/>
+          <a:p>
+            <a:endParaRPr lang="en-US"/>
+          </a:p>
+        </p:txBody>
       </p:sp>
       <p:sp>
         <p:nvSpPr>
@@ -4823,7 +4686,7 @@
           <a:bodyPr wrap="square" lIns="0" tIns="0" rIns="0" bIns="0" rtlCol="0" anchor="ctr"/>
           <a:lstStyle/>
           <a:p>
-            <a:pPr algn="ctr" indent="0" marL="0">
+            <a:pPr marL="0" indent="0" algn="ctr">
               <a:buNone/>
             </a:pPr>
             <a:r>
@@ -4865,6 +4728,13 @@
             <a:prstDash val="solid"/>
           </a:ln>
         </p:spPr>
+        <p:txBody>
+          <a:bodyPr/>
+          <a:lstStyle/>
+          <a:p>
+            <a:endParaRPr lang="en-US"/>
+          </a:p>
+        </p:txBody>
       </p:sp>
       <p:sp>
         <p:nvSpPr>
@@ -4890,6 +4760,13 @@
             <a:prstDash val="solid"/>
           </a:ln>
         </p:spPr>
+        <p:txBody>
+          <a:bodyPr/>
+          <a:lstStyle/>
+          <a:p>
+            <a:endParaRPr lang="en-US"/>
+          </a:p>
+        </p:txBody>
       </p:sp>
       <p:sp>
         <p:nvSpPr>
@@ -4915,6 +4792,13 @@
             <a:prstDash val="solid"/>
           </a:ln>
         </p:spPr>
+        <p:txBody>
+          <a:bodyPr/>
+          <a:lstStyle/>
+          <a:p>
+            <a:endParaRPr lang="en-US"/>
+          </a:p>
+        </p:txBody>
       </p:sp>
       <p:sp>
         <p:nvSpPr>
@@ -4940,6 +4824,13 @@
             <a:prstDash val="solid"/>
           </a:ln>
         </p:spPr>
+        <p:txBody>
+          <a:bodyPr/>
+          <a:lstStyle/>
+          <a:p>
+            <a:endParaRPr lang="en-US"/>
+          </a:p>
+        </p:txBody>
       </p:sp>
       <p:sp>
         <p:nvSpPr>
@@ -4965,6 +4856,13 @@
             <a:prstDash val="solid"/>
           </a:ln>
         </p:spPr>
+        <p:txBody>
+          <a:bodyPr/>
+          <a:lstStyle/>
+          <a:p>
+            <a:endParaRPr lang="en-US"/>
+          </a:p>
+        </p:txBody>
       </p:sp>
       <p:sp>
         <p:nvSpPr>
@@ -4990,6 +4888,13 @@
             <a:prstDash val="solid"/>
           </a:ln>
         </p:spPr>
+        <p:txBody>
+          <a:bodyPr/>
+          <a:lstStyle/>
+          <a:p>
+            <a:endParaRPr lang="en-US"/>
+          </a:p>
+        </p:txBody>
       </p:sp>
       <p:sp>
         <p:nvSpPr>
@@ -5012,7 +4917,7 @@
           <a:bodyPr wrap="square" lIns="0" tIns="0" rIns="0" bIns="0" rtlCol="0" anchor="ctr"/>
           <a:lstStyle/>
           <a:p>
-            <a:pPr algn="ctr" indent="0" marL="0">
+            <a:pPr marL="0" indent="0" algn="ctr">
               <a:buNone/>
             </a:pPr>
             <a:r>
@@ -5051,7 +4956,7 @@
           <a:bodyPr wrap="square" lIns="0" tIns="0" rIns="0" bIns="0" rtlCol="0" anchor="ctr"/>
           <a:lstStyle/>
           <a:p>
-            <a:pPr algn="ctr" indent="0" marL="0">
+            <a:pPr marL="0" indent="0" algn="ctr">
               <a:buNone/>
             </a:pPr>
             <a:r>
@@ -5095,6 +5000,13 @@
             <a:prstDash val="solid"/>
           </a:ln>
         </p:spPr>
+        <p:txBody>
+          <a:bodyPr/>
+          <a:lstStyle/>
+          <a:p>
+            <a:endParaRPr lang="en-US"/>
+          </a:p>
+        </p:txBody>
       </p:sp>
       <p:sp>
         <p:nvSpPr>
@@ -5117,7 +5029,7 @@
           <a:bodyPr wrap="square" lIns="0" tIns="0" rIns="0" bIns="0" rtlCol="0" anchor="ctr"/>
           <a:lstStyle/>
           <a:p>
-            <a:pPr algn="ctr" indent="0" marL="0">
+            <a:pPr marL="0" indent="0" algn="ctr">
               <a:buNone/>
             </a:pPr>
             <a:r>
@@ -5161,6 +5073,13 @@
             <a:prstDash val="solid"/>
           </a:ln>
         </p:spPr>
+        <p:txBody>
+          <a:bodyPr/>
+          <a:lstStyle/>
+          <a:p>
+            <a:endParaRPr lang="en-US"/>
+          </a:p>
+        </p:txBody>
       </p:sp>
       <p:sp>
         <p:nvSpPr>
@@ -5183,7 +5102,7 @@
           <a:bodyPr wrap="square" lIns="0" tIns="0" rIns="0" bIns="0" rtlCol="0" anchor="ctr"/>
           <a:lstStyle/>
           <a:p>
-            <a:pPr algn="ctr" indent="0" marL="0">
+            <a:pPr marL="0" indent="0" algn="ctr">
               <a:buNone/>
             </a:pPr>
             <a:r>
@@ -5227,6 +5146,13 @@
             <a:prstDash val="solid"/>
           </a:ln>
         </p:spPr>
+        <p:txBody>
+          <a:bodyPr/>
+          <a:lstStyle/>
+          <a:p>
+            <a:endParaRPr lang="en-US"/>
+          </a:p>
+        </p:txBody>
       </p:sp>
       <p:sp>
         <p:nvSpPr>
@@ -5249,7 +5175,7 @@
           <a:bodyPr wrap="square" lIns="0" tIns="0" rIns="0" bIns="0" rtlCol="0" anchor="ctr"/>
           <a:lstStyle/>
           <a:p>
-            <a:pPr algn="ctr" indent="0" marL="0">
+            <a:pPr marL="0" indent="0" algn="ctr">
               <a:buNone/>
             </a:pPr>
             <a:r>
@@ -5293,6 +5219,13 @@
             <a:prstDash val="solid"/>
           </a:ln>
         </p:spPr>
+        <p:txBody>
+          <a:bodyPr/>
+          <a:lstStyle/>
+          <a:p>
+            <a:endParaRPr lang="en-US"/>
+          </a:p>
+        </p:txBody>
       </p:sp>
       <p:sp>
         <p:nvSpPr>
@@ -5315,7 +5248,7 @@
           <a:bodyPr wrap="square" lIns="0" tIns="0" rIns="0" bIns="0" rtlCol="0" anchor="ctr"/>
           <a:lstStyle/>
           <a:p>
-            <a:pPr algn="ctr" indent="0" marL="0">
+            <a:pPr marL="0" indent="0" algn="ctr">
               <a:buNone/>
             </a:pPr>
             <a:r>
@@ -5359,6 +5292,13 @@
             <a:prstDash val="solid"/>
           </a:ln>
         </p:spPr>
+        <p:txBody>
+          <a:bodyPr/>
+          <a:lstStyle/>
+          <a:p>
+            <a:endParaRPr lang="en-US"/>
+          </a:p>
+        </p:txBody>
       </p:sp>
       <p:sp>
         <p:nvSpPr>
@@ -5381,7 +5321,7 @@
           <a:bodyPr wrap="square" lIns="0" tIns="0" rIns="0" bIns="0" rtlCol="0" anchor="ctr"/>
           <a:lstStyle/>
           <a:p>
-            <a:pPr algn="ctr" indent="0" marL="0">
+            <a:pPr marL="0" indent="0" algn="ctr">
               <a:buNone/>
             </a:pPr>
             <a:r>
@@ -5420,7 +5360,7 @@
           <a:bodyPr wrap="square" lIns="0" tIns="0" rIns="0" bIns="0" rtlCol="0" anchor="ctr"/>
           <a:lstStyle/>
           <a:p>
-            <a:pPr algn="ctr" indent="0" marL="0">
+            <a:pPr marL="0" indent="0" algn="ctr">
               <a:buNone/>
             </a:pPr>
             <a:r>
@@ -5459,7 +5399,7 @@
           <a:bodyPr wrap="square" lIns="0" tIns="0" rIns="0" bIns="0" rtlCol="0" anchor="ctr"/>
           <a:lstStyle/>
           <a:p>
-            <a:pPr indent="0" marL="0">
+            <a:pPr marL="0" indent="0">
               <a:buNone/>
             </a:pPr>
             <a:r>
@@ -5498,7 +5438,7 @@
           <a:bodyPr wrap="square" lIns="0" tIns="0" rIns="0" bIns="0" rtlCol="0" anchor="ctr"/>
           <a:lstStyle/>
           <a:p>
-            <a:pPr algn="r" indent="0" marL="0">
+            <a:pPr marL="0" indent="0" algn="r">
               <a:buNone/>
             </a:pPr>
             <a:r>
@@ -5532,6 +5472,7 @@
         <a:solidFill>
           <a:srgbClr val="FFFFFF"/>
         </a:solidFill>
+        <a:effectLst/>
       </p:bgPr>
     </p:bg>
     <p:spTree>
@@ -5569,11 +5510,11 @@
           <a:bodyPr wrap="square" lIns="0" tIns="0" rIns="0" bIns="0" rtlCol="0" anchor="ctr"/>
           <a:lstStyle/>
           <a:p>
-            <a:pPr indent="0" marL="0">
-              <a:buNone/>
-            </a:pPr>
-            <a:r>
-              <a:rPr lang="en-US" sz="1200" b="1" spc="200" kern="0" dirty="0">
+            <a:pPr marL="0" indent="0">
+              <a:buNone/>
+            </a:pPr>
+            <a:r>
+              <a:rPr lang="en-US" sz="1200" b="1" kern="0" spc="200" dirty="0">
                 <a:solidFill>
                   <a:srgbClr val="5B3DF5"/>
                 </a:solidFill>
@@ -5608,7 +5549,7 @@
           <a:bodyPr wrap="square" lIns="0" tIns="0" rIns="0" bIns="0" rtlCol="0" anchor="t"/>
           <a:lstStyle/>
           <a:p>
-            <a:pPr indent="0" marL="0">
+            <a:pPr marL="0" indent="0">
               <a:buNone/>
             </a:pPr>
             <a:r>
@@ -5652,13 +5593,20 @@
             <a:prstDash val="solid"/>
           </a:ln>
           <a:effectLst>
-            <a:outerShdw sx="100000" sy="100000" kx="0" ky="0" algn="bl" rotWithShape="0" blurRad="114300" dist="38100" dir="8100000">
+            <a:outerShdw blurRad="114300" dist="38100" dir="8100000" algn="bl" rotWithShape="0">
               <a:srgbClr val="17151F">
                 <a:alpha val="12000"/>
               </a:srgbClr>
             </a:outerShdw>
           </a:effectLst>
         </p:spPr>
+        <p:txBody>
+          <a:bodyPr/>
+          <a:lstStyle/>
+          <a:p>
+            <a:endParaRPr lang="en-US"/>
+          </a:p>
+        </p:txBody>
       </p:sp>
       <p:sp>
         <p:nvSpPr>
@@ -5681,7 +5629,7 @@
           <a:bodyPr wrap="square" lIns="0" tIns="0" rIns="0" bIns="0" rtlCol="0" anchor="ctr"/>
           <a:lstStyle/>
           <a:p>
-            <a:pPr algn="ctr" indent="0" marL="0">
+            <a:pPr marL="0" indent="0" algn="ctr">
               <a:buNone/>
             </a:pPr>
             <a:r>
@@ -5720,7 +5668,7 @@
           <a:bodyPr wrap="square" lIns="0" tIns="0" rIns="0" bIns="0" rtlCol="0" anchor="ctr"/>
           <a:lstStyle/>
           <a:p>
-            <a:pPr algn="ctr" indent="0" marL="0">
+            <a:pPr marL="0" indent="0" algn="ctr">
               <a:buNone/>
             </a:pPr>
             <a:r>
@@ -5759,7 +5707,7 @@
           <a:bodyPr wrap="square" lIns="0" tIns="0" rIns="0" bIns="0" rtlCol="0" anchor="ctr"/>
           <a:lstStyle/>
           <a:p>
-            <a:pPr algn="ctr" indent="0" marL="0">
+            <a:pPr marL="0" indent="0" algn="ctr">
               <a:buNone/>
             </a:pPr>
             <a:r>
@@ -5803,13 +5751,20 @@
             <a:prstDash val="solid"/>
           </a:ln>
           <a:effectLst>
-            <a:outerShdw sx="100000" sy="100000" kx="0" ky="0" algn="bl" rotWithShape="0" blurRad="114300" dist="38100" dir="8100000">
+            <a:outerShdw blurRad="114300" dist="38100" dir="8100000" algn="bl" rotWithShape="0">
               <a:srgbClr val="17151F">
                 <a:alpha val="12000"/>
               </a:srgbClr>
             </a:outerShdw>
           </a:effectLst>
         </p:spPr>
+        <p:txBody>
+          <a:bodyPr/>
+          <a:lstStyle/>
+          <a:p>
+            <a:endParaRPr lang="en-US"/>
+          </a:p>
+        </p:txBody>
       </p:sp>
       <p:sp>
         <p:nvSpPr>
@@ -5832,7 +5787,7 @@
           <a:bodyPr wrap="square" lIns="0" tIns="0" rIns="0" bIns="0" rtlCol="0" anchor="ctr"/>
           <a:lstStyle/>
           <a:p>
-            <a:pPr algn="ctr" indent="0" marL="0">
+            <a:pPr marL="0" indent="0" algn="ctr">
               <a:buNone/>
             </a:pPr>
             <a:r>
@@ -5871,7 +5826,7 @@
           <a:bodyPr wrap="square" lIns="0" tIns="0" rIns="0" bIns="0" rtlCol="0" anchor="ctr"/>
           <a:lstStyle/>
           <a:p>
-            <a:pPr algn="ctr" indent="0" marL="0">
+            <a:pPr marL="0" indent="0" algn="ctr">
               <a:buNone/>
             </a:pPr>
             <a:r>
@@ -5910,7 +5865,7 @@
           <a:bodyPr wrap="square" lIns="0" tIns="0" rIns="0" bIns="0" rtlCol="0" anchor="ctr"/>
           <a:lstStyle/>
           <a:p>
-            <a:pPr algn="ctr" indent="0" marL="0">
+            <a:pPr marL="0" indent="0" algn="ctr">
               <a:buNone/>
             </a:pPr>
             <a:r>
@@ -5954,13 +5909,20 @@
             <a:prstDash val="solid"/>
           </a:ln>
           <a:effectLst>
-            <a:outerShdw sx="100000" sy="100000" kx="0" ky="0" algn="bl" rotWithShape="0" blurRad="114300" dist="38100" dir="8100000">
+            <a:outerShdw blurRad="114300" dist="38100" dir="8100000" algn="bl" rotWithShape="0">
               <a:srgbClr val="17151F">
                 <a:alpha val="12000"/>
               </a:srgbClr>
             </a:outerShdw>
           </a:effectLst>
         </p:spPr>
+        <p:txBody>
+          <a:bodyPr/>
+          <a:lstStyle/>
+          <a:p>
+            <a:endParaRPr lang="en-US"/>
+          </a:p>
+        </p:txBody>
       </p:sp>
       <p:sp>
         <p:nvSpPr>
@@ -5983,7 +5945,7 @@
           <a:bodyPr wrap="square" lIns="0" tIns="0" rIns="0" bIns="0" rtlCol="0" anchor="ctr"/>
           <a:lstStyle/>
           <a:p>
-            <a:pPr algn="ctr" indent="0" marL="0">
+            <a:pPr marL="0" indent="0" algn="ctr">
               <a:buNone/>
             </a:pPr>
             <a:r>
@@ -6022,7 +5984,7 @@
           <a:bodyPr wrap="square" lIns="0" tIns="0" rIns="0" bIns="0" rtlCol="0" anchor="ctr"/>
           <a:lstStyle/>
           <a:p>
-            <a:pPr algn="ctr" indent="0" marL="0">
+            <a:pPr marL="0" indent="0" algn="ctr">
               <a:buNone/>
             </a:pPr>
             <a:r>
@@ -6061,7 +6023,7 @@
           <a:bodyPr wrap="square" lIns="0" tIns="0" rIns="0" bIns="0" rtlCol="0" anchor="ctr"/>
           <a:lstStyle/>
           <a:p>
-            <a:pPr algn="ctr" indent="0" marL="0">
+            <a:pPr marL="0" indent="0" algn="ctr">
               <a:buNone/>
             </a:pPr>
             <a:r>
@@ -6100,7 +6062,7 @@
           <a:bodyPr wrap="square" lIns="0" tIns="0" rIns="0" bIns="0" rtlCol="0" anchor="ctr"/>
           <a:lstStyle/>
           <a:p>
-            <a:pPr algn="ctr" indent="0" marL="0">
+            <a:pPr marL="0" indent="0" algn="ctr">
               <a:buNone/>
             </a:pPr>
             <a:r>
@@ -6114,9 +6076,6 @@
               </a:rPr>
               <a:t>And the method works for anything — </a:t>
             </a:r>
-            <a:pPr algn="ctr" indent="0" marL="0">
-              <a:buNone/>
-            </a:pPr>
             <a:r>
               <a:rPr lang="en-US" sz="1800" b="1" dirty="0">
                 <a:solidFill>
@@ -6153,7 +6112,7 @@
           <a:bodyPr wrap="square" lIns="0" tIns="0" rIns="0" bIns="0" rtlCol="0" anchor="ctr"/>
           <a:lstStyle/>
           <a:p>
-            <a:pPr indent="0" marL="0">
+            <a:pPr marL="0" indent="0">
               <a:buNone/>
             </a:pPr>
             <a:r>
@@ -6192,7 +6151,7 @@
           <a:bodyPr wrap="square" lIns="0" tIns="0" rIns="0" bIns="0" rtlCol="0" anchor="ctr"/>
           <a:lstStyle/>
           <a:p>
-            <a:pPr algn="r" indent="0" marL="0">
+            <a:pPr marL="0" indent="0" algn="r">
               <a:buNone/>
             </a:pPr>
             <a:r>
@@ -6226,6 +6185,7 @@
         <a:solidFill>
           <a:srgbClr val="FFFFFF"/>
         </a:solidFill>
+        <a:effectLst/>
       </p:bgPr>
     </p:bg>
     <p:spTree>
@@ -6263,11 +6223,11 @@
           <a:bodyPr wrap="square" lIns="0" tIns="0" rIns="0" bIns="0" rtlCol="0" anchor="ctr"/>
           <a:lstStyle/>
           <a:p>
-            <a:pPr indent="0" marL="0">
-              <a:buNone/>
-            </a:pPr>
-            <a:r>
-              <a:rPr lang="en-US" sz="1200" b="1" spc="200" kern="0" dirty="0">
+            <a:pPr marL="0" indent="0">
+              <a:buNone/>
+            </a:pPr>
+            <a:r>
+              <a:rPr lang="en-US" sz="1200" b="1" kern="0" spc="200" dirty="0">
                 <a:solidFill>
                   <a:srgbClr val="5B3DF5"/>
                 </a:solidFill>
@@ -6302,7 +6262,7 @@
           <a:bodyPr wrap="square" lIns="0" tIns="0" rIns="0" bIns="0" rtlCol="0" anchor="t"/>
           <a:lstStyle/>
           <a:p>
-            <a:pPr indent="0" marL="0">
+            <a:pPr marL="0" indent="0">
               <a:buNone/>
             </a:pPr>
             <a:r>
@@ -6344,6 +6304,13 @@
             <a:prstDash val="solid"/>
           </a:ln>
         </p:spPr>
+        <p:txBody>
+          <a:bodyPr/>
+          <a:lstStyle/>
+          <a:p>
+            <a:endParaRPr lang="en-US"/>
+          </a:p>
+        </p:txBody>
       </p:sp>
       <p:sp>
         <p:nvSpPr>
@@ -6366,7 +6333,7 @@
           <a:bodyPr wrap="square" lIns="0" tIns="0" rIns="0" bIns="0" rtlCol="0" anchor="ctr"/>
           <a:lstStyle/>
           <a:p>
-            <a:pPr algn="ctr" indent="0" marL="0">
+            <a:pPr marL="0" indent="0" algn="ctr">
               <a:buNone/>
             </a:pPr>
             <a:r>
@@ -6405,7 +6372,7 @@
           <a:bodyPr wrap="square" lIns="0" tIns="0" rIns="0" bIns="0" rtlCol="0" anchor="ctr"/>
           <a:lstStyle/>
           <a:p>
-            <a:pPr indent="0" marL="0">
+            <a:pPr marL="0" indent="0">
               <a:buNone/>
             </a:pPr>
             <a:r>
@@ -6444,7 +6411,7 @@
           <a:bodyPr wrap="square" lIns="0" tIns="0" rIns="0" bIns="0" rtlCol="0" anchor="ctr"/>
           <a:lstStyle/>
           <a:p>
-            <a:pPr indent="0" marL="0">
+            <a:pPr marL="0" indent="0">
               <a:buNone/>
             </a:pPr>
             <a:r>
@@ -6486,6 +6453,13 @@
             <a:prstDash val="solid"/>
           </a:ln>
         </p:spPr>
+        <p:txBody>
+          <a:bodyPr/>
+          <a:lstStyle/>
+          <a:p>
+            <a:endParaRPr lang="en-US"/>
+          </a:p>
+        </p:txBody>
       </p:sp>
       <p:sp>
         <p:nvSpPr>
@@ -6508,7 +6482,7 @@
           <a:bodyPr wrap="square" lIns="0" tIns="0" rIns="0" bIns="0" rtlCol="0" anchor="ctr"/>
           <a:lstStyle/>
           <a:p>
-            <a:pPr algn="ctr" indent="0" marL="0">
+            <a:pPr marL="0" indent="0" algn="ctr">
               <a:buNone/>
             </a:pPr>
             <a:r>
@@ -6547,7 +6521,7 @@
           <a:bodyPr wrap="square" lIns="0" tIns="0" rIns="0" bIns="0" rtlCol="0" anchor="ctr"/>
           <a:lstStyle/>
           <a:p>
-            <a:pPr indent="0" marL="0">
+            <a:pPr marL="0" indent="0">
               <a:buNone/>
             </a:pPr>
             <a:r>
@@ -6586,7 +6560,7 @@
           <a:bodyPr wrap="square" lIns="0" tIns="0" rIns="0" bIns="0" rtlCol="0" anchor="ctr"/>
           <a:lstStyle/>
           <a:p>
-            <a:pPr indent="0" marL="0">
+            <a:pPr marL="0" indent="0">
               <a:buNone/>
             </a:pPr>
             <a:r>
@@ -6628,6 +6602,13 @@
             <a:prstDash val="solid"/>
           </a:ln>
         </p:spPr>
+        <p:txBody>
+          <a:bodyPr/>
+          <a:lstStyle/>
+          <a:p>
+            <a:endParaRPr lang="en-US"/>
+          </a:p>
+        </p:txBody>
       </p:sp>
       <p:sp>
         <p:nvSpPr>
@@ -6650,7 +6631,7 @@
           <a:bodyPr wrap="square" lIns="0" tIns="0" rIns="0" bIns="0" rtlCol="0" anchor="ctr"/>
           <a:lstStyle/>
           <a:p>
-            <a:pPr algn="ctr" indent="0" marL="0">
+            <a:pPr marL="0" indent="0" algn="ctr">
               <a:buNone/>
             </a:pPr>
             <a:r>
@@ -6689,7 +6670,7 @@
           <a:bodyPr wrap="square" lIns="0" tIns="0" rIns="0" bIns="0" rtlCol="0" anchor="ctr"/>
           <a:lstStyle/>
           <a:p>
-            <a:pPr indent="0" marL="0">
+            <a:pPr marL="0" indent="0">
               <a:buNone/>
             </a:pPr>
             <a:r>
@@ -6728,7 +6709,7 @@
           <a:bodyPr wrap="square" lIns="0" tIns="0" rIns="0" bIns="0" rtlCol="0" anchor="ctr"/>
           <a:lstStyle/>
           <a:p>
-            <a:pPr indent="0" marL="0">
+            <a:pPr marL="0" indent="0">
               <a:buNone/>
             </a:pPr>
             <a:r>
@@ -6770,6 +6751,13 @@
             <a:prstDash val="solid"/>
           </a:ln>
         </p:spPr>
+        <p:txBody>
+          <a:bodyPr/>
+          <a:lstStyle/>
+          <a:p>
+            <a:endParaRPr lang="en-US"/>
+          </a:p>
+        </p:txBody>
       </p:sp>
       <p:sp>
         <p:nvSpPr>
@@ -6792,7 +6780,7 @@
           <a:bodyPr wrap="square" lIns="0" tIns="0" rIns="0" bIns="0" rtlCol="0" anchor="ctr"/>
           <a:lstStyle/>
           <a:p>
-            <a:pPr algn="ctr" indent="0" marL="0">
+            <a:pPr marL="0" indent="0" algn="ctr">
               <a:buNone/>
             </a:pPr>
             <a:r>
@@ -6831,7 +6819,7 @@
           <a:bodyPr wrap="square" lIns="0" tIns="0" rIns="0" bIns="0" rtlCol="0" anchor="ctr"/>
           <a:lstStyle/>
           <a:p>
-            <a:pPr indent="0" marL="0">
+            <a:pPr marL="0" indent="0">
               <a:buNone/>
             </a:pPr>
             <a:r>
@@ -6870,7 +6858,7 @@
           <a:bodyPr wrap="square" lIns="0" tIns="0" rIns="0" bIns="0" rtlCol="0" anchor="ctr"/>
           <a:lstStyle/>
           <a:p>
-            <a:pPr indent="0" marL="0">
+            <a:pPr marL="0" indent="0">
               <a:buNone/>
             </a:pPr>
             <a:r>
@@ -6912,6 +6900,13 @@
             <a:prstDash val="solid"/>
           </a:ln>
         </p:spPr>
+        <p:txBody>
+          <a:bodyPr/>
+          <a:lstStyle/>
+          <a:p>
+            <a:endParaRPr lang="en-US"/>
+          </a:p>
+        </p:txBody>
       </p:sp>
       <p:sp>
         <p:nvSpPr>
@@ -6934,7 +6929,7 @@
           <a:bodyPr wrap="square" lIns="0" tIns="0" rIns="0" bIns="0" rtlCol="0" anchor="ctr"/>
           <a:lstStyle/>
           <a:p>
-            <a:pPr algn="ctr" indent="0" marL="0">
+            <a:pPr marL="0" indent="0" algn="ctr">
               <a:buNone/>
             </a:pPr>
             <a:r>
@@ -6973,7 +6968,7 @@
           <a:bodyPr wrap="square" lIns="0" tIns="0" rIns="0" bIns="0" rtlCol="0" anchor="ctr"/>
           <a:lstStyle/>
           <a:p>
-            <a:pPr indent="0" marL="0">
+            <a:pPr marL="0" indent="0">
               <a:buNone/>
             </a:pPr>
             <a:r>
@@ -7012,7 +7007,7 @@
           <a:bodyPr wrap="square" lIns="0" tIns="0" rIns="0" bIns="0" rtlCol="0" anchor="ctr"/>
           <a:lstStyle/>
           <a:p>
-            <a:pPr indent="0" marL="0">
+            <a:pPr marL="0" indent="0">
               <a:buNone/>
             </a:pPr>
             <a:r>
@@ -7051,7 +7046,7 @@
           <a:bodyPr wrap="square" lIns="0" tIns="0" rIns="0" bIns="0" rtlCol="0" anchor="ctr"/>
           <a:lstStyle/>
           <a:p>
-            <a:pPr indent="0" marL="0">
+            <a:pPr marL="0" indent="0">
               <a:buNone/>
             </a:pPr>
             <a:r>
@@ -7090,7 +7085,7 @@
           <a:bodyPr wrap="square" lIns="0" tIns="0" rIns="0" bIns="0" rtlCol="0" anchor="ctr"/>
           <a:lstStyle/>
           <a:p>
-            <a:pPr algn="r" indent="0" marL="0">
+            <a:pPr marL="0" indent="0" algn="r">
               <a:buNone/>
             </a:pPr>
             <a:r>
@@ -7124,6 +7119,7 @@
         <a:solidFill>
           <a:srgbClr val="FFFFFF"/>
         </a:solidFill>
+        <a:effectLst/>
       </p:bgPr>
     </p:bg>
     <p:spTree>
@@ -7161,11 +7157,11 @@
           <a:bodyPr wrap="square" lIns="0" tIns="0" rIns="0" bIns="0" rtlCol="0" anchor="ctr"/>
           <a:lstStyle/>
           <a:p>
-            <a:pPr indent="0" marL="0">
-              <a:buNone/>
-            </a:pPr>
-            <a:r>
-              <a:rPr lang="en-US" sz="1200" b="1" spc="200" kern="0" dirty="0">
+            <a:pPr marL="0" indent="0">
+              <a:buNone/>
+            </a:pPr>
+            <a:r>
+              <a:rPr lang="en-US" sz="1200" b="1" kern="0" spc="200" dirty="0">
                 <a:solidFill>
                   <a:srgbClr val="5B3DF5"/>
                 </a:solidFill>
@@ -7200,7 +7196,7 @@
           <a:bodyPr wrap="square" lIns="0" tIns="0" rIns="0" bIns="0" rtlCol="0" anchor="t"/>
           <a:lstStyle/>
           <a:p>
-            <a:pPr indent="0" marL="0">
+            <a:pPr marL="0" indent="0">
               <a:buNone/>
             </a:pPr>
             <a:r>
@@ -7239,11 +7235,11 @@
           <a:bodyPr wrap="square" lIns="0" tIns="0" rIns="0" bIns="0" rtlCol="0" anchor="ctr"/>
           <a:lstStyle/>
           <a:p>
-            <a:pPr indent="0" marL="0">
-              <a:buNone/>
-            </a:pPr>
-            <a:r>
-              <a:rPr lang="en-US" sz="1200" b="1" spc="100" kern="0" dirty="0">
+            <a:pPr marL="0" indent="0">
+              <a:buNone/>
+            </a:pPr>
+            <a:r>
+              <a:rPr lang="en-US" sz="1200" b="1" kern="0" spc="100" dirty="0">
                 <a:solidFill>
                   <a:srgbClr val="6B6770"/>
                 </a:solidFill>
@@ -7279,6 +7275,13 @@
             <a:prstDash val="solid"/>
           </a:ln>
         </p:spPr>
+        <p:txBody>
+          <a:bodyPr/>
+          <a:lstStyle/>
+          <a:p>
+            <a:endParaRPr lang="en-US"/>
+          </a:p>
+        </p:txBody>
       </p:sp>
       <p:sp>
         <p:nvSpPr>
@@ -7306,13 +7309,20 @@
             <a:prstDash val="solid"/>
           </a:ln>
           <a:effectLst>
-            <a:outerShdw sx="100000" sy="100000" kx="0" ky="0" algn="bl" rotWithShape="0" blurRad="114300" dist="38100" dir="8100000">
+            <a:outerShdw blurRad="114300" dist="38100" dir="8100000" algn="bl" rotWithShape="0">
               <a:srgbClr val="17151F">
                 <a:alpha val="12000"/>
               </a:srgbClr>
             </a:outerShdw>
           </a:effectLst>
         </p:spPr>
+        <p:txBody>
+          <a:bodyPr/>
+          <a:lstStyle/>
+          <a:p>
+            <a:endParaRPr lang="en-US"/>
+          </a:p>
+        </p:txBody>
       </p:sp>
       <p:sp>
         <p:nvSpPr>
@@ -7335,7 +7345,7 @@
           <a:bodyPr wrap="square" lIns="0" tIns="0" rIns="0" bIns="0" rtlCol="0" anchor="ctr"/>
           <a:lstStyle/>
           <a:p>
-            <a:pPr indent="0" marL="0">
+            <a:pPr marL="0" indent="0">
               <a:buNone/>
             </a:pPr>
             <a:r>
@@ -7374,11 +7384,11 @@
           <a:bodyPr wrap="square" lIns="0" tIns="0" rIns="0" bIns="0" rtlCol="0" anchor="ctr"/>
           <a:lstStyle/>
           <a:p>
-            <a:pPr indent="0" marL="0">
-              <a:buNone/>
-            </a:pPr>
-            <a:r>
-              <a:rPr lang="en-US" sz="1200" b="1" spc="100" kern="0" dirty="0">
+            <a:pPr marL="0" indent="0">
+              <a:buNone/>
+            </a:pPr>
+            <a:r>
+              <a:rPr lang="en-US" sz="1200" b="1" kern="0" spc="100" dirty="0">
                 <a:solidFill>
                   <a:srgbClr val="6B6770"/>
                 </a:solidFill>
@@ -7414,6 +7424,13 @@
             <a:prstDash val="solid"/>
           </a:ln>
         </p:spPr>
+        <p:txBody>
+          <a:bodyPr/>
+          <a:lstStyle/>
+          <a:p>
+            <a:endParaRPr lang="en-US"/>
+          </a:p>
+        </p:txBody>
       </p:sp>
       <p:sp>
         <p:nvSpPr>
@@ -7441,13 +7458,20 @@
             <a:prstDash val="solid"/>
           </a:ln>
           <a:effectLst>
-            <a:outerShdw sx="100000" sy="100000" kx="0" ky="0" algn="bl" rotWithShape="0" blurRad="114300" dist="38100" dir="8100000">
+            <a:outerShdw blurRad="114300" dist="38100" dir="8100000" algn="bl" rotWithShape="0">
               <a:srgbClr val="17151F">
                 <a:alpha val="12000"/>
               </a:srgbClr>
             </a:outerShdw>
           </a:effectLst>
         </p:spPr>
+        <p:txBody>
+          <a:bodyPr/>
+          <a:lstStyle/>
+          <a:p>
+            <a:endParaRPr lang="en-US"/>
+          </a:p>
+        </p:txBody>
       </p:sp>
       <p:sp>
         <p:nvSpPr>
@@ -7470,7 +7494,7 @@
           <a:bodyPr wrap="square" lIns="0" tIns="0" rIns="0" bIns="0" rtlCol="0" anchor="ctr"/>
           <a:lstStyle/>
           <a:p>
-            <a:pPr indent="0" marL="0">
+            <a:pPr marL="0" indent="0">
               <a:buNone/>
             </a:pPr>
             <a:r>
@@ -7509,11 +7533,11 @@
           <a:bodyPr wrap="square" lIns="0" tIns="0" rIns="0" bIns="0" rtlCol="0" anchor="ctr"/>
           <a:lstStyle/>
           <a:p>
-            <a:pPr indent="0" marL="0">
-              <a:buNone/>
-            </a:pPr>
-            <a:r>
-              <a:rPr lang="en-US" sz="1200" b="1" spc="100" kern="0" dirty="0">
+            <a:pPr marL="0" indent="0">
+              <a:buNone/>
+            </a:pPr>
+            <a:r>
+              <a:rPr lang="en-US" sz="1200" b="1" kern="0" spc="100" dirty="0">
                 <a:solidFill>
                   <a:srgbClr val="B5791A"/>
                 </a:solidFill>
@@ -7549,6 +7573,13 @@
             <a:prstDash val="solid"/>
           </a:ln>
         </p:spPr>
+        <p:txBody>
+          <a:bodyPr/>
+          <a:lstStyle/>
+          <a:p>
+            <a:endParaRPr lang="en-US"/>
+          </a:p>
+        </p:txBody>
       </p:sp>
       <p:sp>
         <p:nvSpPr>
@@ -7576,13 +7607,20 @@
             <a:prstDash val="solid"/>
           </a:ln>
           <a:effectLst>
-            <a:outerShdw sx="100000" sy="100000" kx="0" ky="0" algn="bl" rotWithShape="0" blurRad="114300" dist="38100" dir="8100000">
+            <a:outerShdw blurRad="114300" dist="38100" dir="8100000" algn="bl" rotWithShape="0">
               <a:srgbClr val="17151F">
                 <a:alpha val="12000"/>
               </a:srgbClr>
             </a:outerShdw>
           </a:effectLst>
         </p:spPr>
+        <p:txBody>
+          <a:bodyPr/>
+          <a:lstStyle/>
+          <a:p>
+            <a:endParaRPr lang="en-US"/>
+          </a:p>
+        </p:txBody>
       </p:sp>
       <p:sp>
         <p:nvSpPr>
@@ -7605,7 +7643,7 @@
           <a:bodyPr wrap="square" lIns="0" tIns="0" rIns="0" bIns="0" rtlCol="0" anchor="ctr"/>
           <a:lstStyle/>
           <a:p>
-            <a:pPr indent="0" marL="0">
+            <a:pPr marL="0" indent="0">
               <a:buNone/>
             </a:pPr>
             <a:r>
@@ -7649,13 +7687,20 @@
             <a:prstDash val="solid"/>
           </a:ln>
           <a:effectLst>
-            <a:outerShdw sx="100000" sy="100000" kx="0" ky="0" algn="bl" rotWithShape="0" blurRad="114300" dist="38100" dir="8100000">
+            <a:outerShdw blurRad="114300" dist="38100" dir="8100000" algn="bl" rotWithShape="0">
               <a:srgbClr val="17151F">
                 <a:alpha val="12000"/>
               </a:srgbClr>
             </a:outerShdw>
           </a:effectLst>
         </p:spPr>
+        <p:txBody>
+          <a:bodyPr/>
+          <a:lstStyle/>
+          <a:p>
+            <a:endParaRPr lang="en-US"/>
+          </a:p>
+        </p:txBody>
       </p:sp>
       <p:sp>
         <p:nvSpPr>
@@ -7678,7 +7723,7 @@
           <a:bodyPr wrap="square" lIns="0" tIns="0" rIns="0" bIns="0" rtlCol="0" anchor="ctr"/>
           <a:lstStyle/>
           <a:p>
-            <a:pPr indent="0" marL="0">
+            <a:pPr marL="0" indent="0">
               <a:buNone/>
             </a:pPr>
             <a:r>
@@ -7722,13 +7767,20 @@
             <a:prstDash val="solid"/>
           </a:ln>
           <a:effectLst>
-            <a:outerShdw sx="100000" sy="100000" kx="0" ky="0" algn="bl" rotWithShape="0" blurRad="114300" dist="38100" dir="8100000">
+            <a:outerShdw blurRad="114300" dist="38100" dir="8100000" algn="bl" rotWithShape="0">
               <a:srgbClr val="17151F">
                 <a:alpha val="12000"/>
               </a:srgbClr>
             </a:outerShdw>
           </a:effectLst>
         </p:spPr>
+        <p:txBody>
+          <a:bodyPr/>
+          <a:lstStyle/>
+          <a:p>
+            <a:endParaRPr lang="en-US"/>
+          </a:p>
+        </p:txBody>
       </p:sp>
       <p:sp>
         <p:nvSpPr>
@@ -7751,7 +7803,7 @@
           <a:bodyPr wrap="square" lIns="0" tIns="0" rIns="0" bIns="0" rtlCol="0" anchor="ctr"/>
           <a:lstStyle/>
           <a:p>
-            <a:pPr indent="0" marL="0">
+            <a:pPr marL="0" indent="0">
               <a:buNone/>
             </a:pPr>
             <a:r>
@@ -7790,11 +7842,11 @@
           <a:bodyPr wrap="square" lIns="0" tIns="0" rIns="0" bIns="0" rtlCol="0" anchor="ctr"/>
           <a:lstStyle/>
           <a:p>
-            <a:pPr indent="0" marL="0">
-              <a:buNone/>
-            </a:pPr>
-            <a:r>
-              <a:rPr lang="en-US" sz="1200" b="1" spc="100" kern="0" dirty="0">
+            <a:pPr marL="0" indent="0">
+              <a:buNone/>
+            </a:pPr>
+            <a:r>
+              <a:rPr lang="en-US" sz="1200" b="1" kern="0" spc="100" dirty="0">
                 <a:solidFill>
                   <a:srgbClr val="6B6770"/>
                 </a:solidFill>
@@ -7830,6 +7882,13 @@
             <a:prstDash val="solid"/>
           </a:ln>
         </p:spPr>
+        <p:txBody>
+          <a:bodyPr/>
+          <a:lstStyle/>
+          <a:p>
+            <a:endParaRPr lang="en-US"/>
+          </a:p>
+        </p:txBody>
       </p:sp>
       <p:sp>
         <p:nvSpPr>
@@ -7857,13 +7916,20 @@
             <a:prstDash val="solid"/>
           </a:ln>
           <a:effectLst>
-            <a:outerShdw sx="100000" sy="100000" kx="0" ky="0" algn="bl" rotWithShape="0" blurRad="114300" dist="38100" dir="8100000">
+            <a:outerShdw blurRad="114300" dist="38100" dir="8100000" algn="bl" rotWithShape="0">
               <a:srgbClr val="17151F">
                 <a:alpha val="12000"/>
               </a:srgbClr>
             </a:outerShdw>
           </a:effectLst>
         </p:spPr>
+        <p:txBody>
+          <a:bodyPr/>
+          <a:lstStyle/>
+          <a:p>
+            <a:endParaRPr lang="en-US"/>
+          </a:p>
+        </p:txBody>
       </p:sp>
       <p:sp>
         <p:nvSpPr>
@@ -7886,7 +7952,7 @@
           <a:bodyPr wrap="square" lIns="0" tIns="0" rIns="0" bIns="0" rtlCol="0" anchor="ctr"/>
           <a:lstStyle/>
           <a:p>
-            <a:pPr indent="0" marL="0">
+            <a:pPr marL="0" indent="0">
               <a:buNone/>
             </a:pPr>
             <a:r>
@@ -7930,13 +7996,20 @@
             <a:prstDash val="solid"/>
           </a:ln>
           <a:effectLst>
-            <a:outerShdw sx="100000" sy="100000" kx="0" ky="0" algn="bl" rotWithShape="0" blurRad="114300" dist="38100" dir="8100000">
+            <a:outerShdw blurRad="114300" dist="38100" dir="8100000" algn="bl" rotWithShape="0">
               <a:srgbClr val="17151F">
                 <a:alpha val="12000"/>
               </a:srgbClr>
             </a:outerShdw>
           </a:effectLst>
         </p:spPr>
+        <p:txBody>
+          <a:bodyPr/>
+          <a:lstStyle/>
+          <a:p>
+            <a:endParaRPr lang="en-US"/>
+          </a:p>
+        </p:txBody>
       </p:sp>
       <p:sp>
         <p:nvSpPr>
@@ -7959,7 +8032,7 @@
           <a:bodyPr wrap="square" lIns="0" tIns="0" rIns="0" bIns="0" rtlCol="0" anchor="ctr"/>
           <a:lstStyle/>
           <a:p>
-            <a:pPr indent="0" marL="0">
+            <a:pPr marL="0" indent="0">
               <a:buNone/>
             </a:pPr>
             <a:r>
@@ -8003,13 +8076,20 @@
             <a:prstDash val="solid"/>
           </a:ln>
           <a:effectLst>
-            <a:outerShdw sx="100000" sy="100000" kx="0" ky="0" algn="bl" rotWithShape="0" blurRad="114300" dist="38100" dir="8100000">
+            <a:outerShdw blurRad="114300" dist="38100" dir="8100000" algn="bl" rotWithShape="0">
               <a:srgbClr val="17151F">
                 <a:alpha val="12000"/>
               </a:srgbClr>
             </a:outerShdw>
           </a:effectLst>
         </p:spPr>
+        <p:txBody>
+          <a:bodyPr/>
+          <a:lstStyle/>
+          <a:p>
+            <a:endParaRPr lang="en-US"/>
+          </a:p>
+        </p:txBody>
       </p:sp>
       <p:sp>
         <p:nvSpPr>
@@ -8032,7 +8112,7 @@
           <a:bodyPr wrap="square" lIns="0" tIns="0" rIns="0" bIns="0" rtlCol="0" anchor="ctr"/>
           <a:lstStyle/>
           <a:p>
-            <a:pPr indent="0" marL="0">
+            <a:pPr marL="0" indent="0">
               <a:buNone/>
             </a:pPr>
             <a:r>
@@ -8071,7 +8151,7 @@
           <a:bodyPr wrap="square" lIns="0" tIns="0" rIns="0" bIns="0" rtlCol="0" anchor="ctr"/>
           <a:lstStyle/>
           <a:p>
-            <a:pPr indent="0" marL="0">
+            <a:pPr marL="0" indent="0">
               <a:buNone/>
             </a:pPr>
             <a:r>
@@ -8085,9 +8165,6 @@
               </a:rPr>
               <a:t>The ledger tracks everything — </a:t>
             </a:r>
-            <a:pPr indent="0" marL="0">
-              <a:buNone/>
-            </a:pPr>
             <a:r>
               <a:rPr lang="en-US" sz="1600" b="1" dirty="0">
                 <a:solidFill>
@@ -8124,7 +8201,7 @@
           <a:bodyPr wrap="square" lIns="0" tIns="0" rIns="0" bIns="0" rtlCol="0" anchor="ctr"/>
           <a:lstStyle/>
           <a:p>
-            <a:pPr indent="0" marL="0">
+            <a:pPr marL="0" indent="0">
               <a:buNone/>
             </a:pPr>
             <a:r>
@@ -8163,7 +8240,7 @@
           <a:bodyPr wrap="square" lIns="0" tIns="0" rIns="0" bIns="0" rtlCol="0" anchor="ctr"/>
           <a:lstStyle/>
           <a:p>
-            <a:pPr algn="r" indent="0" marL="0">
+            <a:pPr marL="0" indent="0" algn="r">
               <a:buNone/>
             </a:pPr>
             <a:r>
@@ -8197,6 +8274,7 @@
         <a:solidFill>
           <a:srgbClr val="FFFFFF"/>
         </a:solidFill>
+        <a:effectLst/>
       </p:bgPr>
     </p:bg>
     <p:spTree>
@@ -8234,11 +8312,11 @@
           <a:bodyPr wrap="square" lIns="0" tIns="0" rIns="0" bIns="0" rtlCol="0" anchor="ctr"/>
           <a:lstStyle/>
           <a:p>
-            <a:pPr indent="0" marL="0">
-              <a:buNone/>
-            </a:pPr>
-            <a:r>
-              <a:rPr lang="en-US" sz="1200" b="1" spc="200" kern="0" dirty="0">
+            <a:pPr marL="0" indent="0">
+              <a:buNone/>
+            </a:pPr>
+            <a:r>
+              <a:rPr lang="en-US" sz="1200" b="1" kern="0" spc="200" dirty="0">
                 <a:solidFill>
                   <a:srgbClr val="5B3DF5"/>
                 </a:solidFill>
@@ -8273,7 +8351,7 @@
           <a:bodyPr wrap="square" lIns="0" tIns="0" rIns="0" bIns="0" rtlCol="0" anchor="t"/>
           <a:lstStyle/>
           <a:p>
-            <a:pPr indent="0" marL="0">
+            <a:pPr marL="0" indent="0">
               <a:buNone/>
             </a:pPr>
             <a:r>
@@ -8312,7 +8390,7 @@
           <a:bodyPr wrap="square" lIns="0" tIns="0" rIns="0" bIns="0" rtlCol="0" anchor="ctr"/>
           <a:lstStyle/>
           <a:p>
-            <a:pPr algn="ctr" indent="0" marL="0">
+            <a:pPr marL="0" indent="0" algn="ctr">
               <a:buNone/>
             </a:pPr>
             <a:r>
@@ -8356,13 +8434,20 @@
             <a:prstDash val="solid"/>
           </a:ln>
           <a:effectLst>
-            <a:outerShdw sx="100000" sy="100000" kx="0" ky="0" algn="bl" rotWithShape="0" blurRad="114300" dist="38100" dir="8100000">
+            <a:outerShdw blurRad="114300" dist="38100" dir="8100000" algn="bl" rotWithShape="0">
               <a:srgbClr val="17151F">
                 <a:alpha val="12000"/>
               </a:srgbClr>
             </a:outerShdw>
           </a:effectLst>
         </p:spPr>
+        <p:txBody>
+          <a:bodyPr/>
+          <a:lstStyle/>
+          <a:p>
+            <a:endParaRPr lang="en-US"/>
+          </a:p>
+        </p:txBody>
       </p:sp>
       <p:sp>
         <p:nvSpPr>
@@ -8390,13 +8475,20 @@
             <a:prstDash val="solid"/>
           </a:ln>
           <a:effectLst>
-            <a:outerShdw sx="100000" sy="100000" kx="0" ky="0" algn="bl" rotWithShape="0" blurRad="114300" dist="38100" dir="8100000">
+            <a:outerShdw blurRad="114300" dist="38100" dir="8100000" algn="bl" rotWithShape="0">
               <a:srgbClr val="17151F">
                 <a:alpha val="12000"/>
               </a:srgbClr>
             </a:outerShdw>
           </a:effectLst>
         </p:spPr>
+        <p:txBody>
+          <a:bodyPr/>
+          <a:lstStyle/>
+          <a:p>
+            <a:endParaRPr lang="en-US"/>
+          </a:p>
+        </p:txBody>
       </p:sp>
       <p:sp>
         <p:nvSpPr>
@@ -8424,13 +8516,20 @@
             <a:prstDash val="solid"/>
           </a:ln>
           <a:effectLst>
-            <a:outerShdw sx="100000" sy="100000" kx="0" ky="0" algn="bl" rotWithShape="0" blurRad="114300" dist="38100" dir="8100000">
+            <a:outerShdw blurRad="114300" dist="38100" dir="8100000" algn="bl" rotWithShape="0">
               <a:srgbClr val="17151F">
                 <a:alpha val="12000"/>
               </a:srgbClr>
             </a:outerShdw>
           </a:effectLst>
         </p:spPr>
+        <p:txBody>
+          <a:bodyPr/>
+          <a:lstStyle/>
+          <a:p>
+            <a:endParaRPr lang="en-US"/>
+          </a:p>
+        </p:txBody>
       </p:sp>
       <p:sp>
         <p:nvSpPr>
@@ -8453,7 +8552,7 @@
           <a:bodyPr wrap="square" lIns="0" tIns="0" rIns="0" bIns="0" rtlCol="0" anchor="ctr"/>
           <a:lstStyle/>
           <a:p>
-            <a:pPr algn="ctr" indent="0" marL="0">
+            <a:pPr marL="0" indent="0" algn="ctr">
               <a:buNone/>
             </a:pPr>
             <a:r>
@@ -8492,7 +8591,7 @@
           <a:bodyPr wrap="square" lIns="0" tIns="0" rIns="0" bIns="0" rtlCol="0" anchor="ctr"/>
           <a:lstStyle/>
           <a:p>
-            <a:pPr algn="ctr" indent="0" marL="0">
+            <a:pPr marL="0" indent="0" algn="ctr">
               <a:buNone/>
             </a:pPr>
             <a:r>
@@ -8531,7 +8630,7 @@
           <a:bodyPr wrap="square" lIns="0" tIns="0" rIns="0" bIns="0" rtlCol="0" anchor="ctr"/>
           <a:lstStyle/>
           <a:p>
-            <a:pPr algn="ctr" indent="0" marL="0">
+            <a:pPr marL="0" indent="0" algn="ctr">
               <a:buNone/>
             </a:pPr>
             <a:r>
@@ -8575,13 +8674,20 @@
             <a:prstDash val="solid"/>
           </a:ln>
           <a:effectLst>
-            <a:outerShdw sx="100000" sy="100000" kx="0" ky="0" algn="bl" rotWithShape="0" blurRad="114300" dist="38100" dir="8100000">
+            <a:outerShdw blurRad="114300" dist="38100" dir="8100000" algn="bl" rotWithShape="0">
               <a:srgbClr val="17151F">
                 <a:alpha val="12000"/>
               </a:srgbClr>
             </a:outerShdw>
           </a:effectLst>
         </p:spPr>
+        <p:txBody>
+          <a:bodyPr/>
+          <a:lstStyle/>
+          <a:p>
+            <a:endParaRPr lang="en-US"/>
+          </a:p>
+        </p:txBody>
       </p:sp>
       <p:sp>
         <p:nvSpPr>
@@ -8604,7 +8710,7 @@
           <a:bodyPr wrap="square" lIns="0" tIns="0" rIns="0" bIns="0" rtlCol="0" anchor="ctr"/>
           <a:lstStyle/>
           <a:p>
-            <a:pPr algn="ctr" indent="0" marL="0">
+            <a:pPr marL="0" indent="0" algn="ctr">
               <a:buNone/>
             </a:pPr>
             <a:r>
@@ -8643,7 +8749,7 @@
           <a:bodyPr wrap="square" lIns="0" tIns="0" rIns="0" bIns="0" rtlCol="0" anchor="ctr"/>
           <a:lstStyle/>
           <a:p>
-            <a:pPr algn="ctr" indent="0" marL="0">
+            <a:pPr marL="0" indent="0" algn="ctr">
               <a:buNone/>
             </a:pPr>
             <a:r>
@@ -8682,7 +8788,7 @@
           <a:bodyPr wrap="square" lIns="0" tIns="0" rIns="0" bIns="0" rtlCol="0" anchor="ctr"/>
           <a:lstStyle/>
           <a:p>
-            <a:pPr algn="ctr" indent="0" marL="0">
+            <a:pPr marL="0" indent="0" algn="ctr">
               <a:buNone/>
             </a:pPr>
             <a:r>
@@ -8726,13 +8832,20 @@
             <a:prstDash val="solid"/>
           </a:ln>
           <a:effectLst>
-            <a:outerShdw sx="100000" sy="100000" kx="0" ky="0" algn="bl" rotWithShape="0" blurRad="114300" dist="38100" dir="8100000">
+            <a:outerShdw blurRad="114300" dist="38100" dir="8100000" algn="bl" rotWithShape="0">
               <a:srgbClr val="17151F">
                 <a:alpha val="12000"/>
               </a:srgbClr>
             </a:outerShdw>
           </a:effectLst>
         </p:spPr>
+        <p:txBody>
+          <a:bodyPr/>
+          <a:lstStyle/>
+          <a:p>
+            <a:endParaRPr lang="en-US"/>
+          </a:p>
+        </p:txBody>
       </p:sp>
       <p:sp>
         <p:nvSpPr>
@@ -8755,7 +8868,7 @@
           <a:bodyPr wrap="square" lIns="0" tIns="0" rIns="0" bIns="0" rtlCol="0" anchor="ctr"/>
           <a:lstStyle/>
           <a:p>
-            <a:pPr algn="ctr" indent="0" marL="0">
+            <a:pPr marL="0" indent="0" algn="ctr">
               <a:buNone/>
             </a:pPr>
             <a:r>
@@ -8794,7 +8907,7 @@
           <a:bodyPr wrap="square" lIns="0" tIns="0" rIns="0" bIns="0" rtlCol="0" anchor="ctr"/>
           <a:lstStyle/>
           <a:p>
-            <a:pPr algn="ctr" indent="0" marL="0">
+            <a:pPr marL="0" indent="0" algn="ctr">
               <a:buNone/>
             </a:pPr>
             <a:r>
@@ -8833,7 +8946,7 @@
           <a:bodyPr wrap="square" lIns="0" tIns="0" rIns="0" bIns="0" rtlCol="0" anchor="ctr"/>
           <a:lstStyle/>
           <a:p>
-            <a:pPr algn="ctr" indent="0" marL="0">
+            <a:pPr marL="0" indent="0" algn="ctr">
               <a:buNone/>
             </a:pPr>
             <a:r>
@@ -8877,13 +8990,20 @@
             <a:prstDash val="solid"/>
           </a:ln>
           <a:effectLst>
-            <a:outerShdw sx="100000" sy="100000" kx="0" ky="0" algn="bl" rotWithShape="0" blurRad="114300" dist="38100" dir="8100000">
+            <a:outerShdw blurRad="114300" dist="38100" dir="8100000" algn="bl" rotWithShape="0">
               <a:srgbClr val="17151F">
                 <a:alpha val="12000"/>
               </a:srgbClr>
             </a:outerShdw>
           </a:effectLst>
         </p:spPr>
+        <p:txBody>
+          <a:bodyPr/>
+          <a:lstStyle/>
+          <a:p>
+            <a:endParaRPr lang="en-US"/>
+          </a:p>
+        </p:txBody>
       </p:sp>
       <p:sp>
         <p:nvSpPr>
@@ -8911,13 +9031,20 @@
             <a:prstDash val="solid"/>
           </a:ln>
           <a:effectLst>
-            <a:outerShdw sx="100000" sy="100000" kx="0" ky="0" algn="bl" rotWithShape="0" blurRad="114300" dist="38100" dir="8100000">
+            <a:outerShdw blurRad="114300" dist="38100" dir="8100000" algn="bl" rotWithShape="0">
               <a:srgbClr val="17151F">
                 <a:alpha val="12000"/>
               </a:srgbClr>
             </a:outerShdw>
           </a:effectLst>
         </p:spPr>
+        <p:txBody>
+          <a:bodyPr/>
+          <a:lstStyle/>
+          <a:p>
+            <a:endParaRPr lang="en-US"/>
+          </a:p>
+        </p:txBody>
       </p:sp>
       <p:sp>
         <p:nvSpPr>
@@ -8945,13 +9072,20 @@
             <a:prstDash val="solid"/>
           </a:ln>
           <a:effectLst>
-            <a:outerShdw sx="100000" sy="100000" kx="0" ky="0" algn="bl" rotWithShape="0" blurRad="114300" dist="38100" dir="8100000">
+            <a:outerShdw blurRad="114300" dist="38100" dir="8100000" algn="bl" rotWithShape="0">
               <a:srgbClr val="17151F">
                 <a:alpha val="12000"/>
               </a:srgbClr>
             </a:outerShdw>
           </a:effectLst>
         </p:spPr>
+        <p:txBody>
+          <a:bodyPr/>
+          <a:lstStyle/>
+          <a:p>
+            <a:endParaRPr lang="en-US"/>
+          </a:p>
+        </p:txBody>
       </p:sp>
       <p:sp>
         <p:nvSpPr>
@@ -8979,13 +9113,20 @@
             <a:prstDash val="solid"/>
           </a:ln>
           <a:effectLst>
-            <a:outerShdw sx="100000" sy="100000" kx="0" ky="0" algn="bl" rotWithShape="0" blurRad="114300" dist="38100" dir="8100000">
+            <a:outerShdw blurRad="114300" dist="38100" dir="8100000" algn="bl" rotWithShape="0">
               <a:srgbClr val="17151F">
                 <a:alpha val="12000"/>
               </a:srgbClr>
             </a:outerShdw>
           </a:effectLst>
         </p:spPr>
+        <p:txBody>
+          <a:bodyPr/>
+          <a:lstStyle/>
+          <a:p>
+            <a:endParaRPr lang="en-US"/>
+          </a:p>
+        </p:txBody>
       </p:sp>
       <p:sp>
         <p:nvSpPr>
@@ -9008,7 +9149,7 @@
           <a:bodyPr wrap="square" lIns="0" tIns="0" rIns="0" bIns="0" rtlCol="0" anchor="ctr"/>
           <a:lstStyle/>
           <a:p>
-            <a:pPr algn="ctr" indent="0" marL="0">
+            <a:pPr marL="0" indent="0" algn="ctr">
               <a:buNone/>
             </a:pPr>
             <a:r>
@@ -9047,7 +9188,7 @@
           <a:bodyPr wrap="square" lIns="0" tIns="0" rIns="0" bIns="0" rtlCol="0" anchor="ctr"/>
           <a:lstStyle/>
           <a:p>
-            <a:pPr algn="ctr" indent="0" marL="0">
+            <a:pPr marL="0" indent="0" algn="ctr">
               <a:buNone/>
             </a:pPr>
             <a:r>
@@ -9086,7 +9227,7 @@
           <a:bodyPr wrap="square" lIns="0" tIns="0" rIns="0" bIns="0" rtlCol="0" anchor="ctr"/>
           <a:lstStyle/>
           <a:p>
-            <a:pPr algn="ctr" indent="0" marL="0">
+            <a:pPr marL="0" indent="0" algn="ctr">
               <a:buNone/>
             </a:pPr>
             <a:r>
@@ -9130,13 +9271,20 @@
             <a:prstDash val="solid"/>
           </a:ln>
           <a:effectLst>
-            <a:outerShdw sx="100000" sy="100000" kx="0" ky="0" algn="bl" rotWithShape="0" blurRad="114300" dist="38100" dir="8100000">
+            <a:outerShdw blurRad="114300" dist="38100" dir="8100000" algn="bl" rotWithShape="0">
               <a:srgbClr val="17151F">
                 <a:alpha val="12000"/>
               </a:srgbClr>
             </a:outerShdw>
           </a:effectLst>
         </p:spPr>
+        <p:txBody>
+          <a:bodyPr/>
+          <a:lstStyle/>
+          <a:p>
+            <a:endParaRPr lang="en-US"/>
+          </a:p>
+        </p:txBody>
       </p:sp>
       <p:sp>
         <p:nvSpPr>
@@ -9159,7 +9307,7 @@
           <a:bodyPr wrap="square" lIns="0" tIns="0" rIns="0" bIns="0" rtlCol="0" anchor="ctr"/>
           <a:lstStyle/>
           <a:p>
-            <a:pPr algn="ctr" indent="0" marL="0">
+            <a:pPr marL="0" indent="0" algn="ctr">
               <a:buNone/>
             </a:pPr>
             <a:r>
@@ -9198,7 +9346,7 @@
           <a:bodyPr wrap="square" lIns="0" tIns="0" rIns="0" bIns="0" rtlCol="0" anchor="ctr"/>
           <a:lstStyle/>
           <a:p>
-            <a:pPr algn="ctr" indent="0" marL="0">
+            <a:pPr marL="0" indent="0" algn="ctr">
               <a:buNone/>
             </a:pPr>
             <a:r>
@@ -9212,9 +9360,6 @@
               </a:rPr>
               <a:t>Parallel where independent</a:t>
             </a:r>
-            <a:pPr algn="ctr" indent="0" marL="0">
-              <a:buNone/>
-            </a:pPr>
             <a:r>
               <a:rPr lang="en-US" sz="1700" dirty="0">
                 <a:solidFill>
@@ -9251,7 +9396,7 @@
           <a:bodyPr wrap="square" lIns="0" tIns="0" rIns="0" bIns="0" rtlCol="0" anchor="ctr"/>
           <a:lstStyle/>
           <a:p>
-            <a:pPr indent="0" marL="0">
+            <a:pPr marL="0" indent="0">
               <a:buNone/>
             </a:pPr>
             <a:r>
@@ -9290,7 +9435,7 @@
           <a:bodyPr wrap="square" lIns="0" tIns="0" rIns="0" bIns="0" rtlCol="0" anchor="ctr"/>
           <a:lstStyle/>
           <a:p>
-            <a:pPr algn="r" indent="0" marL="0">
+            <a:pPr marL="0" indent="0" algn="r">
               <a:buNone/>
             </a:pPr>
             <a:r>
@@ -9324,6 +9469,7 @@
         <a:solidFill>
           <a:srgbClr val="FFFFFF"/>
         </a:solidFill>
+        <a:effectLst/>
       </p:bgPr>
     </p:bg>
     <p:spTree>
@@ -9361,11 +9507,11 @@
           <a:bodyPr wrap="square" lIns="0" tIns="0" rIns="0" bIns="0" rtlCol="0" anchor="ctr"/>
           <a:lstStyle/>
           <a:p>
-            <a:pPr indent="0" marL="0">
-              <a:buNone/>
-            </a:pPr>
-            <a:r>
-              <a:rPr lang="en-US" sz="1200" b="1" spc="200" kern="0" dirty="0">
+            <a:pPr marL="0" indent="0">
+              <a:buNone/>
+            </a:pPr>
+            <a:r>
+              <a:rPr lang="en-US" sz="1200" b="1" kern="0" spc="200" dirty="0">
                 <a:solidFill>
                   <a:srgbClr val="5B3DF5"/>
                 </a:solidFill>
@@ -9400,7 +9546,7 @@
           <a:bodyPr wrap="square" lIns="0" tIns="0" rIns="0" bIns="0" rtlCol="0" anchor="t"/>
           <a:lstStyle/>
           <a:p>
-            <a:pPr indent="0" marL="0">
+            <a:pPr marL="0" indent="0">
               <a:buNone/>
             </a:pPr>
             <a:r>
@@ -9444,13 +9590,20 @@
             <a:prstDash val="solid"/>
           </a:ln>
           <a:effectLst>
-            <a:outerShdw sx="100000" sy="100000" kx="0" ky="0" algn="bl" rotWithShape="0" blurRad="114300" dist="38100" dir="8100000">
+            <a:outerShdw blurRad="114300" dist="38100" dir="8100000" algn="bl" rotWithShape="0">
               <a:srgbClr val="17151F">
                 <a:alpha val="12000"/>
               </a:srgbClr>
             </a:outerShdw>
           </a:effectLst>
         </p:spPr>
+        <p:txBody>
+          <a:bodyPr/>
+          <a:lstStyle/>
+          <a:p>
+            <a:endParaRPr lang="en-US"/>
+          </a:p>
+        </p:txBody>
       </p:sp>
       <p:sp>
         <p:nvSpPr>
@@ -9471,6 +9624,13 @@
           </a:solidFill>
           <a:ln/>
         </p:spPr>
+        <p:txBody>
+          <a:bodyPr/>
+          <a:lstStyle/>
+          <a:p>
+            <a:endParaRPr lang="en-US"/>
+          </a:p>
+        </p:txBody>
       </p:sp>
       <p:sp>
         <p:nvSpPr>
@@ -9493,7 +9653,7 @@
           <a:bodyPr wrap="square" lIns="0" tIns="0" rIns="0" bIns="0" rtlCol="0" anchor="ctr"/>
           <a:lstStyle/>
           <a:p>
-            <a:pPr indent="0" marL="0">
+            <a:pPr marL="0" indent="0">
               <a:buNone/>
             </a:pPr>
             <a:r>
@@ -9532,7 +9692,7 @@
           <a:bodyPr wrap="square" lIns="0" tIns="0" rIns="0" bIns="0" rtlCol="0" anchor="ctr"/>
           <a:lstStyle/>
           <a:p>
-            <a:pPr indent="0" marL="0">
+            <a:pPr marL="0" indent="0">
               <a:lnSpc>
                 <a:spcPct val="105000"/>
               </a:lnSpc>
@@ -9574,7 +9734,7 @@
           <a:bodyPr wrap="square" lIns="0" tIns="0" rIns="0" bIns="0" rtlCol="0" anchor="ctr"/>
           <a:lstStyle/>
           <a:p>
-            <a:pPr indent="0" marL="0">
+            <a:pPr marL="0" indent="0">
               <a:buNone/>
             </a:pPr>
             <a:r>
@@ -9618,13 +9778,20 @@
             <a:prstDash val="solid"/>
           </a:ln>
           <a:effectLst>
-            <a:outerShdw sx="100000" sy="100000" kx="0" ky="0" algn="bl" rotWithShape="0" blurRad="114300" dist="38100" dir="8100000">
+            <a:outerShdw blurRad="114300" dist="38100" dir="8100000" algn="bl" rotWithShape="0">
               <a:srgbClr val="17151F">
                 <a:alpha val="12000"/>
               </a:srgbClr>
             </a:outerShdw>
           </a:effectLst>
         </p:spPr>
+        <p:txBody>
+          <a:bodyPr/>
+          <a:lstStyle/>
+          <a:p>
+            <a:endParaRPr lang="en-US"/>
+          </a:p>
+        </p:txBody>
       </p:sp>
       <p:sp>
         <p:nvSpPr>
@@ -9645,6 +9812,13 @@
           </a:solidFill>
           <a:ln/>
         </p:spPr>
+        <p:txBody>
+          <a:bodyPr/>
+          <a:lstStyle/>
+          <a:p>
+            <a:endParaRPr lang="en-US"/>
+          </a:p>
+        </p:txBody>
       </p:sp>
       <p:sp>
         <p:nvSpPr>
@@ -9667,7 +9841,7 @@
           <a:bodyPr wrap="square" lIns="0" tIns="0" rIns="0" bIns="0" rtlCol="0" anchor="ctr"/>
           <a:lstStyle/>
           <a:p>
-            <a:pPr indent="0" marL="0">
+            <a:pPr marL="0" indent="0">
               <a:buNone/>
             </a:pPr>
             <a:r>
@@ -9706,7 +9880,7 @@
           <a:bodyPr wrap="square" lIns="0" tIns="0" rIns="0" bIns="0" rtlCol="0" anchor="ctr"/>
           <a:lstStyle/>
           <a:p>
-            <a:pPr indent="0" marL="0">
+            <a:pPr marL="0" indent="0">
               <a:lnSpc>
                 <a:spcPct val="105000"/>
               </a:lnSpc>
@@ -9748,7 +9922,7 @@
           <a:bodyPr wrap="square" lIns="0" tIns="0" rIns="0" bIns="0" rtlCol="0" anchor="ctr"/>
           <a:lstStyle/>
           <a:p>
-            <a:pPr indent="0" marL="0">
+            <a:pPr marL="0" indent="0">
               <a:buNone/>
             </a:pPr>
             <a:r>
@@ -9792,13 +9966,20 @@
             <a:prstDash val="solid"/>
           </a:ln>
           <a:effectLst>
-            <a:outerShdw sx="100000" sy="100000" kx="0" ky="0" algn="bl" rotWithShape="0" blurRad="114300" dist="38100" dir="8100000">
+            <a:outerShdw blurRad="114300" dist="38100" dir="8100000" algn="bl" rotWithShape="0">
               <a:srgbClr val="17151F">
                 <a:alpha val="12000"/>
               </a:srgbClr>
             </a:outerShdw>
           </a:effectLst>
         </p:spPr>
+        <p:txBody>
+          <a:bodyPr/>
+          <a:lstStyle/>
+          <a:p>
+            <a:endParaRPr lang="en-US"/>
+          </a:p>
+        </p:txBody>
       </p:sp>
       <p:sp>
         <p:nvSpPr>
@@ -9819,6 +10000,13 @@
           </a:solidFill>
           <a:ln/>
         </p:spPr>
+        <p:txBody>
+          <a:bodyPr/>
+          <a:lstStyle/>
+          <a:p>
+            <a:endParaRPr lang="en-US"/>
+          </a:p>
+        </p:txBody>
       </p:sp>
       <p:sp>
         <p:nvSpPr>
@@ -9841,7 +10029,7 @@
           <a:bodyPr wrap="square" lIns="0" tIns="0" rIns="0" bIns="0" rtlCol="0" anchor="ctr"/>
           <a:lstStyle/>
           <a:p>
-            <a:pPr indent="0" marL="0">
+            <a:pPr marL="0" indent="0">
               <a:buNone/>
             </a:pPr>
             <a:r>
@@ -9880,7 +10068,7 @@
           <a:bodyPr wrap="square" lIns="0" tIns="0" rIns="0" bIns="0" rtlCol="0" anchor="ctr"/>
           <a:lstStyle/>
           <a:p>
-            <a:pPr indent="0" marL="0">
+            <a:pPr marL="0" indent="0">
               <a:lnSpc>
                 <a:spcPct val="105000"/>
               </a:lnSpc>
@@ -9922,7 +10110,7 @@
           <a:bodyPr wrap="square" lIns="0" tIns="0" rIns="0" bIns="0" rtlCol="0" anchor="ctr"/>
           <a:lstStyle/>
           <a:p>
-            <a:pPr indent="0" marL="0">
+            <a:pPr marL="0" indent="0">
               <a:buNone/>
             </a:pPr>
             <a:r>
@@ -9966,13 +10154,20 @@
             <a:prstDash val="solid"/>
           </a:ln>
           <a:effectLst>
-            <a:outerShdw sx="100000" sy="100000" kx="0" ky="0" algn="bl" rotWithShape="0" blurRad="114300" dist="38100" dir="8100000">
+            <a:outerShdw blurRad="114300" dist="38100" dir="8100000" algn="bl" rotWithShape="0">
               <a:srgbClr val="17151F">
                 <a:alpha val="12000"/>
               </a:srgbClr>
             </a:outerShdw>
           </a:effectLst>
         </p:spPr>
+        <p:txBody>
+          <a:bodyPr/>
+          <a:lstStyle/>
+          <a:p>
+            <a:endParaRPr lang="en-US"/>
+          </a:p>
+        </p:txBody>
       </p:sp>
       <p:sp>
         <p:nvSpPr>
@@ -9993,6 +10188,13 @@
           </a:solidFill>
           <a:ln/>
         </p:spPr>
+        <p:txBody>
+          <a:bodyPr/>
+          <a:lstStyle/>
+          <a:p>
+            <a:endParaRPr lang="en-US"/>
+          </a:p>
+        </p:txBody>
       </p:sp>
       <p:sp>
         <p:nvSpPr>
@@ -10015,7 +10217,7 @@
           <a:bodyPr wrap="square" lIns="0" tIns="0" rIns="0" bIns="0" rtlCol="0" anchor="ctr"/>
           <a:lstStyle/>
           <a:p>
-            <a:pPr indent="0" marL="0">
+            <a:pPr marL="0" indent="0">
               <a:buNone/>
             </a:pPr>
             <a:r>
@@ -10054,7 +10256,7 @@
           <a:bodyPr wrap="square" lIns="0" tIns="0" rIns="0" bIns="0" rtlCol="0" anchor="ctr"/>
           <a:lstStyle/>
           <a:p>
-            <a:pPr indent="0" marL="0">
+            <a:pPr marL="0" indent="0">
               <a:lnSpc>
                 <a:spcPct val="105000"/>
               </a:lnSpc>
@@ -10096,7 +10298,7 @@
           <a:bodyPr wrap="square" lIns="0" tIns="0" rIns="0" bIns="0" rtlCol="0" anchor="ctr"/>
           <a:lstStyle/>
           <a:p>
-            <a:pPr indent="0" marL="0">
+            <a:pPr marL="0" indent="0">
               <a:buNone/>
             </a:pPr>
             <a:r>
@@ -10135,7 +10337,7 @@
           <a:bodyPr wrap="square" lIns="0" tIns="0" rIns="0" bIns="0" rtlCol="0" anchor="ctr"/>
           <a:lstStyle/>
           <a:p>
-            <a:pPr indent="0" marL="0">
+            <a:pPr marL="0" indent="0">
               <a:buNone/>
             </a:pPr>
             <a:r>
@@ -10174,7 +10376,7 @@
           <a:bodyPr wrap="square" lIns="0" tIns="0" rIns="0" bIns="0" rtlCol="0" anchor="ctr"/>
           <a:lstStyle/>
           <a:p>
-            <a:pPr algn="r" indent="0" marL="0">
+            <a:pPr marL="0" indent="0" algn="r">
               <a:buNone/>
             </a:pPr>
             <a:r>
@@ -10208,6 +10410,7 @@
         <a:solidFill>
           <a:srgbClr val="FFFFFF"/>
         </a:solidFill>
+        <a:effectLst/>
       </p:bgPr>
     </p:bg>
     <p:spTree>
@@ -10245,11 +10448,11 @@
           <a:bodyPr wrap="square" lIns="0" tIns="0" rIns="0" bIns="0" rtlCol="0" anchor="ctr"/>
           <a:lstStyle/>
           <a:p>
-            <a:pPr indent="0" marL="0">
-              <a:buNone/>
-            </a:pPr>
-            <a:r>
-              <a:rPr lang="en-US" sz="1200" b="1" spc="200" kern="0" dirty="0">
+            <a:pPr marL="0" indent="0">
+              <a:buNone/>
+            </a:pPr>
+            <a:r>
+              <a:rPr lang="en-US" sz="1200" b="1" kern="0" spc="200" dirty="0">
                 <a:solidFill>
                   <a:srgbClr val="5B3DF5"/>
                 </a:solidFill>
@@ -10284,7 +10487,7 @@
           <a:bodyPr wrap="square" lIns="0" tIns="0" rIns="0" bIns="0" rtlCol="0" anchor="t"/>
           <a:lstStyle/>
           <a:p>
-            <a:pPr indent="0" marL="0">
+            <a:pPr marL="0" indent="0">
               <a:buNone/>
             </a:pPr>
             <a:r>
@@ -10323,7 +10526,7 @@
           <a:bodyPr wrap="square" lIns="0" tIns="0" rIns="0" bIns="0" rtlCol="0" anchor="ctr"/>
           <a:lstStyle/>
           <a:p>
-            <a:pPr indent="0" marL="0">
+            <a:pPr marL="0" indent="0">
               <a:buNone/>
             </a:pPr>
             <a:r>
@@ -10367,6 +10570,13 @@
             <a:prstDash val="solid"/>
           </a:ln>
         </p:spPr>
+        <p:txBody>
+          <a:bodyPr/>
+          <a:lstStyle/>
+          <a:p>
+            <a:endParaRPr lang="en-US"/>
+          </a:p>
+        </p:txBody>
       </p:sp>
       <p:sp>
         <p:nvSpPr>
@@ -10394,6 +10604,13 @@
             <a:prstDash val="solid"/>
           </a:ln>
         </p:spPr>
+        <p:txBody>
+          <a:bodyPr/>
+          <a:lstStyle/>
+          <a:p>
+            <a:endParaRPr lang="en-US"/>
+          </a:p>
+        </p:txBody>
       </p:sp>
       <p:sp>
         <p:nvSpPr>
@@ -10416,7 +10633,7 @@
           <a:bodyPr wrap="square" lIns="0" tIns="0" rIns="0" bIns="0" rtlCol="0" anchor="ctr"/>
           <a:lstStyle/>
           <a:p>
-            <a:pPr indent="0" marL="0">
+            <a:pPr marL="0" indent="0">
               <a:buNone/>
             </a:pPr>
             <a:r>
@@ -10455,7 +10672,7 @@
           <a:bodyPr wrap="square" lIns="0" tIns="0" rIns="0" bIns="0" rtlCol="0" anchor="ctr"/>
           <a:lstStyle/>
           <a:p>
-            <a:pPr indent="0" marL="0">
+            <a:pPr marL="0" indent="0">
               <a:buNone/>
             </a:pPr>
             <a:r>
@@ -10499,6 +10716,13 @@
             <a:prstDash val="solid"/>
           </a:ln>
         </p:spPr>
+        <p:txBody>
+          <a:bodyPr/>
+          <a:lstStyle/>
+          <a:p>
+            <a:endParaRPr lang="en-US"/>
+          </a:p>
+        </p:txBody>
       </p:sp>
       <p:sp>
         <p:nvSpPr>
@@ -10526,6 +10750,13 @@
             <a:prstDash val="solid"/>
           </a:ln>
         </p:spPr>
+        <p:txBody>
+          <a:bodyPr/>
+          <a:lstStyle/>
+          <a:p>
+            <a:endParaRPr lang="en-US"/>
+          </a:p>
+        </p:txBody>
       </p:sp>
       <p:sp>
         <p:nvSpPr>
@@ -10548,7 +10779,7 @@
           <a:bodyPr wrap="square" lIns="0" tIns="0" rIns="0" bIns="0" rtlCol="0" anchor="ctr"/>
           <a:lstStyle/>
           <a:p>
-            <a:pPr indent="0" marL="0">
+            <a:pPr marL="0" indent="0">
               <a:buNone/>
             </a:pPr>
             <a:r>
@@ -10587,7 +10818,7 @@
           <a:bodyPr wrap="square" lIns="0" tIns="0" rIns="0" bIns="0" rtlCol="0" anchor="ctr"/>
           <a:lstStyle/>
           <a:p>
-            <a:pPr indent="0" marL="0">
+            <a:pPr marL="0" indent="0">
               <a:lnSpc>
                 <a:spcPct val="110000"/>
               </a:lnSpc>
@@ -10604,12 +10835,6 @@
               </a:rPr>
               <a:t>Give the right context at the right step. </a:t>
             </a:r>
-            <a:pPr indent="0" marL="0">
-              <a:lnSpc>
-                <a:spcPct val="110000"/>
-              </a:lnSpc>
-              <a:buNone/>
-            </a:pPr>
             <a:r>
               <a:rPr lang="en-US" sz="1700" dirty="0">
                 <a:solidFill>
@@ -10646,7 +10871,7 @@
           <a:bodyPr wrap="square" lIns="0" tIns="0" rIns="0" bIns="0" rtlCol="0" anchor="ctr"/>
           <a:lstStyle/>
           <a:p>
-            <a:pPr indent="0" marL="0">
+            <a:pPr marL="0" indent="0">
               <a:buNone/>
             </a:pPr>
             <a:r>
@@ -10685,7 +10910,7 @@
           <a:bodyPr wrap="square" lIns="0" tIns="0" rIns="0" bIns="0" rtlCol="0" anchor="ctr"/>
           <a:lstStyle/>
           <a:p>
-            <a:pPr algn="r" indent="0" marL="0">
+            <a:pPr marL="0" indent="0" algn="r">
               <a:buNone/>
             </a:pPr>
             <a:r>
@@ -10719,6 +10944,7 @@
         <a:solidFill>
           <a:srgbClr val="FFFFFF"/>
         </a:solidFill>
+        <a:effectLst/>
       </p:bgPr>
     </p:bg>
     <p:spTree>
@@ -10756,11 +10982,11 @@
           <a:bodyPr wrap="square" lIns="0" tIns="0" rIns="0" bIns="0" rtlCol="0" anchor="ctr"/>
           <a:lstStyle/>
           <a:p>
-            <a:pPr indent="0" marL="0">
-              <a:buNone/>
-            </a:pPr>
-            <a:r>
-              <a:rPr lang="en-US" sz="1200" b="1" spc="200" kern="0" dirty="0">
+            <a:pPr marL="0" indent="0">
+              <a:buNone/>
+            </a:pPr>
+            <a:r>
+              <a:rPr lang="en-US" sz="1200" b="1" kern="0" spc="200" dirty="0">
                 <a:solidFill>
                   <a:srgbClr val="5B3DF5"/>
                 </a:solidFill>
@@ -10795,7 +11021,7 @@
           <a:bodyPr wrap="square" lIns="0" tIns="0" rIns="0" bIns="0" rtlCol="0" anchor="t"/>
           <a:lstStyle/>
           <a:p>
-            <a:pPr indent="0" marL="0">
+            <a:pPr marL="0" indent="0">
               <a:buNone/>
             </a:pPr>
             <a:r>
@@ -10839,13 +11065,20 @@
             <a:prstDash val="solid"/>
           </a:ln>
           <a:effectLst>
-            <a:outerShdw sx="100000" sy="100000" kx="0" ky="0" algn="bl" rotWithShape="0" blurRad="114300" dist="38100" dir="8100000">
+            <a:outerShdw blurRad="114300" dist="38100" dir="8100000" algn="bl" rotWithShape="0">
               <a:srgbClr val="17151F">
                 <a:alpha val="12000"/>
               </a:srgbClr>
             </a:outerShdw>
           </a:effectLst>
         </p:spPr>
+        <p:txBody>
+          <a:bodyPr/>
+          <a:lstStyle/>
+          <a:p>
+            <a:endParaRPr lang="en-US"/>
+          </a:p>
+        </p:txBody>
       </p:sp>
       <p:sp>
         <p:nvSpPr>
@@ -10866,6 +11099,13 @@
           </a:solidFill>
           <a:ln/>
         </p:spPr>
+        <p:txBody>
+          <a:bodyPr/>
+          <a:lstStyle/>
+          <a:p>
+            <a:endParaRPr lang="en-US"/>
+          </a:p>
+        </p:txBody>
       </p:sp>
       <p:sp>
         <p:nvSpPr>
@@ -10888,7 +11128,7 @@
           <a:bodyPr wrap="square" lIns="0" tIns="0" rIns="0" bIns="0" rtlCol="0" anchor="ctr"/>
           <a:lstStyle/>
           <a:p>
-            <a:pPr indent="0" marL="0">
+            <a:pPr marL="0" indent="0">
               <a:buNone/>
             </a:pPr>
             <a:r>
@@ -10927,7 +11167,7 @@
           <a:bodyPr wrap="square" lIns="0" tIns="0" rIns="0" bIns="0" rtlCol="0" anchor="t"/>
           <a:lstStyle/>
           <a:p>
-            <a:pPr indent="0" marL="0">
+            <a:pPr marL="0" indent="0">
               <a:lnSpc>
                 <a:spcPct val="115000"/>
               </a:lnSpc>
@@ -10974,13 +11214,20 @@
             <a:prstDash val="solid"/>
           </a:ln>
           <a:effectLst>
-            <a:outerShdw sx="100000" sy="100000" kx="0" ky="0" algn="bl" rotWithShape="0" blurRad="114300" dist="38100" dir="8100000">
+            <a:outerShdw blurRad="114300" dist="38100" dir="8100000" algn="bl" rotWithShape="0">
               <a:srgbClr val="17151F">
                 <a:alpha val="12000"/>
               </a:srgbClr>
             </a:outerShdw>
           </a:effectLst>
         </p:spPr>
+        <p:txBody>
+          <a:bodyPr/>
+          <a:lstStyle/>
+          <a:p>
+            <a:endParaRPr lang="en-US"/>
+          </a:p>
+        </p:txBody>
       </p:sp>
       <p:sp>
         <p:nvSpPr>
@@ -11001,6 +11248,13 @@
           </a:solidFill>
           <a:ln/>
         </p:spPr>
+        <p:txBody>
+          <a:bodyPr/>
+          <a:lstStyle/>
+          <a:p>
+            <a:endParaRPr lang="en-US"/>
+          </a:p>
+        </p:txBody>
       </p:sp>
       <p:sp>
         <p:nvSpPr>
@@ -11023,7 +11277,7 @@
           <a:bodyPr wrap="square" lIns="0" tIns="0" rIns="0" bIns="0" rtlCol="0" anchor="ctr"/>
           <a:lstStyle/>
           <a:p>
-            <a:pPr indent="0" marL="0">
+            <a:pPr marL="0" indent="0">
               <a:buNone/>
             </a:pPr>
             <a:r>
@@ -11062,7 +11316,7 @@
           <a:bodyPr wrap="square" lIns="0" tIns="0" rIns="0" bIns="0" rtlCol="0" anchor="t"/>
           <a:lstStyle/>
           <a:p>
-            <a:pPr indent="0" marL="0">
+            <a:pPr marL="0" indent="0">
               <a:lnSpc>
                 <a:spcPct val="115000"/>
               </a:lnSpc>
@@ -11109,13 +11363,20 @@
             <a:prstDash val="solid"/>
           </a:ln>
           <a:effectLst>
-            <a:outerShdw sx="100000" sy="100000" kx="0" ky="0" algn="bl" rotWithShape="0" blurRad="114300" dist="38100" dir="8100000">
+            <a:outerShdw blurRad="114300" dist="38100" dir="8100000" algn="bl" rotWithShape="0">
               <a:srgbClr val="17151F">
                 <a:alpha val="12000"/>
               </a:srgbClr>
             </a:outerShdw>
           </a:effectLst>
         </p:spPr>
+        <p:txBody>
+          <a:bodyPr/>
+          <a:lstStyle/>
+          <a:p>
+            <a:endParaRPr lang="en-US"/>
+          </a:p>
+        </p:txBody>
       </p:sp>
       <p:sp>
         <p:nvSpPr>
@@ -11136,6 +11397,13 @@
           </a:solidFill>
           <a:ln/>
         </p:spPr>
+        <p:txBody>
+          <a:bodyPr/>
+          <a:lstStyle/>
+          <a:p>
+            <a:endParaRPr lang="en-US"/>
+          </a:p>
+        </p:txBody>
       </p:sp>
       <p:sp>
         <p:nvSpPr>
@@ -11158,7 +11426,7 @@
           <a:bodyPr wrap="square" lIns="0" tIns="0" rIns="0" bIns="0" rtlCol="0" anchor="ctr"/>
           <a:lstStyle/>
           <a:p>
-            <a:pPr indent="0" marL="0">
+            <a:pPr marL="0" indent="0">
               <a:buNone/>
             </a:pPr>
             <a:r>
@@ -11197,7 +11465,7 @@
           <a:bodyPr wrap="square" lIns="0" tIns="0" rIns="0" bIns="0" rtlCol="0" anchor="t"/>
           <a:lstStyle/>
           <a:p>
-            <a:pPr indent="0" marL="0">
+            <a:pPr marL="0" indent="0">
               <a:lnSpc>
                 <a:spcPct val="115000"/>
               </a:lnSpc>
@@ -11239,7 +11507,7 @@
           <a:bodyPr wrap="square" lIns="0" tIns="0" rIns="0" bIns="0" rtlCol="0" anchor="ctr"/>
           <a:lstStyle/>
           <a:p>
-            <a:pPr algn="ctr" indent="0" marL="0">
+            <a:pPr marL="0" indent="0" algn="ctr">
               <a:buNone/>
             </a:pPr>
             <a:r>
@@ -11278,7 +11546,7 @@
           <a:bodyPr wrap="square" lIns="0" tIns="0" rIns="0" bIns="0" rtlCol="0" anchor="ctr"/>
           <a:lstStyle/>
           <a:p>
-            <a:pPr indent="0" marL="0">
+            <a:pPr marL="0" indent="0">
               <a:buNone/>
             </a:pPr>
             <a:r>
@@ -11317,7 +11585,7 @@
           <a:bodyPr wrap="square" lIns="0" tIns="0" rIns="0" bIns="0" rtlCol="0" anchor="ctr"/>
           <a:lstStyle/>
           <a:p>
-            <a:pPr algn="r" indent="0" marL="0">
+            <a:pPr marL="0" indent="0" algn="r">
               <a:buNone/>
             </a:pPr>
             <a:r>
@@ -11636,4 +11904,319 @@
     </a:ext>
   </a:extLst>
 </a:theme>
+</file>
+
+<file path=ppt/theme/theme2.xml><?xml version="1.0" encoding="utf-8"?>
+<a:theme xmlns:a="http://schemas.openxmlformats.org/drawingml/2006/main" name="Office Theme">
+  <a:themeElements>
+    <a:clrScheme name="Office">
+      <a:dk1>
+        <a:sysClr val="windowText" lastClr="000000"/>
+      </a:dk1>
+      <a:lt1>
+        <a:sysClr val="window" lastClr="FFFFFF"/>
+      </a:lt1>
+      <a:dk2>
+        <a:srgbClr val="0E2841"/>
+      </a:dk2>
+      <a:lt2>
+        <a:srgbClr val="E8E8E8"/>
+      </a:lt2>
+      <a:accent1>
+        <a:srgbClr val="156082"/>
+      </a:accent1>
+      <a:accent2>
+        <a:srgbClr val="E97132"/>
+      </a:accent2>
+      <a:accent3>
+        <a:srgbClr val="196B24"/>
+      </a:accent3>
+      <a:accent4>
+        <a:srgbClr val="0F9ED5"/>
+      </a:accent4>
+      <a:accent5>
+        <a:srgbClr val="A02B93"/>
+      </a:accent5>
+      <a:accent6>
+        <a:srgbClr val="4EA72E"/>
+      </a:accent6>
+      <a:hlink>
+        <a:srgbClr val="467886"/>
+      </a:hlink>
+      <a:folHlink>
+        <a:srgbClr val="96607D"/>
+      </a:folHlink>
+    </a:clrScheme>
+    <a:fontScheme name="Office">
+      <a:majorFont>
+        <a:latin typeface="Aptos Display" panose="02110004020202020204"/>
+        <a:ea typeface=""/>
+        <a:cs typeface=""/>
+        <a:font script="Jpan" typeface="游ゴシック Light"/>
+        <a:font script="Hang" typeface="맑은 고딕"/>
+        <a:font script="Hans" typeface="等线 Light"/>
+        <a:font script="Hant" typeface="新細明體"/>
+        <a:font script="Arab" typeface="Times New Roman"/>
+        <a:font script="Hebr" typeface="Times New Roman"/>
+        <a:font script="Thai" typeface="Angsana New"/>
+        <a:font script="Ethi" typeface="Nyala"/>
+        <a:font script="Beng" typeface="Vrinda"/>
+        <a:font script="Gujr" typeface="Shruti"/>
+        <a:font script="Khmr" typeface="MoolBoran"/>
+        <a:font script="Knda" typeface="Tunga"/>
+        <a:font script="Guru" typeface="Raavi"/>
+        <a:font script="Cans" typeface="Euphemia"/>
+        <a:font script="Cher" typeface="Plantagenet Cherokee"/>
+        <a:font script="Yiii" typeface="Microsoft Yi Baiti"/>
+        <a:font script="Tibt" typeface="Microsoft Himalaya"/>
+        <a:font script="Thaa" typeface="MV Boli"/>
+        <a:font script="Deva" typeface="Mangal"/>
+        <a:font script="Telu" typeface="Gautami"/>
+        <a:font script="Taml" typeface="Latha"/>
+        <a:font script="Syrc" typeface="Estrangelo Edessa"/>
+        <a:font script="Orya" typeface="Kalinga"/>
+        <a:font script="Mlym" typeface="Kartika"/>
+        <a:font script="Laoo" typeface="DokChampa"/>
+        <a:font script="Sinh" typeface="Iskoola Pota"/>
+        <a:font script="Mong" typeface="Mongolian Baiti"/>
+        <a:font script="Viet" typeface="Times New Roman"/>
+        <a:font script="Uigh" typeface="Microsoft Uighur"/>
+        <a:font script="Geor" typeface="Sylfaen"/>
+        <a:font script="Armn" typeface="Arial"/>
+        <a:font script="Bugi" typeface="Leelawadee UI"/>
+        <a:font script="Bopo" typeface="Microsoft JhengHei"/>
+        <a:font script="Java" typeface="Javanese Text"/>
+        <a:font script="Lisu" typeface="Segoe UI"/>
+        <a:font script="Mymr" typeface="Myanmar Text"/>
+        <a:font script="Nkoo" typeface="Ebrima"/>
+        <a:font script="Olck" typeface="Nirmala UI"/>
+        <a:font script="Osma" typeface="Ebrima"/>
+        <a:font script="Phag" typeface="Phagspa"/>
+        <a:font script="Syrn" typeface="Estrangelo Edessa"/>
+        <a:font script="Syrj" typeface="Estrangelo Edessa"/>
+        <a:font script="Syre" typeface="Estrangelo Edessa"/>
+        <a:font script="Sora" typeface="Nirmala UI"/>
+        <a:font script="Tale" typeface="Microsoft Tai Le"/>
+        <a:font script="Talu" typeface="Microsoft New Tai Lue"/>
+        <a:font script="Tfng" typeface="Ebrima"/>
+      </a:majorFont>
+      <a:minorFont>
+        <a:latin typeface="Aptos" panose="02110004020202020204"/>
+        <a:ea typeface=""/>
+        <a:cs typeface=""/>
+        <a:font script="Jpan" typeface="游ゴシック"/>
+        <a:font script="Hang" typeface="맑은 고딕"/>
+        <a:font script="Hans" typeface="等线"/>
+        <a:font script="Hant" typeface="新細明體"/>
+        <a:font script="Arab" typeface="Arial"/>
+        <a:font script="Hebr" typeface="Arial"/>
+        <a:font script="Thai" typeface="Cordia New"/>
+        <a:font script="Ethi" typeface="Nyala"/>
+        <a:font script="Beng" typeface="Vrinda"/>
+        <a:font script="Gujr" typeface="Shruti"/>
+        <a:font script="Khmr" typeface="DaunPenh"/>
+        <a:font script="Knda" typeface="Tunga"/>
+        <a:font script="Guru" typeface="Raavi"/>
+        <a:font script="Cans" typeface="Euphemia"/>
+        <a:font script="Cher" typeface="Plantagenet Cherokee"/>
+        <a:font script="Yiii" typeface="Microsoft Yi Baiti"/>
+        <a:font script="Tibt" typeface="Microsoft Himalaya"/>
+        <a:font script="Thaa" typeface="MV Boli"/>
+        <a:font script="Deva" typeface="Mangal"/>
+        <a:font script="Telu" typeface="Gautami"/>
+        <a:font script="Taml" typeface="Latha"/>
+        <a:font script="Syrc" typeface="Estrangelo Edessa"/>
+        <a:font script="Orya" typeface="Kalinga"/>
+        <a:font script="Mlym" typeface="Kartika"/>
+        <a:font script="Laoo" typeface="DokChampa"/>
+        <a:font script="Sinh" typeface="Iskoola Pota"/>
+        <a:font script="Mong" typeface="Mongolian Baiti"/>
+        <a:font script="Viet" typeface="Arial"/>
+        <a:font script="Uigh" typeface="Microsoft Uighur"/>
+        <a:font script="Geor" typeface="Sylfaen"/>
+        <a:font script="Armn" typeface="Arial"/>
+        <a:font script="Bugi" typeface="Leelawadee UI"/>
+        <a:font script="Bopo" typeface="Microsoft JhengHei"/>
+        <a:font script="Java" typeface="Javanese Text"/>
+        <a:font script="Lisu" typeface="Segoe UI"/>
+        <a:font script="Mymr" typeface="Myanmar Text"/>
+        <a:font script="Nkoo" typeface="Ebrima"/>
+        <a:font script="Olck" typeface="Nirmala UI"/>
+        <a:font script="Osma" typeface="Ebrima"/>
+        <a:font script="Phag" typeface="Phagspa"/>
+        <a:font script="Syrn" typeface="Estrangelo Edessa"/>
+        <a:font script="Syrj" typeface="Estrangelo Edessa"/>
+        <a:font script="Syre" typeface="Estrangelo Edessa"/>
+        <a:font script="Sora" typeface="Nirmala UI"/>
+        <a:font script="Tale" typeface="Microsoft Tai Le"/>
+        <a:font script="Talu" typeface="Microsoft New Tai Lue"/>
+        <a:font script="Tfng" typeface="Ebrima"/>
+      </a:minorFont>
+    </a:fontScheme>
+    <a:fmtScheme name="Office">
+      <a:fillStyleLst>
+        <a:solidFill>
+          <a:schemeClr val="phClr"/>
+        </a:solidFill>
+        <a:gradFill rotWithShape="1">
+          <a:gsLst>
+            <a:gs pos="0">
+              <a:schemeClr val="phClr">
+                <a:lumMod val="110000"/>
+                <a:satMod val="105000"/>
+                <a:tint val="67000"/>
+              </a:schemeClr>
+            </a:gs>
+            <a:gs pos="50000">
+              <a:schemeClr val="phClr">
+                <a:lumMod val="105000"/>
+                <a:satMod val="103000"/>
+                <a:tint val="73000"/>
+              </a:schemeClr>
+            </a:gs>
+            <a:gs pos="100000">
+              <a:schemeClr val="phClr">
+                <a:lumMod val="105000"/>
+                <a:satMod val="109000"/>
+                <a:tint val="81000"/>
+              </a:schemeClr>
+            </a:gs>
+          </a:gsLst>
+          <a:lin ang="5400000" scaled="0"/>
+        </a:gradFill>
+        <a:gradFill rotWithShape="1">
+          <a:gsLst>
+            <a:gs pos="0">
+              <a:schemeClr val="phClr">
+                <a:satMod val="103000"/>
+                <a:lumMod val="102000"/>
+                <a:tint val="94000"/>
+              </a:schemeClr>
+            </a:gs>
+            <a:gs pos="50000">
+              <a:schemeClr val="phClr">
+                <a:satMod val="110000"/>
+                <a:lumMod val="100000"/>
+                <a:shade val="100000"/>
+              </a:schemeClr>
+            </a:gs>
+            <a:gs pos="100000">
+              <a:schemeClr val="phClr">
+                <a:lumMod val="99000"/>
+                <a:satMod val="120000"/>
+                <a:shade val="78000"/>
+              </a:schemeClr>
+            </a:gs>
+          </a:gsLst>
+          <a:lin ang="5400000" scaled="0"/>
+        </a:gradFill>
+      </a:fillStyleLst>
+      <a:lnStyleLst>
+        <a:ln w="12700" cap="flat" cmpd="sng" algn="ctr">
+          <a:solidFill>
+            <a:schemeClr val="phClr"/>
+          </a:solidFill>
+          <a:prstDash val="solid"/>
+          <a:miter lim="800000"/>
+        </a:ln>
+        <a:ln w="19050" cap="flat" cmpd="sng" algn="ctr">
+          <a:solidFill>
+            <a:schemeClr val="phClr"/>
+          </a:solidFill>
+          <a:prstDash val="solid"/>
+          <a:miter lim="800000"/>
+        </a:ln>
+        <a:ln w="25400" cap="flat" cmpd="sng" algn="ctr">
+          <a:solidFill>
+            <a:schemeClr val="phClr"/>
+          </a:solidFill>
+          <a:prstDash val="solid"/>
+          <a:miter lim="800000"/>
+        </a:ln>
+      </a:lnStyleLst>
+      <a:effectStyleLst>
+        <a:effectStyle>
+          <a:effectLst/>
+        </a:effectStyle>
+        <a:effectStyle>
+          <a:effectLst/>
+        </a:effectStyle>
+        <a:effectStyle>
+          <a:effectLst>
+            <a:outerShdw blurRad="57150" dist="19050" dir="5400000" algn="ctr" rotWithShape="0">
+              <a:srgbClr val="000000">
+                <a:alpha val="63000"/>
+              </a:srgbClr>
+            </a:outerShdw>
+          </a:effectLst>
+        </a:effectStyle>
+      </a:effectStyleLst>
+      <a:bgFillStyleLst>
+        <a:solidFill>
+          <a:schemeClr val="phClr"/>
+        </a:solidFill>
+        <a:solidFill>
+          <a:schemeClr val="phClr">
+            <a:tint val="95000"/>
+            <a:satMod val="170000"/>
+          </a:schemeClr>
+        </a:solidFill>
+        <a:gradFill rotWithShape="1">
+          <a:gsLst>
+            <a:gs pos="0">
+              <a:schemeClr val="phClr">
+                <a:tint val="93000"/>
+                <a:satMod val="150000"/>
+                <a:shade val="98000"/>
+                <a:lumMod val="102000"/>
+              </a:schemeClr>
+            </a:gs>
+            <a:gs pos="50000">
+              <a:schemeClr val="phClr">
+                <a:tint val="98000"/>
+                <a:satMod val="130000"/>
+                <a:shade val="90000"/>
+                <a:lumMod val="103000"/>
+              </a:schemeClr>
+            </a:gs>
+            <a:gs pos="100000">
+              <a:schemeClr val="phClr">
+                <a:shade val="63000"/>
+                <a:satMod val="120000"/>
+              </a:schemeClr>
+            </a:gs>
+          </a:gsLst>
+          <a:lin ang="5400000" scaled="0"/>
+        </a:gradFill>
+      </a:bgFillStyleLst>
+    </a:fmtScheme>
+  </a:themeElements>
+  <a:objectDefaults>
+    <a:lnDef>
+      <a:spPr/>
+      <a:bodyPr/>
+      <a:lstStyle/>
+      <a:style>
+        <a:lnRef idx="2">
+          <a:schemeClr val="accent1"/>
+        </a:lnRef>
+        <a:fillRef idx="0">
+          <a:schemeClr val="accent1"/>
+        </a:fillRef>
+        <a:effectRef idx="1">
+          <a:schemeClr val="accent1"/>
+        </a:effectRef>
+        <a:fontRef idx="minor">
+          <a:schemeClr val="tx1"/>
+        </a:fontRef>
+      </a:style>
+    </a:lnDef>
+  </a:objectDefaults>
+  <a:extraClrSchemeLst/>
+  <a:extLst>
+    <a:ext uri="{05A4C25C-085E-4340-85A3-A5531E510DB2}">
+      <thm15:themeFamily xmlns:thm15="http://schemas.microsoft.com/office/thememl/2012/main" name="Office Theme" id="{2E142A2C-CD16-42D6-873A-C26D2A0506FA}" vid="{1BDDFF52-6CD6-40A5-AB3C-68EB2F1E4D0A}"/>
+    </a:ext>
+  </a:extLst>
+</a:theme>
 </file>
</xml_diff>